<commit_message>
no-mistakes(review): replace borrowed slide images, fix deck geometry and typos
</commit_message>
<xml_diff>
--- a/slides/pptx/lecture01_intro.pptx
+++ b/slides/pptx/lecture01_intro.pptx
@@ -5988,7 +5988,7 @@
         <p:spPr>
           <a:xfrm>
             <a:off x="672207" y="1558804"/>
-            <a:ext cx="10515600" cy="1292517"/>
+            <a:ext cx="10515600" cy="1572768"/>
           </a:xfrm>
           <a:prstGeom prst="rect">
             <a:avLst/>
@@ -6147,7 +6147,11 @@
             <p:ph type="title"/>
           </p:nvPr>
         </p:nvSpPr>
-        <p:spPr/>
+        <p:spPr>
+          <a:xfrm>
+            <a:ext cx="0" cy="658368"/>
+          </a:xfrm>
+        </p:spPr>
         <p:txBody>
           <a:bodyPr/>
           <a:lstStyle/>
@@ -6178,7 +6182,7 @@
         <p:spPr>
           <a:xfrm>
             <a:off x="548640" y="1920240"/>
-            <a:ext cx="8706571" cy="4434840"/>
+            <a:ext cx="8706571" cy="3165307"/>
           </a:xfrm>
         </p:spPr>
         <p:txBody>
@@ -6348,7 +6352,7 @@
         <p:spPr>
           <a:xfrm>
             <a:off x="672208" y="5140411"/>
-            <a:ext cx="6544137" cy="830997"/>
+            <a:ext cx="6544137" cy="1207008"/>
           </a:xfrm>
           <a:prstGeom prst="rect">
             <a:avLst/>
@@ -6932,7 +6936,7 @@
         </p:blipFill>
         <p:spPr>
           <a:xfrm>
-            <a:off x="398268" y="1661505"/>
+            <a:off x="193031" y="1914144"/>
             <a:ext cx="2566703" cy="1309950"/>
           </a:xfrm>
           <a:prstGeom prst="rect">
@@ -7911,7 +7915,7 @@
         <p:spPr>
           <a:xfrm>
             <a:off x="548640" y="1920240"/>
-            <a:ext cx="10789920" cy="3185487"/>
+            <a:ext cx="10789920" cy="3401568"/>
           </a:xfrm>
           <a:prstGeom prst="rect">
             <a:avLst/>
@@ -8911,7 +8915,7 @@
         <p:spPr>
           <a:xfrm>
             <a:off x="548640" y="731520"/>
-            <a:ext cx="11064240" cy="615553"/>
+            <a:ext cx="11064240" cy="1146048"/>
           </a:xfrm>
           <a:prstGeom prst="rect">
             <a:avLst/>
@@ -8959,8 +8963,8 @@
         </p:nvSpPr>
         <p:spPr>
           <a:xfrm>
-            <a:off x="548640" y="1920240"/>
-            <a:ext cx="10789920" cy="3139321"/>
+            <a:off x="548640" y="1932432"/>
+            <a:ext cx="10789920" cy="3407664"/>
           </a:xfrm>
           <a:prstGeom prst="rect">
             <a:avLst/>
@@ -8981,7 +8985,7 @@
               <a:buAutoNum type="arabicPeriod"/>
             </a:pPr>
             <a:r>
-              <a:rPr lang="en-US" sz="2300" b="0" i="0" dirty="0">
+              <a:rPr lang="en-US" sz="2100" b="0" i="0" dirty="0">
                 <a:solidFill>
                   <a:srgbClr val="1B2025"/>
                 </a:solidFill>
@@ -8990,7 +8994,7 @@
               <a:t>(Sun AM) </a:t>
             </a:r>
             <a:r>
-              <a:rPr sz="2300" b="0" i="0" dirty="0">
+              <a:rPr sz="2100" b="0" i="0" dirty="0">
                 <a:solidFill>
                   <a:srgbClr val="1B2025"/>
                 </a:solidFill>
@@ -9014,7 +9018,7 @@
               <a:buAutoNum type="arabicPeriod"/>
             </a:pPr>
             <a:r>
-              <a:rPr lang="en-US" sz="2300" b="0" i="0" dirty="0">
+              <a:rPr lang="en-US" sz="2100" b="0" i="0" dirty="0">
                 <a:solidFill>
                   <a:srgbClr val="1B2025"/>
                 </a:solidFill>
@@ -9023,7 +9027,7 @@
               <a:t>(Sun PM) </a:t>
             </a:r>
             <a:r>
-              <a:rPr sz="2300" b="0" i="0" dirty="0">
+              <a:rPr sz="2100" b="0" i="0" dirty="0">
                 <a:solidFill>
                   <a:srgbClr val="1B2025"/>
                 </a:solidFill>
@@ -9041,7 +9045,7 @@
               <a:buAutoNum type="arabicPeriod"/>
             </a:pPr>
             <a:r>
-              <a:rPr lang="en-US" sz="2300" b="0" i="0" dirty="0">
+              <a:rPr lang="en-US" sz="2100" b="0" i="0" dirty="0">
                 <a:solidFill>
                   <a:srgbClr val="1B2025"/>
                 </a:solidFill>
@@ -9050,7 +9054,7 @@
               <a:t>(Mon AM) </a:t>
             </a:r>
             <a:r>
-              <a:rPr sz="2300" b="0" i="0" dirty="0">
+              <a:rPr sz="2100" b="0" i="0" dirty="0">
                 <a:solidFill>
                   <a:srgbClr val="1B2025"/>
                 </a:solidFill>
@@ -9068,7 +9072,7 @@
               <a:buAutoNum type="arabicPeriod"/>
             </a:pPr>
             <a:r>
-              <a:rPr lang="en-US" sz="2300" b="0" i="0" dirty="0">
+              <a:rPr lang="en-US" sz="2100" b="0" i="0" dirty="0">
                 <a:solidFill>
                   <a:srgbClr val="1B2025"/>
                 </a:solidFill>
@@ -9077,7 +9081,7 @@
               <a:t>(Mon PM) </a:t>
             </a:r>
             <a:r>
-              <a:rPr sz="2300" b="0" i="0" dirty="0">
+              <a:rPr sz="2100" b="0" i="0" dirty="0">
                 <a:solidFill>
                   <a:srgbClr val="1B2025"/>
                 </a:solidFill>
@@ -9095,7 +9099,7 @@
               <a:buAutoNum type="arabicPeriod"/>
             </a:pPr>
             <a:r>
-              <a:rPr lang="en-US" sz="2300" b="0" i="0" dirty="0">
+              <a:rPr lang="en-US" sz="2100" b="0" i="0" dirty="0">
                 <a:solidFill>
                   <a:srgbClr val="1B2025"/>
                 </a:solidFill>
@@ -9104,7 +9108,7 @@
               <a:t>(Tue AM) </a:t>
             </a:r>
             <a:r>
-              <a:rPr sz="2300" b="0" i="0" dirty="0">
+              <a:rPr sz="2100" b="0" i="0" dirty="0">
                 <a:solidFill>
                   <a:srgbClr val="1B2025"/>
                 </a:solidFill>
@@ -9454,7 +9458,7 @@
         </p:nvSpPr>
         <p:spPr>
           <a:xfrm>
-            <a:off x="548640" y="5815583"/>
+            <a:off x="548640" y="5504688"/>
             <a:ext cx="11064240" cy="411480"/>
           </a:xfrm>
           <a:prstGeom prst="rect">
@@ -9495,8 +9499,8 @@
         </p:nvSpPr>
         <p:spPr>
           <a:xfrm>
-            <a:off x="2693773" y="6175165"/>
-            <a:ext cx="6993924" cy="461665"/>
+            <a:off x="2693773" y="5971032"/>
+            <a:ext cx="6993924" cy="841248"/>
           </a:xfrm>
           <a:prstGeom prst="rect">
             <a:avLst/>
@@ -10028,7 +10032,7 @@
         <p:spPr>
           <a:xfrm>
             <a:off x="5684107" y="2570205"/>
-            <a:ext cx="6376087" cy="2954655"/>
+            <a:ext cx="6376087" cy="3096768"/>
           </a:xfrm>
           <a:prstGeom prst="rect">
             <a:avLst/>
@@ -10420,7 +10424,7 @@
         <p:spPr>
           <a:xfrm>
             <a:off x="6309360" y="2011680"/>
-            <a:ext cx="5394960" cy="2000548"/>
+            <a:ext cx="5394960" cy="2441448"/>
           </a:xfrm>
           <a:prstGeom prst="rect">
             <a:avLst/>
@@ -10707,7 +10711,7 @@
         <p:spPr>
           <a:xfrm>
             <a:off x="548640" y="1920240"/>
-            <a:ext cx="10789920" cy="2785378"/>
+            <a:ext cx="10789920" cy="3401568"/>
           </a:xfrm>
           <a:prstGeom prst="rect">
             <a:avLst/>
@@ -10953,7 +10957,7 @@
         </p:nvSpPr>
         <p:spPr>
           <a:xfrm>
-            <a:off x="1515657" y="4821256"/>
+            <a:off x="1515657" y="5376672"/>
             <a:ext cx="8855886" cy="1015663"/>
           </a:xfrm>
           <a:prstGeom prst="rect">

</xml_diff>

<commit_message>
no-mistakes(review): repair geometry-pass regressions, restore FORCE_COLOR
</commit_message>
<xml_diff>
--- a/slides/pptx/lecture01_intro.pptx
+++ b/slides/pptx/lecture01_intro.pptx
@@ -6147,11 +6147,7 @@
             <p:ph type="title"/>
           </p:nvPr>
         </p:nvSpPr>
-        <p:spPr>
-          <a:xfrm>
-            <a:ext cx="0" cy="658368"/>
-          </a:xfrm>
-        </p:spPr>
+        <p:spPr/>
         <p:txBody>
           <a:bodyPr/>
           <a:lstStyle/>
@@ -6269,8 +6265,8 @@
         </p:blipFill>
         <p:spPr>
           <a:xfrm>
-            <a:off x="8404315" y="1142896"/>
-            <a:ext cx="2527300" cy="1320800"/>
+            <a:off x="8404315" y="1783080"/>
+            <a:ext cx="2278380" cy="1188720"/>
           </a:xfrm>
           <a:prstGeom prst="rect">
             <a:avLst/>
@@ -10711,7 +10707,7 @@
         <p:spPr>
           <a:xfrm>
             <a:off x="548640" y="1920240"/>
-            <a:ext cx="10789920" cy="3401568"/>
+            <a:ext cx="10789920" cy="2785378"/>
           </a:xfrm>
           <a:prstGeom prst="rect">
             <a:avLst/>
@@ -10957,7 +10953,7 @@
         </p:nvSpPr>
         <p:spPr>
           <a:xfrm>
-            <a:off x="1515657" y="5376672"/>
+            <a:off x="1515657" y="4821256"/>
             <a:ext cx="8855886" cy="1015663"/>
           </a:xfrm>
           <a:prstGeom prst="rect">

</xml_diff>

<commit_message>
slides: instructor edits to lectures 1 and 2
Lixing's own hand edits in PowerPoint, committed as they were before the
header and quiz-stop pass.

Lecture 1: drops the three-activations I-do slide and the contract's goal
line, adds a picture to the deep-learning slide, retitles the
universal-approximation slide ("Core Belief: ...") and splits several
callouts onto two lines.

Lecture 2: adds the "Deep learning training" slide (target vs. parameters),
rewords the learning-loop title, adds a "Pros and Cons of Gradient Descent?"
discussion prompt, and retitles the loss-curve panel "Ideal Loss Fall".

Text dumps regenerated to match.
</commit_message>
<xml_diff>
--- a/slides/pptx/lecture01_intro.pptx
+++ b/slides/pptx/lecture01_intro.pptx
@@ -5,7 +5,7 @@
     <p:sldMasterId id="2147483658" r:id="rId1"/>
   </p:sldMasterIdLst>
   <p:notesMasterIdLst>
-    <p:notesMasterId r:id="rId26"/>
+    <p:notesMasterId r:id="rId24"/>
   </p:notesMasterIdLst>
   <p:sldIdLst>
     <p:sldId id="256" r:id="rId2"/>
@@ -20,18 +20,16 @@
     <p:sldId id="280" r:id="rId11"/>
     <p:sldId id="281" r:id="rId12"/>
     <p:sldId id="265" r:id="rId13"/>
-    <p:sldId id="266" r:id="rId14"/>
-    <p:sldId id="267" r:id="rId15"/>
-    <p:sldId id="268" r:id="rId16"/>
-    <p:sldId id="269" r:id="rId17"/>
-    <p:sldId id="270" r:id="rId18"/>
-    <p:sldId id="271" r:id="rId19"/>
-    <p:sldId id="272" r:id="rId20"/>
-    <p:sldId id="273" r:id="rId21"/>
-    <p:sldId id="274" r:id="rId22"/>
-    <p:sldId id="275" r:id="rId23"/>
-    <p:sldId id="276" r:id="rId24"/>
-    <p:sldId id="278" r:id="rId25"/>
+    <p:sldId id="267" r:id="rId14"/>
+    <p:sldId id="268" r:id="rId15"/>
+    <p:sldId id="269" r:id="rId16"/>
+    <p:sldId id="270" r:id="rId17"/>
+    <p:sldId id="271" r:id="rId18"/>
+    <p:sldId id="272" r:id="rId19"/>
+    <p:sldId id="273" r:id="rId20"/>
+    <p:sldId id="274" r:id="rId21"/>
+    <p:sldId id="275" r:id="rId22"/>
+    <p:sldId id="278" r:id="rId23"/>
   </p:sldIdLst>
   <p:sldSz cx="12192000" cy="6858000"/>
   <p:notesSz cx="6858000" cy="9144000"/>
@@ -392,7 +390,7 @@
           <a:lstStyle/>
           <a:p>
             <a:r>
-              <a:t>I-DO. Two workhorses plus the do-nothing baseline. ReLU — "rectified linear unit," but just say: negatives to zero, positives unchanged; trivial to compute, trains well. Sigmoid — the S-curve into 0-1, so we read the output as a probability; typically at the end of a yes/no classifier. Linear = no activation, a straight line, the thing we DON'T want in hidden layers. Conceptual payload: activations are the only non-straight step — remove them and the whole network, however deep, flattens to a single straight line. Next slide you name these shapes yourself — that is Quiz 1 Q1.</a:t>
+              <a:t>YOU-DO = Quiz 1 Q1 — an apply/decide item, NOT naming. Three tasks: (i) which activation belongs on the final neuron of a resistant-vs-susceptible classifier? Answer: (a) the SIGMOID — it is the only curve whose output is squeezed into (0, 1), so it reads as a probability; ReLU is unbounded above and Linear is unbounded both ways, so neither can be a probability. (ii) ReLU(−3) = max(0, −3) = 0 — the neuron is silent (the on/off idea again). (iii) sigmoid(0) = 1/(1+e^0) = 0.5 — maximally uncertain, a coin flip. The point: shape → range → job. Poll the room on (i) before revealing, then have them fill Q1 on the sheet.</a:t>
             </a:r>
           </a:p>
           <a:p>
@@ -465,7 +463,7 @@
           <a:lstStyle/>
           <a:p>
             <a:r>
-              <a:t>YOU-DO = Quiz 1 Q1 — an apply/decide item, NOT naming. Three tasks: (i) which activation belongs on the final neuron of a resistant-vs-susceptible classifier? Answer: (a) the SIGMOID — it is the only curve whose output is squeezed into (0, 1), so it reads as a probability; ReLU is unbounded above and Linear is unbounded both ways, so neither can be a probability. (ii) ReLU(−3) = max(0, −3) = 0 — the neuron is silent (the on/off idea again). (iii) sigmoid(0) = 1/(1+e^0) = 0.5 — maximally uncertain, a coin flip. The point: shape → range → job. Poll the room on (i) before revealing, then have them fill Q1 on the sheet.</a:t>
+              <a:t>I-DO, done aloud and slowly — the first hand-computation of the course. z is the dot product of weights and inputs, plus bias: 2·3=6, −1·2=−2, +1 → z=5. Then bend: ReLU leaves 5 alone (positive passes); sigmoid would map 5 to about 0.99, a confident yes. Note the schematic: inputs → weighted edges → Σ (the sum, z) → activation (the bend) → output y. Next slide you run the SAME machine on different numbers — and this time the sum comes out negative. That is Quiz 1 Q2.</a:t>
             </a:r>
           </a:p>
           <a:p>
@@ -538,7 +536,7 @@
           <a:lstStyle/>
           <a:p>
             <a:r>
-              <a:t>I-DO, done aloud and slowly — the first hand-computation of the course. z is the dot product of weights and inputs, plus bias: 2·3=6, −1·2=−2, +1 → z=5. Then bend: ReLU leaves 5 alone (positive passes); sigmoid would map 5 to about 0.99, a confident yes. Note the schematic: inputs → weighted edges → Σ (the sum, z) → activation (the bend) → output y. Next slide you run the SAME machine on different numbers — and this time the sum comes out negative. That is Quiz 1 Q2.</a:t>
+              <a:t>YOU-DO = Quiz 1 Q2 (same schematic, different numbers — and the sum lands negative on purpose). Worked answer: z = (0.5·2) + (−1·3) + 1 = 1 − 3 + 1 = −1. ReLU(−1) = max(0, −1) = 0 — the neuron stays SILENT. This is the on/off behaviour that, times millions of neurons, is how a network routes information: a negative weighted sum is clamped to zero and that neuron contributes nothing. Ask a couple of pairs for their z before revealing, then have them fill Q2 on the sheet.</a:t>
             </a:r>
           </a:p>
           <a:p>
@@ -611,7 +609,7 @@
           <a:lstStyle/>
           <a:p>
             <a:r>
-              <a:t>YOU-DO = Quiz 1 Q2 (same schematic, different numbers — and the sum lands negative on purpose). Worked answer: z = (0.5·2) + (−1·3) + 1 = 1 − 3 + 1 = −1. ReLU(−1) = max(0, −1) = 0 — the neuron stays SILENT. This is the on/off behaviour that, times millions of neurons, is how a network routes information: a negative weighted sum is clamped to zero and that neuron contributes nothing. Ask a couple of pairs for their z before revealing, then have them fill Q2 on the sheet.</a:t>
+              <a:t>I-DO. Frame first: each ROW of W is one neuron's weight list; the input x is the same three numbers for both neurons (three peak intensities: 2, 1, 0). Running the layer is the matrix–vector product W·x. The one gotcha is the shape rule: the column count (3) must equal the number of inputs (3); the row count (2) sets how many outputs. Compute row 1 live — take row 1 of W, pair term-by-term with x, multiply, add: 1·2=2, 0·1=0, 2·0=0; sum = 2. Say "dot product" once. One row left — they do it next, and it is Quiz 1 Q3.</a:t>
             </a:r>
           </a:p>
           <a:p>
@@ -684,7 +682,7 @@
           <a:lstStyle/>
           <a:p>
             <a:r>
-              <a:t>I-DO. Frame first: each ROW of W is one neuron's weight list; the input x is the same three numbers for both neurons (three peak intensities: 2, 1, 0). Running the layer is the matrix–vector product W·x. The one gotcha is the shape rule: the column count (3) must equal the number of inputs (3); the row count (2) sets how many outputs. Compute row 1 live — take row 1 of W, pair term-by-term with x, multiply, add: 1·2=2, 0·1=0, 2·0=0; sum = 2. Say "dot product" once. One row left — they do it next, and it is Quiz 1 Q3.</a:t>
+              <a:t>YOU-DO = Quiz 1 Q3 (the second row of the same matrix — different numbers from row 1, so genuine practice). Row 2 (−1, 3, 1) dotted with (2, 1, 0): (−1)(2) + (3)(1) + (1)(0) = −2 + 3 + 0 = 1. So Wx = (2, 1). Land it: a 2×3 matrix times a length-3 vector gives a length-2 output — one number per neuron, a full forward pass, and a fresh two-number representation that simply becomes the input to the next layer. Have them fill Q3 on the sheet.</a:t>
             </a:r>
           </a:p>
           <a:p>
@@ -757,7 +755,7 @@
           <a:lstStyle/>
           <a:p>
             <a:r>
-              <a:t>YOU-DO = Quiz 1 Q3 (the second row of the same matrix — different numbers from row 1, so genuine practice). Row 2 (−1, 3, 1) dotted with (2, 1, 0): (−1)(2) + (3)(1) + (1)(0) = −2 + 3 + 0 = 1. So Wx = (2, 1). Land it: a 2×3 matrix times a length-3 vector gives a length-2 output — one number per neuron, a full forward pass, and a fresh two-number representation that simply becomes the input to the next layer. Have them fill Q3 on the sheet.</a:t>
+              <a:t>The reassuring theorem, shown not stated: a network with enough neurons can approximate essentially any function. Each ReLU contributes one bend (the faint amber lines); summed, the bends chase the wiggly black target (teal dashed). The takeaway is intuition, not a proof: more neurons → more bends → more shape. This is WHY the non-linear bend from the last few slides matters — without it every stack collapses to a single straight line and no amount of depth would help. No math required; just "bends add up."</a:t>
             </a:r>
           </a:p>
           <a:p>
@@ -830,7 +828,7 @@
           <a:lstStyle/>
           <a:p>
             <a:r>
-              <a:t>The reassuring theorem, shown not stated: a network with enough neurons can approximate essentially any function. Each ReLU contributes one bend (the faint amber lines); summed, the bends chase the wiggly black target (teal dashed). The takeaway is intuition, not a proof: more neurons → more bends → more shape. This is WHY the non-linear bend from the last few slides matters — without it every stack collapses to a single straight line and no amount of depth would help. No math required; just "bends add up."</a:t>
+              <a:t>I-DO, read straight off the diagram (same 2→2→1 node layout as the you-do next slide, every weight and bias now printed on the figure). Feed x = (2, 1) into layer 1: hidden neuron 1 = (1)(2) + (−1)(1) + 0 = 1 → ReLU 1; hidden neuron 2 = (0)(2) + (1)(1) + 0 = 1 → ReLU 1. Both neurons fire, so hidden h = (1, 1) — a fresh representation, and a layer's output is just the next layer's input. Layer 2 reads h like any input, with weights W2 = (2, 1) and bias b2 = −1: y = (2)(1) + (1)(1) − 1 = 2. That is all "deep" means — multiply, add, bend, pass it on; stack the same move and depth builds the hierarchy on the next two slides. Soft callback: layer 1 is the same multiply-add-bend the room just ran on the matrix–vector slides, now feeding a second layer that reads the hidden vector — we do NOT claim the hidden layer just copies the input; here it recomputes to (1, 1). Next slide you take a fresh (2, 1) through your own two layers, with different weights — that is Quiz 1 Q6.</a:t>
             </a:r>
           </a:p>
           <a:p>
@@ -903,7 +901,7 @@
           <a:lstStyle/>
           <a:p>
             <a:r>
-              <a:t>I-DO, read straight off the diagram (same 2→2→1 node layout as the you-do next slide, every weight and bias now printed on the figure). Feed x = (2, 1) into layer 1: hidden neuron 1 = (1)(2) + (−1)(1) + 0 = 1 → ReLU 1; hidden neuron 2 = (0)(2) + (1)(1) + 0 = 1 → ReLU 1. Both neurons fire, so hidden h = (1, 1) — a fresh representation, and a layer's output is just the next layer's input. Layer 2 reads h like any input, with weights W2 = (2, 1) and bias b2 = −1: y = (2)(1) + (1)(1) − 1 = 2. That is all "deep" means — multiply, add, bend, pass it on; stack the same move and depth builds the hierarchy on the next two slides. Soft callback: layer 1 is the same multiply-add-bend the room just ran on the matrix–vector slides, now feeding a second layer that reads the hidden vector — we do NOT claim the hidden layer just copies the input; here it recomputes to (1, 1). Next slide you take a fresh (2, 1) through your own two layers, with different weights — that is Quiz 1 Q6.</a:t>
+              <a:t>YOU-DO = Quiz 1 Q6 (same input → hidden(ReLU) → output shape as the I-do, taking the (2, 1) you just computed forward as the input). Given x = (2, 1); W1 = [[1, −1], [−1, 1]], b1 = (0, −4); W2 = (3, 2), b2 = −1. Layer 1: row 1 = (1)(2) + (−1)(1) + 0 = 1 → ReLU 1; row 2 = (−1)(2) + (1)(1) + (−4) = −5 → ReLU 0. Hidden h = (1, 0) — the second neuron is silent again. Layer 2: y = (3)(1) + (2)(0) − 1 = 2. Ask a pair for their hidden vector before revealing y, then have them fill Q6 on the sheet.</a:t>
             </a:r>
           </a:p>
           <a:p>
@@ -976,7 +974,7 @@
           <a:lstStyle/>
           <a:p>
             <a:r>
-              <a:t>YOU-DO = Quiz 1 Q6 (same input → hidden(ReLU) → output shape as the I-do, taking the (2, 1) you just computed forward as the input). Given x = (2, 1); W1 = [[1, −1], [−1, 1]], b1 = (0, −4); W2 = (3, 2), b2 = −1. Layer 1: row 1 = (1)(2) + (−1)(1) + 0 = 1 → ReLU 1; row 2 = (−1)(2) + (1)(1) + (−4) = −5 → ReLU 0. Hidden h = (1, 0) — the second neuron is silent again. Layer 2: y = (3)(1) + (2)(0) − 1 = 2. Ask a pair for their hidden vector before revealing y, then have them fill Q6 on the sheet.</a:t>
+              <a:t>Close the loop opened at the start. This is DEPTH, not parallel filters: each layer takes the previous layer's output and builds something more abstract — pixels → edges → parts → whole → label. Early layers see fragments, deep layers see meaning. Crucial honesty: this hierarchy is LEARNED, not designed — it echoes the engineered-vs-learned pivot and previews Lecture 5, where a network's first layer literally becomes edge and peak detectors. The composite here is one cat photo (CC BY-SA 3.0) abstracted left-to-right at successive layers.</a:t>
             </a:r>
           </a:p>
           <a:p>
@@ -1049,7 +1047,7 @@
           <a:lstStyle/>
           <a:p>
             <a:r>
-              <a:t>Close the loop opened at the start. This is DEPTH, not parallel filters: each layer takes the previous layer's output and builds something more abstract — pixels → edges → parts → whole → label. Early layers see fragments, deep layers see meaning. Crucial honesty: this hierarchy is LEARNED, not designed — it echoes the engineered-vs-learned pivot and previews Lecture 5, where a network's first layer literally becomes edge and peak detectors. The composite here is one cat photo (CC BY-SA 3.0) abstracted left-to-right at successive layers.</a:t>
+              <a:t>Close the hour with the Quiz 1 Q5 reflection as a think-pair-share, then widen it to the room. Full-credit Q5 answers capture "learned features from raw data" vs. "human-engineered features first." After harvesting a sentence or two, push the problem-driven follow-up that seeds Lab 1 and the Segment 1 discussion: what data in YOUR lab could train a network, and would it likely beat the methods you rely on today? Harvest a few aloud — peak area, isotope ratio, retention time, S/N, a QC rule — each a hand-engineered feature a network could learn. Gain (patterns you never thought to measure) vs. risk (more data, less interpretability, validation burden — Lecture 10). Bridge to Lecture 2: today we assumed the weights; next hour we learn where they come from.</a:t>
             </a:r>
           </a:p>
           <a:p>
@@ -1128,152 +1126,6 @@
           </a:p>
           <a:p>
             <a:endParaRPr dirty="0"/>
-          </a:p>
-        </p:txBody>
-      </p:sp>
-      <p:sp>
-        <p:nvSpPr>
-          <p:cNvPr id="4" name="Slide Number Placeholder 3"/>
-          <p:cNvSpPr>
-            <a:spLocks noGrp="1"/>
-          </p:cNvSpPr>
-          <p:nvPr>
-            <p:ph type="sldNum" sz="quarter" idx="5"/>
-          </p:nvPr>
-        </p:nvSpPr>
-        <p:spPr/>
-      </p:sp>
-    </p:spTree>
-  </p:cSld>
-  <p:clrMapOvr>
-    <a:masterClrMapping/>
-  </p:clrMapOvr>
-</p:notes>
-</file>
-
-<file path=ppt/notesSlides/notesSlide20.xml><?xml version="1.0" encoding="utf-8"?>
-<p:notes xmlns:a="http://schemas.openxmlformats.org/drawingml/2006/main" xmlns:r="http://schemas.openxmlformats.org/officeDocument/2006/relationships" xmlns:p="http://schemas.openxmlformats.org/presentationml/2006/main">
-  <p:cSld>
-    <p:spTree>
-      <p:nvGrpSpPr>
-        <p:cNvPr id="1" name=""/>
-        <p:cNvGrpSpPr/>
-        <p:nvPr/>
-      </p:nvGrpSpPr>
-      <p:grpSpPr>
-        <a:xfrm>
-          <a:off x="0" y="0"/>
-          <a:ext cx="0" cy="0"/>
-          <a:chOff x="0" y="0"/>
-          <a:chExt cx="0" cy="0"/>
-        </a:xfrm>
-      </p:grpSpPr>
-      <p:sp>
-        <p:nvSpPr>
-          <p:cNvPr id="2" name="Slide Image Placeholder 1"/>
-          <p:cNvSpPr>
-            <a:spLocks noGrp="1" noRot="1" noChangeAspect="1"/>
-          </p:cNvSpPr>
-          <p:nvPr>
-            <p:ph type="sldImg" idx="2"/>
-          </p:nvPr>
-        </p:nvSpPr>
-        <p:spPr/>
-      </p:sp>
-      <p:sp>
-        <p:nvSpPr>
-          <p:cNvPr id="3" name="Notes Placeholder 2"/>
-          <p:cNvSpPr>
-            <a:spLocks noGrp="1"/>
-          </p:cNvSpPr>
-          <p:nvPr>
-            <p:ph type="body" sz="quarter" idx="3"/>
-          </p:nvPr>
-        </p:nvSpPr>
-        <p:spPr/>
-        <p:txBody>
-          <a:bodyPr/>
-          <a:lstStyle/>
-          <a:p>
-            <a:r>
-              <a:t>Rule-2 MS anchor for the whole hour: the cat hierarchy, retold on a REAL clinical spectrum — one Staphylococcus aureus isolate from DRIAMS, plotted straight from the binned_6000 vector (intensity vs m/z, CC0). This isolate is oxacillin-resistant (MRSA). Same machinery — multiply, add, bend — reads spectra: early layers find peak shapes, deeper layers find patterns of peaks, the top layer calls susceptible vs. resistant. This is exactly what Lab 2's 1D CNN does on these DRIAMS spectra. (Tighter clinical anchor than the earlier generic peptide MALDI figure.)</a:t>
-            </a:r>
-          </a:p>
-          <a:p>
-            <a:endParaRPr/>
-          </a:p>
-        </p:txBody>
-      </p:sp>
-      <p:sp>
-        <p:nvSpPr>
-          <p:cNvPr id="4" name="Slide Number Placeholder 3"/>
-          <p:cNvSpPr>
-            <a:spLocks noGrp="1"/>
-          </p:cNvSpPr>
-          <p:nvPr>
-            <p:ph type="sldNum" sz="quarter" idx="5"/>
-          </p:nvPr>
-        </p:nvSpPr>
-        <p:spPr/>
-      </p:sp>
-    </p:spTree>
-  </p:cSld>
-  <p:clrMapOvr>
-    <a:masterClrMapping/>
-  </p:clrMapOvr>
-</p:notes>
-</file>
-
-<file path=ppt/notesSlides/notesSlide21.xml><?xml version="1.0" encoding="utf-8"?>
-<p:notes xmlns:a="http://schemas.openxmlformats.org/drawingml/2006/main" xmlns:r="http://schemas.openxmlformats.org/officeDocument/2006/relationships" xmlns:p="http://schemas.openxmlformats.org/presentationml/2006/main">
-  <p:cSld>
-    <p:spTree>
-      <p:nvGrpSpPr>
-        <p:cNvPr id="1" name=""/>
-        <p:cNvGrpSpPr/>
-        <p:nvPr/>
-      </p:nvGrpSpPr>
-      <p:grpSpPr>
-        <a:xfrm>
-          <a:off x="0" y="0"/>
-          <a:ext cx="0" cy="0"/>
-          <a:chOff x="0" y="0"/>
-          <a:chExt cx="0" cy="0"/>
-        </a:xfrm>
-      </p:grpSpPr>
-      <p:sp>
-        <p:nvSpPr>
-          <p:cNvPr id="2" name="Slide Image Placeholder 1"/>
-          <p:cNvSpPr>
-            <a:spLocks noGrp="1" noRot="1" noChangeAspect="1"/>
-          </p:cNvSpPr>
-          <p:nvPr>
-            <p:ph type="sldImg" idx="2"/>
-          </p:nvPr>
-        </p:nvSpPr>
-        <p:spPr/>
-      </p:sp>
-      <p:sp>
-        <p:nvSpPr>
-          <p:cNvPr id="3" name="Notes Placeholder 2"/>
-          <p:cNvSpPr>
-            <a:spLocks noGrp="1"/>
-          </p:cNvSpPr>
-          <p:nvPr>
-            <p:ph type="body" sz="quarter" idx="3"/>
-          </p:nvPr>
-        </p:nvSpPr>
-        <p:spPr/>
-        <p:txBody>
-          <a:bodyPr/>
-          <a:lstStyle/>
-          <a:p>
-            <a:r>
-              <a:t>Close the hour with the Quiz 1 Q5 reflection as a think-pair-share, then widen it to the room. Full-credit Q5 answers capture "learned features from raw data" vs. "human-engineered features first." After harvesting a sentence or two, push the problem-driven follow-up that seeds Lab 1 and the Segment 1 discussion: what data in YOUR lab could train a network, and would it likely beat the methods you rely on today? Harvest a few aloud — peak area, isotope ratio, retention time, S/N, a QC rule — each a hand-engineered feature a network could learn. Gain (patterns you never thought to measure) vs. risk (more data, less interpretability, validation burden — Lecture 10). Bridge to Lecture 2: today we assumed the weights; next hour we learn where they come from.</a:t>
-            </a:r>
-          </a:p>
-          <a:p>
-            <a:endParaRPr/>
           </a:p>
         </p:txBody>
       </p:sp>
@@ -3890,13 +3742,25 @@
           <a:p>
             <a:pPr algn="ctr"/>
             <a:r>
-              <a:rPr lang="en-US" sz="1700" b="0" i="0" dirty="0">
+              <a:rPr lang="en-US" sz="1700" b="0" i="0" u="sng" dirty="0">
                 <a:solidFill>
                   <a:srgbClr val="3D444C"/>
                 </a:solidFill>
                 <a:latin typeface="Avenir Next"/>
               </a:rPr>
-              <a:t>Weight and Bias will transform the feature; Activation will make it non-linear.</a:t>
+              <a:t>Weight and Bias will transform the feature; </a:t>
+            </a:r>
+          </a:p>
+          <a:p>
+            <a:pPr algn="ctr"/>
+            <a:r>
+              <a:rPr lang="en-US" sz="1700" b="0" i="0" u="sng" dirty="0">
+                <a:solidFill>
+                  <a:srgbClr val="3D444C"/>
+                </a:solidFill>
+                <a:latin typeface="Avenir Next"/>
+              </a:rPr>
+              <a:t>Activation will make it non-linear.</a:t>
             </a:r>
           </a:p>
           <a:p>
@@ -4202,291 +4066,6 @@
       </p:grpSpPr>
       <p:sp>
         <p:nvSpPr>
-          <p:cNvPr id="3" name="TextBox 2"/>
-          <p:cNvSpPr txBox="1"/>
-          <p:nvPr/>
-        </p:nvSpPr>
-        <p:spPr>
-          <a:xfrm>
-            <a:off x="548640" y="320040"/>
-            <a:ext cx="10972800" cy="365760"/>
-          </a:xfrm>
-          <a:prstGeom prst="rect">
-            <a:avLst/>
-          </a:prstGeom>
-          <a:noFill/>
-        </p:spPr>
-        <p:txBody>
-          <a:bodyPr wrap="square" anchor="t">
-            <a:spAutoFit/>
-          </a:bodyPr>
-          <a:lstStyle/>
-          <a:p>
-            <a:r>
-              <a:rPr sz="1300" b="1" i="0">
-                <a:solidFill>
-                  <a:srgbClr val="8A9099"/>
-                </a:solidFill>
-                <a:latin typeface="Menlo"/>
-              </a:rPr>
-              <a:t>THE NEURON · THE BEND (I-DO)</a:t>
-            </a:r>
-          </a:p>
-        </p:txBody>
-      </p:sp>
-      <p:sp>
-        <p:nvSpPr>
-          <p:cNvPr id="4" name="TextBox 3"/>
-          <p:cNvSpPr txBox="1"/>
-          <p:nvPr/>
-        </p:nvSpPr>
-        <p:spPr>
-          <a:xfrm>
-            <a:off x="548640" y="731520"/>
-            <a:ext cx="11064240" cy="1005840"/>
-          </a:xfrm>
-          <a:prstGeom prst="rect">
-            <a:avLst/>
-          </a:prstGeom>
-          <a:noFill/>
-        </p:spPr>
-        <p:txBody>
-          <a:bodyPr wrap="square" anchor="t">
-            <a:spAutoFit/>
-          </a:bodyPr>
-          <a:lstStyle/>
-          <a:p>
-            <a:r>
-              <a:rPr sz="3400" b="1" i="0">
-                <a:solidFill>
-                  <a:srgbClr val="1B2025"/>
-                </a:solidFill>
-                <a:latin typeface="Avenir Next"/>
-              </a:rPr>
-              <a:t>Three activations, three shapes</a:t>
-            </a:r>
-          </a:p>
-        </p:txBody>
-      </p:sp>
-      <p:pic>
-        <p:nvPicPr>
-          <p:cNvPr id="5" name="Picture 4" descr="fig_activations.png"/>
-          <p:cNvPicPr>
-            <a:picLocks noChangeAspect="1"/>
-          </p:cNvPicPr>
-          <p:nvPr/>
-        </p:nvPicPr>
-        <p:blipFill>
-          <a:blip r:embed="rId3"/>
-          <a:stretch>
-            <a:fillRect/>
-          </a:stretch>
-        </p:blipFill>
-        <p:spPr>
-          <a:xfrm>
-            <a:off x="1701970" y="1828800"/>
-            <a:ext cx="8757579" cy="3200400"/>
-          </a:xfrm>
-          <a:prstGeom prst="rect">
-            <a:avLst/>
-          </a:prstGeom>
-        </p:spPr>
-      </p:pic>
-      <p:sp>
-        <p:nvSpPr>
-          <p:cNvPr id="6" name="Rectangle 5"/>
-          <p:cNvSpPr/>
-          <p:nvPr/>
-        </p:nvSpPr>
-        <p:spPr>
-          <a:xfrm>
-            <a:off x="548640" y="5120640"/>
-            <a:ext cx="10515600" cy="914400"/>
-          </a:xfrm>
-          <a:prstGeom prst="rect">
-            <a:avLst/>
-          </a:prstGeom>
-          <a:solidFill>
-            <a:srgbClr val="F1F1EC"/>
-          </a:solidFill>
-          <a:ln w="12700">
-            <a:solidFill>
-              <a:srgbClr val="3D444C"/>
-            </a:solidFill>
-          </a:ln>
-          <a:effectLst/>
-        </p:spPr>
-        <p:style>
-          <a:lnRef idx="1">
-            <a:schemeClr val="accent1"/>
-          </a:lnRef>
-          <a:fillRef idx="3">
-            <a:schemeClr val="accent1"/>
-          </a:fillRef>
-          <a:effectRef idx="2">
-            <a:schemeClr val="accent1"/>
-          </a:effectRef>
-          <a:fontRef idx="minor">
-            <a:schemeClr val="lt1"/>
-          </a:fontRef>
-        </p:style>
-        <p:txBody>
-          <a:bodyPr wrap="square" lIns="182880" rIns="182880" rtlCol="0" anchor="ctr"/>
-          <a:lstStyle/>
-          <a:p>
-            <a:pPr algn="ctr"/>
-            <a:r>
-              <a:rPr sz="1700" b="0" i="0">
-                <a:solidFill>
-                  <a:srgbClr val="3D444C"/>
-                </a:solidFill>
-                <a:latin typeface="Avenir Next"/>
-              </a:rPr>
-              <a:t>ReLU — negatives → 0, positives pass (the default hidden layer). Sigmoid — squashes any number into 0–1, read as a probability. Linear — no bend at all.</a:t>
-            </a:r>
-          </a:p>
-        </p:txBody>
-      </p:sp>
-      <p:sp>
-        <p:nvSpPr>
-          <p:cNvPr id="7" name="TextBox 6">
-            <a:extLst>
-              <a:ext uri="{FF2B5EF4-FFF2-40B4-BE49-F238E27FC236}">
-                <a16:creationId xmlns:a16="http://schemas.microsoft.com/office/drawing/2014/main" id="{9DDE73EC-890A-CBD8-A0DC-CD7CFD6340B2}"/>
-              </a:ext>
-            </a:extLst>
-          </p:cNvPr>
-          <p:cNvSpPr txBox="1"/>
-          <p:nvPr/>
-        </p:nvSpPr>
-        <p:spPr>
-          <a:xfrm>
-            <a:off x="8449239" y="2828835"/>
-            <a:ext cx="1238457" cy="1200329"/>
-          </a:xfrm>
-          <a:prstGeom prst="rect">
-            <a:avLst/>
-          </a:prstGeom>
-          <a:noFill/>
-        </p:spPr>
-        <p:txBody>
-          <a:bodyPr wrap="square" rtlCol="0">
-            <a:spAutoFit/>
-          </a:bodyPr>
-          <a:lstStyle/>
-          <a:p>
-            <a:r>
-              <a:rPr lang="en-US" sz="7200" dirty="0"/>
-              <a:t>❌</a:t>
-            </a:r>
-          </a:p>
-        </p:txBody>
-      </p:sp>
-    </p:spTree>
-  </p:cSld>
-  <p:clrMapOvr>
-    <a:masterClrMapping/>
-  </p:clrMapOvr>
-  <p:timing>
-    <p:tnLst>
-      <p:par>
-        <p:cTn id="1" dur="indefinite" restart="never" nodeType="tmRoot">
-          <p:childTnLst>
-            <p:seq concurrent="1" nextAc="seek">
-              <p:cTn id="2" dur="indefinite" nodeType="mainSeq">
-                <p:childTnLst>
-                  <p:par>
-                    <p:cTn id="3" fill="hold">
-                      <p:stCondLst>
-                        <p:cond delay="indefinite"/>
-                      </p:stCondLst>
-                      <p:childTnLst>
-                        <p:par>
-                          <p:cTn id="4" fill="hold">
-                            <p:stCondLst>
-                              <p:cond delay="0"/>
-                            </p:stCondLst>
-                            <p:childTnLst>
-                              <p:par>
-                                <p:cTn id="5" presetID="1" presetClass="entr" presetSubtype="0" fill="hold" grpId="0" nodeType="clickEffect">
-                                  <p:stCondLst>
-                                    <p:cond delay="0"/>
-                                  </p:stCondLst>
-                                  <p:childTnLst>
-                                    <p:set>
-                                      <p:cBhvr>
-                                        <p:cTn id="6" dur="1" fill="hold">
-                                          <p:stCondLst>
-                                            <p:cond delay="0"/>
-                                          </p:stCondLst>
-                                        </p:cTn>
-                                        <p:tgtEl>
-                                          <p:spTgt spid="7"/>
-                                        </p:tgtEl>
-                                        <p:attrNameLst>
-                                          <p:attrName>style.visibility</p:attrName>
-                                        </p:attrNameLst>
-                                      </p:cBhvr>
-                                      <p:to>
-                                        <p:strVal val="visible"/>
-                                      </p:to>
-                                    </p:set>
-                                  </p:childTnLst>
-                                </p:cTn>
-                              </p:par>
-                            </p:childTnLst>
-                          </p:cTn>
-                        </p:par>
-                      </p:childTnLst>
-                    </p:cTn>
-                  </p:par>
-                </p:childTnLst>
-              </p:cTn>
-              <p:prevCondLst>
-                <p:cond evt="onPrev" delay="0">
-                  <p:tgtEl>
-                    <p:sldTgt/>
-                  </p:tgtEl>
-                </p:cond>
-              </p:prevCondLst>
-              <p:nextCondLst>
-                <p:cond evt="onNext" delay="0">
-                  <p:tgtEl>
-                    <p:sldTgt/>
-                  </p:tgtEl>
-                </p:cond>
-              </p:nextCondLst>
-            </p:seq>
-          </p:childTnLst>
-        </p:cTn>
-      </p:par>
-    </p:tnLst>
-    <p:bldLst>
-      <p:bldP spid="7" grpId="0"/>
-    </p:bldLst>
-  </p:timing>
-</p:sld>
-</file>
-
-<file path=ppt/slides/slide14.xml><?xml version="1.0" encoding="utf-8"?>
-<p:sld xmlns:a="http://schemas.openxmlformats.org/drawingml/2006/main" xmlns:r="http://schemas.openxmlformats.org/officeDocument/2006/relationships" xmlns:p="http://schemas.openxmlformats.org/presentationml/2006/main">
-  <p:cSld>
-    <p:spTree>
-      <p:nvGrpSpPr>
-        <p:cNvPr id="1" name=""/>
-        <p:cNvGrpSpPr/>
-        <p:nvPr/>
-      </p:nvGrpSpPr>
-      <p:grpSpPr>
-        <a:xfrm>
-          <a:off x="0" y="0"/>
-          <a:ext cx="0" cy="0"/>
-          <a:chOff x="0" y="0"/>
-          <a:chExt cx="0" cy="0"/>
-        </a:xfrm>
-      </p:grpSpPr>
-      <p:sp>
-        <p:nvSpPr>
           <p:cNvPr id="2" name="Rectangle 1"/>
           <p:cNvSpPr/>
           <p:nvPr/>
@@ -4885,6 +4464,259 @@
 </p:sld>
 </file>
 
+<file path=ppt/slides/slide14.xml><?xml version="1.0" encoding="utf-8"?>
+<p:sld xmlns:a="http://schemas.openxmlformats.org/drawingml/2006/main" xmlns:r="http://schemas.openxmlformats.org/officeDocument/2006/relationships" xmlns:p="http://schemas.openxmlformats.org/presentationml/2006/main">
+  <p:cSld>
+    <p:spTree>
+      <p:nvGrpSpPr>
+        <p:cNvPr id="1" name=""/>
+        <p:cNvGrpSpPr/>
+        <p:nvPr/>
+      </p:nvGrpSpPr>
+      <p:grpSpPr>
+        <a:xfrm>
+          <a:off x="0" y="0"/>
+          <a:ext cx="0" cy="0"/>
+          <a:chOff x="0" y="0"/>
+          <a:chExt cx="0" cy="0"/>
+        </a:xfrm>
+      </p:grpSpPr>
+      <p:sp>
+        <p:nvSpPr>
+          <p:cNvPr id="2" name="Rectangle 1"/>
+          <p:cNvSpPr/>
+          <p:nvPr/>
+        </p:nvSpPr>
+        <p:spPr>
+          <a:xfrm>
+            <a:off x="0" y="0"/>
+            <a:ext cx="12191695" cy="6858000"/>
+          </a:xfrm>
+          <a:prstGeom prst="rect">
+            <a:avLst/>
+          </a:prstGeom>
+          <a:solidFill>
+            <a:srgbClr val="FBFBF8"/>
+          </a:solidFill>
+          <a:ln>
+            <a:noFill/>
+          </a:ln>
+          <a:effectLst/>
+        </p:spPr>
+        <p:style>
+          <a:lnRef idx="1">
+            <a:schemeClr val="accent1"/>
+          </a:lnRef>
+          <a:fillRef idx="3">
+            <a:schemeClr val="accent1"/>
+          </a:fillRef>
+          <a:effectRef idx="2">
+            <a:schemeClr val="accent1"/>
+          </a:effectRef>
+          <a:fontRef idx="minor">
+            <a:schemeClr val="lt1"/>
+          </a:fontRef>
+        </p:style>
+        <p:txBody>
+          <a:bodyPr rtlCol="0" anchor="ctr"/>
+          <a:lstStyle/>
+          <a:p>
+            <a:pPr algn="ctr"/>
+            <a:endParaRPr/>
+          </a:p>
+        </p:txBody>
+      </p:sp>
+      <p:sp>
+        <p:nvSpPr>
+          <p:cNvPr id="3" name="TextBox 2"/>
+          <p:cNvSpPr txBox="1"/>
+          <p:nvPr/>
+        </p:nvSpPr>
+        <p:spPr>
+          <a:xfrm>
+            <a:off x="548640" y="320040"/>
+            <a:ext cx="10972800" cy="365760"/>
+          </a:xfrm>
+          <a:prstGeom prst="rect">
+            <a:avLst/>
+          </a:prstGeom>
+          <a:noFill/>
+        </p:spPr>
+        <p:txBody>
+          <a:bodyPr wrap="square" anchor="t">
+            <a:spAutoFit/>
+          </a:bodyPr>
+          <a:lstStyle/>
+          <a:p>
+            <a:r>
+              <a:rPr sz="1300" b="1" i="0">
+                <a:solidFill>
+                  <a:srgbClr val="8A9099"/>
+                </a:solidFill>
+                <a:latin typeface="Menlo"/>
+              </a:rPr>
+              <a:t>THE NEURON · WORKED BY HAND (I-DO)</a:t>
+            </a:r>
+          </a:p>
+        </p:txBody>
+      </p:sp>
+      <p:sp>
+        <p:nvSpPr>
+          <p:cNvPr id="4" name="TextBox 3"/>
+          <p:cNvSpPr txBox="1"/>
+          <p:nvPr/>
+        </p:nvSpPr>
+        <p:spPr>
+          <a:xfrm>
+            <a:off x="548640" y="731520"/>
+            <a:ext cx="11064240" cy="1005840"/>
+          </a:xfrm>
+          <a:prstGeom prst="rect">
+            <a:avLst/>
+          </a:prstGeom>
+          <a:noFill/>
+        </p:spPr>
+        <p:txBody>
+          <a:bodyPr wrap="square" anchor="t">
+            <a:spAutoFit/>
+          </a:bodyPr>
+          <a:lstStyle/>
+          <a:p>
+            <a:r>
+              <a:rPr sz="3400" b="1" i="0">
+                <a:solidFill>
+                  <a:srgbClr val="1B2025"/>
+                </a:solidFill>
+                <a:latin typeface="Avenir Next"/>
+              </a:rPr>
+              <a:t>One neuron, real numbers</a:t>
+            </a:r>
+          </a:p>
+        </p:txBody>
+      </p:sp>
+      <p:pic>
+        <p:nvPicPr>
+          <p:cNvPr id="5" name="Picture 4" descr="fig_neuron_ido.png"/>
+          <p:cNvPicPr>
+            <a:picLocks noChangeAspect="1"/>
+          </p:cNvPicPr>
+          <p:nvPr/>
+        </p:nvPicPr>
+        <p:blipFill>
+          <a:blip r:embed="rId3"/>
+          <a:stretch>
+            <a:fillRect/>
+          </a:stretch>
+        </p:blipFill>
+        <p:spPr>
+          <a:xfrm>
+            <a:off x="2632553" y="1828800"/>
+            <a:ext cx="6896413" cy="3200400"/>
+          </a:xfrm>
+          <a:prstGeom prst="rect">
+            <a:avLst/>
+          </a:prstGeom>
+        </p:spPr>
+      </p:pic>
+      <p:sp>
+        <p:nvSpPr>
+          <p:cNvPr id="6" name="Rectangle 5"/>
+          <p:cNvSpPr/>
+          <p:nvPr/>
+        </p:nvSpPr>
+        <p:spPr>
+          <a:xfrm>
+            <a:off x="548640" y="5120640"/>
+            <a:ext cx="10515600" cy="914400"/>
+          </a:xfrm>
+          <a:prstGeom prst="rect">
+            <a:avLst/>
+          </a:prstGeom>
+          <a:solidFill>
+            <a:srgbClr val="E3F0EF"/>
+          </a:solidFill>
+          <a:ln w="12700">
+            <a:solidFill>
+              <a:srgbClr val="0E7C7B"/>
+            </a:solidFill>
+          </a:ln>
+          <a:effectLst/>
+        </p:spPr>
+        <p:style>
+          <a:lnRef idx="1">
+            <a:schemeClr val="accent1"/>
+          </a:lnRef>
+          <a:fillRef idx="3">
+            <a:schemeClr val="accent1"/>
+          </a:fillRef>
+          <a:effectRef idx="2">
+            <a:schemeClr val="accent1"/>
+          </a:effectRef>
+          <a:fontRef idx="minor">
+            <a:schemeClr val="lt1"/>
+          </a:fontRef>
+        </p:style>
+        <p:txBody>
+          <a:bodyPr wrap="square" lIns="182880" rIns="182880" rtlCol="0" anchor="ctr"/>
+          <a:lstStyle/>
+          <a:p>
+            <a:pPr algn="ctr"/>
+            <a:r>
+              <a:rPr lang="en-US" sz="1200" b="1" i="0" dirty="0">
+                <a:solidFill>
+                  <a:srgbClr val="0E7C7B"/>
+                </a:solidFill>
+                <a:latin typeface="Menlo"/>
+              </a:rPr>
+              <a:t>Math</a:t>
+            </a:r>
+            <a:r>
+              <a:rPr sz="1200" b="1" i="0" dirty="0">
+                <a:solidFill>
+                  <a:srgbClr val="0E7C7B"/>
+                </a:solidFill>
+                <a:latin typeface="Menlo"/>
+              </a:rPr>
+              <a:t>· </a:t>
+            </a:r>
+            <a:r>
+              <a:rPr sz="1700" b="0" i="0" dirty="0">
+                <a:solidFill>
+                  <a:srgbClr val="3D444C"/>
+                </a:solidFill>
+                <a:latin typeface="Avenir Next"/>
+              </a:rPr>
+              <a:t>z = (2·3) + (−1·2) + 1 = 5, so </a:t>
+            </a:r>
+            <a:r>
+              <a:rPr sz="1700" b="0" i="0" dirty="0" err="1">
+                <a:solidFill>
+                  <a:srgbClr val="3D444C"/>
+                </a:solidFill>
+                <a:latin typeface="Avenir Next"/>
+              </a:rPr>
+              <a:t>ReLU</a:t>
+            </a:r>
+            <a:r>
+              <a:rPr sz="1700" b="0" i="0" dirty="0">
+                <a:solidFill>
+                  <a:srgbClr val="3D444C"/>
+                </a:solidFill>
+                <a:latin typeface="Avenir Next"/>
+              </a:rPr>
+              <a:t>(5) = 5 — the neuron fires. Read x as two peak intensities: this neuron likes input 1 and distrusts input 2.</a:t>
+            </a:r>
+          </a:p>
+        </p:txBody>
+      </p:sp>
+    </p:spTree>
+  </p:cSld>
+  <p:clrMapOvr>
+    <a:masterClrMapping/>
+  </p:clrMapOvr>
+</p:sld>
+</file>
+
 <file path=ppt/slides/slide15.xml><?xml version="1.0" encoding="utf-8"?>
 <p:sld xmlns:a="http://schemas.openxmlformats.org/drawingml/2006/main" xmlns:r="http://schemas.openxmlformats.org/officeDocument/2006/relationships" xmlns:p="http://schemas.openxmlformats.org/presentationml/2006/main">
   <p:cSld>
@@ -4976,7 +4808,7 @@
                 </a:solidFill>
                 <a:latin typeface="Menlo"/>
               </a:rPr>
-              <a:t>THE NEURON · WORKED BY HAND (I-DO)</a:t>
+              <a:t>THE NEURON · YOUR TURN (YOU-DO)</a:t>
             </a:r>
           </a:p>
         </p:txBody>
@@ -5010,14 +4842,14 @@
                 </a:solidFill>
                 <a:latin typeface="Avenir Next"/>
               </a:rPr>
-              <a:t>One neuron, real numbers</a:t>
+              <a:t>Your neuron — compute it</a:t>
             </a:r>
           </a:p>
         </p:txBody>
       </p:sp>
       <p:pic>
         <p:nvPicPr>
-          <p:cNvPr id="5" name="Picture 4" descr="fig_neuron_ido.png"/>
+          <p:cNvPr id="5" name="Picture 4" descr="fig_neuron_youdo.png"/>
           <p:cNvPicPr>
             <a:picLocks noChangeAspect="1"/>
           </p:cNvPicPr>
@@ -5054,11 +4886,11 @@
             <a:avLst/>
           </a:prstGeom>
           <a:solidFill>
-            <a:srgbClr val="E3F0EF"/>
+            <a:srgbClr val="F1F1EC"/>
           </a:solidFill>
           <a:ln w="12700">
             <a:solidFill>
-              <a:srgbClr val="0E7C7B"/>
+              <a:srgbClr val="E09E2F"/>
             </a:solidFill>
           </a:ln>
           <a:effectLst/>
@@ -5083,49 +4915,22 @@
           <a:p>
             <a:pPr algn="ctr"/>
             <a:r>
-              <a:rPr lang="en-US" sz="1200" b="1" i="0" dirty="0">
-                <a:solidFill>
-                  <a:srgbClr val="0E7C7B"/>
+              <a:rPr sz="1200" b="1" i="0">
+                <a:solidFill>
+                  <a:srgbClr val="E09E2F"/>
                 </a:solidFill>
                 <a:latin typeface="Menlo"/>
               </a:rPr>
-              <a:t>Math</a:t>
-            </a:r>
-            <a:r>
-              <a:rPr sz="1200" b="1" i="0" dirty="0">
-                <a:solidFill>
-                  <a:srgbClr val="0E7C7B"/>
-                </a:solidFill>
-                <a:latin typeface="Menlo"/>
-              </a:rPr>
-              <a:t>· </a:t>
-            </a:r>
-            <a:r>
-              <a:rPr sz="1700" b="0" i="0" dirty="0">
+              <a:t>CHECKPOINT · </a:t>
+            </a:r>
+            <a:r>
+              <a:rPr sz="1700" b="0" i="0">
                 <a:solidFill>
                   <a:srgbClr val="3D444C"/>
                 </a:solidFill>
                 <a:latin typeface="Avenir Next"/>
               </a:rPr>
-              <a:t>z = (2·3) + (−1·2) + 1 = 5, so </a:t>
-            </a:r>
-            <a:r>
-              <a:rPr sz="1700" b="0" i="0" dirty="0" err="1">
-                <a:solidFill>
-                  <a:srgbClr val="3D444C"/>
-                </a:solidFill>
-                <a:latin typeface="Avenir Next"/>
-              </a:rPr>
-              <a:t>ReLU</a:t>
-            </a:r>
-            <a:r>
-              <a:rPr sz="1700" b="0" i="0" dirty="0">
-                <a:solidFill>
-                  <a:srgbClr val="3D444C"/>
-                </a:solidFill>
-                <a:latin typeface="Avenir Next"/>
-              </a:rPr>
-              <a:t>(5) = 5 — the neuron fires. Read x as two peak intensities: this neuron likes input 1 and distrusts input 2.</a:t>
+              <a:t>Your turn → Quiz 1, Q2. Compute z = w·x + b, then apply ReLU. 90 seconds with a neighbour — worked answer in the notes.</a:t>
             </a:r>
           </a:p>
         </p:txBody>
@@ -5229,7 +5034,7 @@
                 </a:solidFill>
                 <a:latin typeface="Menlo"/>
               </a:rPr>
-              <a:t>THE NEURON · YOUR TURN (YOU-DO)</a:t>
+              <a:t>STACKING · A LAYER IS A MATRIX, ROW 1 (I-DO)</a:t>
             </a:r>
           </a:p>
         </p:txBody>
@@ -5263,14 +5068,14 @@
                 </a:solidFill>
                 <a:latin typeface="Avenir Next"/>
               </a:rPr>
-              <a:t>Your neuron — compute it</a:t>
+              <a:t>Two neurons, three inputs — row 1</a:t>
             </a:r>
           </a:p>
         </p:txBody>
       </p:sp>
       <p:pic>
         <p:nvPicPr>
-          <p:cNvPr id="5" name="Picture 4" descr="fig_neuron_youdo.png"/>
+          <p:cNvPr id="5" name="Picture 4" descr="fig_matvec_row1.png"/>
           <p:cNvPicPr>
             <a:picLocks noChangeAspect="1"/>
           </p:cNvPicPr>
@@ -5284,8 +5089,8 @@
         </p:blipFill>
         <p:spPr>
           <a:xfrm>
-            <a:off x="2632553" y="1828800"/>
-            <a:ext cx="6896413" cy="3200400"/>
+            <a:off x="1573154" y="1828800"/>
+            <a:ext cx="9015211" cy="3200400"/>
           </a:xfrm>
           <a:prstGeom prst="rect">
             <a:avLst/>
@@ -5311,7 +5116,7 @@
           </a:solidFill>
           <a:ln w="12700">
             <a:solidFill>
-              <a:srgbClr val="E09E2F"/>
+              <a:srgbClr val="3D444C"/>
             </a:solidFill>
           </a:ln>
           <a:effectLst/>
@@ -5336,22 +5141,13 @@
           <a:p>
             <a:pPr algn="ctr"/>
             <a:r>
-              <a:rPr sz="1200" b="1" i="0">
-                <a:solidFill>
-                  <a:srgbClr val="E09E2F"/>
-                </a:solidFill>
-                <a:latin typeface="Menlo"/>
-              </a:rPr>
-              <a:t>CHECKPOINT · </a:t>
-            </a:r>
-            <a:r>
               <a:rPr sz="1700" b="0" i="0">
                 <a:solidFill>
                   <a:srgbClr val="3D444C"/>
                 </a:solidFill>
                 <a:latin typeface="Avenir Next"/>
               </a:rPr>
-              <a:t>Your turn → Quiz 1, Q2. Compute z = w·x + b, then apply ReLU. 90 seconds with a neighbour — worked answer in the notes.</a:t>
+              <a:t>Each ROW of W is one neuron; running the layer is W·x. Shapes must click: 3 inputs → 3 columns · 2 neurons → 2 rows → 2 outputs. Row 1 = (1·2)+(0·1)+(2·0) = 2.</a:t>
             </a:r>
           </a:p>
         </p:txBody>
@@ -5455,7 +5251,7 @@
                 </a:solidFill>
                 <a:latin typeface="Menlo"/>
               </a:rPr>
-              <a:t>STACKING · A LAYER IS A MATRIX, ROW 1 (I-DO)</a:t>
+              <a:t>STACKING · YOUR TURN, ROW 2 (YOU-DO)</a:t>
             </a:r>
           </a:p>
         </p:txBody>
@@ -5489,14 +5285,14 @@
                 </a:solidFill>
                 <a:latin typeface="Avenir Next"/>
               </a:rPr>
-              <a:t>Two neurons, three inputs — row 1</a:t>
+              <a:t>Row 2 — your turn, then read Wx</a:t>
             </a:r>
           </a:p>
         </p:txBody>
       </p:sp>
       <p:pic>
         <p:nvPicPr>
-          <p:cNvPr id="5" name="Picture 4" descr="fig_matvec_row1.png"/>
+          <p:cNvPr id="5" name="Picture 4" descr="fig_matvec_row2.png"/>
           <p:cNvPicPr>
             <a:picLocks noChangeAspect="1"/>
           </p:cNvPicPr>
@@ -5537,7 +5333,7 @@
           </a:solidFill>
           <a:ln w="12700">
             <a:solidFill>
-              <a:srgbClr val="3D444C"/>
+              <a:srgbClr val="E09E2F"/>
             </a:solidFill>
           </a:ln>
           <a:effectLst/>
@@ -5562,13 +5358,22 @@
           <a:p>
             <a:pPr algn="ctr"/>
             <a:r>
+              <a:rPr sz="1200" b="1" i="0">
+                <a:solidFill>
+                  <a:srgbClr val="E09E2F"/>
+                </a:solidFill>
+                <a:latin typeface="Menlo"/>
+              </a:rPr>
+              <a:t>CHECKPOINT · </a:t>
+            </a:r>
+            <a:r>
               <a:rPr sz="1700" b="0" i="0">
                 <a:solidFill>
                   <a:srgbClr val="3D444C"/>
                 </a:solidFill>
                 <a:latin typeface="Avenir Next"/>
               </a:rPr>
-              <a:t>Each ROW of W is one neuron; running the layer is W·x. Shapes must click: 3 inputs → 3 columns · 2 neurons → 2 rows → 2 outputs. Row 1 = (1·2)+(0·1)+(2·0) = 2.</a:t>
+              <a:t>Your turn → Quiz 1, Q3. Compute row 2's dot product and read the full output Wx. Worked answer in the notes.</a:t>
             </a:r>
           </a:p>
         </p:txBody>
@@ -5672,7 +5477,7 @@
                 </a:solidFill>
                 <a:latin typeface="Menlo"/>
               </a:rPr>
-              <a:t>STACKING · YOUR TURN, ROW 2 (YOU-DO)</a:t>
+              <a:t>WHY THE BEND MATTERS · THE BIG PICTURE</a:t>
             </a:r>
           </a:p>
         </p:txBody>
@@ -5686,7 +5491,7 @@
         <p:spPr>
           <a:xfrm>
             <a:off x="548640" y="731520"/>
-            <a:ext cx="11064240" cy="1005840"/>
+            <a:ext cx="11064240" cy="615553"/>
           </a:xfrm>
           <a:prstGeom prst="rect">
             <a:avLst/>
@@ -5700,20 +5505,47 @@
           <a:lstStyle/>
           <a:p>
             <a:r>
-              <a:rPr sz="3400" b="1" i="0">
+              <a:rPr lang="en-US" sz="3400" b="1" i="0" dirty="0">
                 <a:solidFill>
                   <a:srgbClr val="1B2025"/>
                 </a:solidFill>
                 <a:latin typeface="Avenir Next"/>
               </a:rPr>
-              <a:t>Row 2 — your turn, then read Wx</a:t>
+              <a:t>Core Belief: </a:t>
+            </a:r>
+            <a:r>
+              <a:rPr sz="3400" b="1" i="0" dirty="0">
+                <a:solidFill>
+                  <a:srgbClr val="1B2025"/>
+                </a:solidFill>
+                <a:latin typeface="Avenir Next"/>
+              </a:rPr>
+              <a:t>Enough </a:t>
+            </a:r>
+            <a:r>
+              <a:rPr lang="en-US" sz="3400" b="1" i="0" dirty="0">
+                <a:solidFill>
+                  <a:srgbClr val="1B2025"/>
+                </a:solidFill>
+                <a:latin typeface="Avenir Next"/>
+              </a:rPr>
+              <a:t>”layers”</a:t>
+            </a:r>
+            <a:r>
+              <a:rPr sz="3400" b="1" i="0" dirty="0">
+                <a:solidFill>
+                  <a:srgbClr val="1B2025"/>
+                </a:solidFill>
+                <a:latin typeface="Avenir Next"/>
+              </a:rPr>
+              <a:t> can trace ANY curve</a:t>
             </a:r>
           </a:p>
         </p:txBody>
       </p:sp>
       <p:pic>
         <p:nvPicPr>
-          <p:cNvPr id="5" name="Picture 4" descr="fig_matvec_row2.png"/>
+          <p:cNvPr id="5" name="Picture 4" descr="fig_universal_approx.png"/>
           <p:cNvPicPr>
             <a:picLocks noChangeAspect="1"/>
           </p:cNvPicPr>
@@ -5727,8 +5559,8 @@
         </p:blipFill>
         <p:spPr>
           <a:xfrm>
-            <a:off x="1573154" y="1828800"/>
-            <a:ext cx="9015211" cy="3200400"/>
+            <a:off x="3016941" y="3337560"/>
+            <a:ext cx="6036197" cy="3200400"/>
           </a:xfrm>
           <a:prstGeom prst="rect">
             <a:avLst/>
@@ -5743,8 +5575,8 @@
         </p:nvSpPr>
         <p:spPr>
           <a:xfrm>
-            <a:off x="548640" y="5120640"/>
-            <a:ext cx="10515600" cy="914400"/>
+            <a:off x="672207" y="1558804"/>
+            <a:ext cx="10515600" cy="1572768"/>
           </a:xfrm>
           <a:prstGeom prst="rect">
             <a:avLst/>
@@ -5754,7 +5586,7 @@
           </a:solidFill>
           <a:ln w="12700">
             <a:solidFill>
-              <a:srgbClr val="E09E2F"/>
+              <a:srgbClr val="3D444C"/>
             </a:solidFill>
           </a:ln>
           <a:effectLst/>
@@ -5779,22 +5611,85 @@
           <a:p>
             <a:pPr algn="ctr"/>
             <a:r>
-              <a:rPr sz="1200" b="1" i="0">
-                <a:solidFill>
-                  <a:srgbClr val="E09E2F"/>
-                </a:solidFill>
-                <a:latin typeface="Menlo"/>
-              </a:rPr>
-              <a:t>CHECKPOINT · </a:t>
-            </a:r>
-            <a:r>
-              <a:rPr sz="1700" b="0" i="0">
+              <a:rPr sz="2400" b="1" i="0" dirty="0">
+                <a:solidFill>
+                  <a:srgbClr val="00B0F0"/>
+                </a:solidFill>
+                <a:latin typeface="Avenir Next"/>
+              </a:rPr>
+              <a:t>Universal approximation</a:t>
+            </a:r>
+            <a:r>
+              <a:rPr lang="en-US" sz="2400" b="1" i="0" dirty="0">
+                <a:solidFill>
+                  <a:srgbClr val="00B0F0"/>
+                </a:solidFill>
+                <a:latin typeface="Avenir Next"/>
+              </a:rPr>
+              <a:t> theorem</a:t>
+            </a:r>
+            <a:r>
+              <a:rPr sz="2400" b="0" i="0" dirty="0">
                 <a:solidFill>
                   <a:srgbClr val="3D444C"/>
                 </a:solidFill>
                 <a:latin typeface="Avenir Next"/>
               </a:rPr>
-              <a:t>Your turn → Quiz 1, Q3. Compute row 2's dot product and read the full output Wx. Worked answer in the notes.</a:t>
+              <a:t>, in one picture: add up </a:t>
+            </a:r>
+            <a:r>
+              <a:rPr sz="2400" b="0" i="0" dirty="0">
+                <a:solidFill>
+                  <a:srgbClr val="FF0000"/>
+                </a:solidFill>
+                <a:latin typeface="Avenir Next"/>
+              </a:rPr>
+              <a:t>enough</a:t>
+            </a:r>
+            <a:r>
+              <a:rPr sz="2400" b="0" i="0" dirty="0">
+                <a:solidFill>
+                  <a:srgbClr val="3D444C"/>
+                </a:solidFill>
+                <a:latin typeface="Avenir Next"/>
+              </a:rPr>
+              <a:t> </a:t>
+            </a:r>
+            <a:r>
+              <a:rPr lang="en-US" sz="2400" b="0" i="0" dirty="0">
+                <a:solidFill>
+                  <a:srgbClr val="3D444C"/>
+                </a:solidFill>
+                <a:latin typeface="Avenir Next"/>
+              </a:rPr>
+              <a:t>(multi-add-bend)</a:t>
+            </a:r>
+            <a:r>
+              <a:rPr sz="2400" b="0" i="0" dirty="0">
+                <a:solidFill>
+                  <a:srgbClr val="3D444C"/>
+                </a:solidFill>
+                <a:latin typeface="Avenir Next"/>
+              </a:rPr>
+              <a:t> pieces and the network approximates </a:t>
+            </a:r>
+            <a:r>
+              <a:rPr sz="2400" b="1" i="0" dirty="0">
+                <a:solidFill>
+                  <a:srgbClr val="3D444C"/>
+                </a:solidFill>
+                <a:latin typeface="Avenir Next"/>
+              </a:rPr>
+              <a:t>any shape</a:t>
+            </a:r>
+            <a:r>
+              <a:rPr sz="2400" b="0" i="0" dirty="0">
+                <a:solidFill>
+                  <a:srgbClr val="3D444C"/>
+                </a:solidFill>
+                <a:latin typeface="Avenir Next"/>
+              </a:rPr>
+              <a:t>. Depth and width buy you bends — that is the whole magic.</a:t>
             </a:r>
           </a:p>
         </p:txBody>
@@ -5804,6 +5699,129 @@
   <p:clrMapOvr>
     <a:masterClrMapping/>
   </p:clrMapOvr>
+  <p:timing>
+    <p:tnLst>
+      <p:par>
+        <p:cTn id="1" dur="indefinite" restart="never" nodeType="tmRoot">
+          <p:childTnLst>
+            <p:seq concurrent="1" nextAc="seek">
+              <p:cTn id="2" dur="indefinite" nodeType="mainSeq">
+                <p:childTnLst>
+                  <p:par>
+                    <p:cTn id="3" fill="hold">
+                      <p:stCondLst>
+                        <p:cond delay="indefinite"/>
+                      </p:stCondLst>
+                      <p:childTnLst>
+                        <p:par>
+                          <p:cTn id="4" fill="hold">
+                            <p:stCondLst>
+                              <p:cond delay="0"/>
+                            </p:stCondLst>
+                            <p:childTnLst>
+                              <p:par>
+                                <p:cTn id="5" presetID="1" presetClass="entr" presetSubtype="0" fill="hold" grpId="0" nodeType="clickEffect">
+                                  <p:stCondLst>
+                                    <p:cond delay="0"/>
+                                  </p:stCondLst>
+                                  <p:childTnLst>
+                                    <p:set>
+                                      <p:cBhvr>
+                                        <p:cTn id="6" dur="1" fill="hold">
+                                          <p:stCondLst>
+                                            <p:cond delay="0"/>
+                                          </p:stCondLst>
+                                        </p:cTn>
+                                        <p:tgtEl>
+                                          <p:spTgt spid="6"/>
+                                        </p:tgtEl>
+                                        <p:attrNameLst>
+                                          <p:attrName>style.visibility</p:attrName>
+                                        </p:attrNameLst>
+                                      </p:cBhvr>
+                                      <p:to>
+                                        <p:strVal val="visible"/>
+                                      </p:to>
+                                    </p:set>
+                                  </p:childTnLst>
+                                </p:cTn>
+                              </p:par>
+                            </p:childTnLst>
+                          </p:cTn>
+                        </p:par>
+                      </p:childTnLst>
+                    </p:cTn>
+                  </p:par>
+                  <p:par>
+                    <p:cTn id="7" fill="hold">
+                      <p:stCondLst>
+                        <p:cond delay="indefinite"/>
+                      </p:stCondLst>
+                      <p:childTnLst>
+                        <p:par>
+                          <p:cTn id="8" fill="hold">
+                            <p:stCondLst>
+                              <p:cond delay="0"/>
+                            </p:stCondLst>
+                            <p:childTnLst>
+                              <p:par>
+                                <p:cTn id="9" presetID="1" presetClass="entr" presetSubtype="0" fill="hold" nodeType="clickEffect">
+                                  <p:stCondLst>
+                                    <p:cond delay="0"/>
+                                  </p:stCondLst>
+                                  <p:childTnLst>
+                                    <p:set>
+                                      <p:cBhvr>
+                                        <p:cTn id="10" dur="1" fill="hold">
+                                          <p:stCondLst>
+                                            <p:cond delay="0"/>
+                                          </p:stCondLst>
+                                        </p:cTn>
+                                        <p:tgtEl>
+                                          <p:spTgt spid="5"/>
+                                        </p:tgtEl>
+                                        <p:attrNameLst>
+                                          <p:attrName>style.visibility</p:attrName>
+                                        </p:attrNameLst>
+                                      </p:cBhvr>
+                                      <p:to>
+                                        <p:strVal val="visible"/>
+                                      </p:to>
+                                    </p:set>
+                                  </p:childTnLst>
+                                </p:cTn>
+                              </p:par>
+                            </p:childTnLst>
+                          </p:cTn>
+                        </p:par>
+                      </p:childTnLst>
+                    </p:cTn>
+                  </p:par>
+                </p:childTnLst>
+              </p:cTn>
+              <p:prevCondLst>
+                <p:cond evt="onPrev" delay="0">
+                  <p:tgtEl>
+                    <p:sldTgt/>
+                  </p:tgtEl>
+                </p:cond>
+              </p:prevCondLst>
+              <p:nextCondLst>
+                <p:cond evt="onNext" delay="0">
+                  <p:tgtEl>
+                    <p:sldTgt/>
+                  </p:tgtEl>
+                </p:cond>
+              </p:nextCondLst>
+            </p:seq>
+          </p:childTnLst>
+        </p:cTn>
+      </p:par>
+    </p:tnLst>
+    <p:bldLst>
+      <p:bldP spid="6" grpId="0" animBg="1"/>
+    </p:bldLst>
+  </p:timing>
 </p:sld>
 </file>
 
@@ -5898,7 +5916,7 @@
                 </a:solidFill>
                 <a:latin typeface="Menlo"/>
               </a:rPr>
-              <a:t>WHY THE BEND MATTERS · THE BIG PICTURE</a:t>
+              <a:t>STACKING · ONE LAYER FEEDS THE NEXT (I-DO)</a:t>
             </a:r>
           </a:p>
         </p:txBody>
@@ -5912,7 +5930,7 @@
         <p:spPr>
           <a:xfrm>
             <a:off x="548640" y="731520"/>
-            <a:ext cx="11064240" cy="615553"/>
+            <a:ext cx="11064240" cy="1127760"/>
           </a:xfrm>
           <a:prstGeom prst="rect">
             <a:avLst/>
@@ -5926,38 +5944,20 @@
           <a:lstStyle/>
           <a:p>
             <a:r>
-              <a:rPr sz="3400" b="1" i="0" dirty="0">
+              <a:rPr sz="3400" b="1" i="0">
                 <a:solidFill>
                   <a:srgbClr val="1B2025"/>
                 </a:solidFill>
                 <a:latin typeface="Avenir Next"/>
               </a:rPr>
-              <a:t>Enough </a:t>
-            </a:r>
-            <a:r>
-              <a:rPr lang="en-US" sz="3400" b="1" i="0" dirty="0">
-                <a:solidFill>
-                  <a:srgbClr val="1B2025"/>
-                </a:solidFill>
-                <a:latin typeface="Avenir Next"/>
-              </a:rPr>
-              <a:t>”layers”</a:t>
-            </a:r>
-            <a:r>
-              <a:rPr sz="3400" b="1" i="0" dirty="0">
-                <a:solidFill>
-                  <a:srgbClr val="1B2025"/>
-                </a:solidFill>
-                <a:latin typeface="Avenir Next"/>
-              </a:rPr>
-              <a:t> can trace ANY curve</a:t>
+              <a:t>Deep = repeat the move, feeding each layer the last</a:t>
             </a:r>
           </a:p>
         </p:txBody>
       </p:sp>
       <p:pic>
         <p:nvPicPr>
-          <p:cNvPr id="5" name="Picture 4" descr="fig_universal_approx.png"/>
+          <p:cNvPr id="5" name="Picture 4" descr="fig_twolayer_ido.png"/>
           <p:cNvPicPr>
             <a:picLocks noChangeAspect="1"/>
           </p:cNvPicPr>
@@ -5971,8 +5971,8 @@
         </p:blipFill>
         <p:spPr>
           <a:xfrm>
-            <a:off x="3016941" y="3337560"/>
-            <a:ext cx="6036197" cy="3200400"/>
+            <a:off x="2814598" y="1828800"/>
+            <a:ext cx="6532323" cy="3200400"/>
           </a:xfrm>
           <a:prstGeom prst="rect">
             <a:avLst/>
@@ -5987,8 +5987,8 @@
         </p:nvSpPr>
         <p:spPr>
           <a:xfrm>
-            <a:off x="672207" y="1558804"/>
-            <a:ext cx="10515600" cy="1572768"/>
+            <a:off x="548640" y="5120640"/>
+            <a:ext cx="10515600" cy="914400"/>
           </a:xfrm>
           <a:prstGeom prst="rect">
             <a:avLst/>
@@ -6023,89 +6023,134 @@
           <a:p>
             <a:pPr algn="ctr"/>
             <a:r>
-              <a:rPr sz="2400" b="1" i="0" dirty="0">
-                <a:solidFill>
-                  <a:srgbClr val="00B0F0"/>
-                </a:solidFill>
-                <a:latin typeface="Avenir Next"/>
-              </a:rPr>
-              <a:t>Universal approximation</a:t>
-            </a:r>
-            <a:r>
-              <a:rPr lang="en-US" sz="2400" b="1" i="0" dirty="0">
-                <a:solidFill>
-                  <a:srgbClr val="00B0F0"/>
-                </a:solidFill>
-                <a:latin typeface="Avenir Next"/>
-              </a:rPr>
-              <a:t> theorem</a:t>
-            </a:r>
-            <a:r>
-              <a:rPr sz="2400" b="0" i="0" dirty="0">
+              <a:rPr sz="1700" b="0" i="0">
                 <a:solidFill>
                   <a:srgbClr val="3D444C"/>
                 </a:solidFill>
                 <a:latin typeface="Avenir Next"/>
               </a:rPr>
-              <a:t>, in one picture: add up </a:t>
-            </a:r>
-            <a:r>
-              <a:rPr sz="2400" b="0" i="0" dirty="0">
-                <a:solidFill>
-                  <a:srgbClr val="FF0000"/>
-                </a:solidFill>
-                <a:latin typeface="Avenir Next"/>
-              </a:rPr>
-              <a:t>enough</a:t>
-            </a:r>
-            <a:r>
-              <a:rPr sz="2400" b="0" i="0" dirty="0">
-                <a:solidFill>
-                  <a:srgbClr val="3D444C"/>
-                </a:solidFill>
-                <a:latin typeface="Avenir Next"/>
-              </a:rPr>
-              <a:t> </a:t>
-            </a:r>
-            <a:r>
-              <a:rPr lang="en-US" sz="2400" b="0" i="0" dirty="0">
-                <a:solidFill>
-                  <a:srgbClr val="3D444C"/>
-                </a:solidFill>
-                <a:latin typeface="Avenir Next"/>
-              </a:rPr>
-              <a:t>(multi-add-bend)</a:t>
-            </a:r>
-            <a:r>
-              <a:rPr sz="2400" b="0" i="0" dirty="0">
-                <a:solidFill>
-                  <a:srgbClr val="3D444C"/>
-                </a:solidFill>
-                <a:latin typeface="Avenir Next"/>
-              </a:rPr>
-              <a:t> pieces and the network approximates </a:t>
-            </a:r>
-            <a:r>
-              <a:rPr sz="2400" b="1" i="0" dirty="0">
-                <a:solidFill>
-                  <a:srgbClr val="3D444C"/>
-                </a:solidFill>
-                <a:latin typeface="Avenir Next"/>
-              </a:rPr>
-              <a:t>any shape</a:t>
-            </a:r>
-            <a:r>
-              <a:rPr sz="2400" b="0" i="0" dirty="0">
-                <a:solidFill>
-                  <a:srgbClr val="3D444C"/>
-                </a:solidFill>
-                <a:latin typeface="Avenir Next"/>
-              </a:rPr>
-              <a:t>. Depth and width buy you bends — that is the whole magic.</a:t>
-            </a:r>
-          </a:p>
-        </p:txBody>
-      </p:sp>
+              <a:t>A layer's output is the next layer's input — stack it and you have depth.</a:t>
+            </a:r>
+          </a:p>
+        </p:txBody>
+      </p:sp>
+      <p:pic>
+        <p:nvPicPr>
+          <p:cNvPr id="7" name="Picture 6">
+            <a:extLst>
+              <a:ext uri="{FF2B5EF4-FFF2-40B4-BE49-F238E27FC236}">
+                <a16:creationId xmlns:a16="http://schemas.microsoft.com/office/drawing/2014/main" id="{55440B74-926C-470A-217F-401D3736D9FB}"/>
+              </a:ext>
+            </a:extLst>
+          </p:cNvPr>
+          <p:cNvPicPr>
+            <a:picLocks noChangeAspect="1"/>
+          </p:cNvPicPr>
+          <p:nvPr/>
+        </p:nvPicPr>
+        <p:blipFill>
+          <a:blip r:embed="rId4"/>
+          <a:stretch>
+            <a:fillRect/>
+          </a:stretch>
+        </p:blipFill>
+        <p:spPr>
+          <a:xfrm>
+            <a:off x="193031" y="1914144"/>
+            <a:ext cx="2566703" cy="1309950"/>
+          </a:xfrm>
+          <a:prstGeom prst="rect">
+            <a:avLst/>
+          </a:prstGeom>
+          <a:ln>
+            <a:solidFill>
+              <a:schemeClr val="tx1"/>
+            </a:solidFill>
+          </a:ln>
+        </p:spPr>
+      </p:pic>
+      <p:cxnSp>
+        <p:nvCxnSpPr>
+          <p:cNvPr id="9" name="Straight Arrow Connector 8">
+            <a:extLst>
+              <a:ext uri="{FF2B5EF4-FFF2-40B4-BE49-F238E27FC236}">
+                <a16:creationId xmlns:a16="http://schemas.microsoft.com/office/drawing/2014/main" id="{A133478A-F178-AEAA-2ABD-A97DDF9BBB63}"/>
+              </a:ext>
+            </a:extLst>
+          </p:cNvPr>
+          <p:cNvCxnSpPr>
+            <a:cxnSpLocks/>
+          </p:cNvCxnSpPr>
+          <p:nvPr/>
+        </p:nvCxnSpPr>
+        <p:spPr>
+          <a:xfrm>
+            <a:off x="2582562" y="2384854"/>
+            <a:ext cx="1062681" cy="370703"/>
+          </a:xfrm>
+          <a:prstGeom prst="straightConnector1">
+            <a:avLst/>
+          </a:prstGeom>
+          <a:ln>
+            <a:tailEnd type="triangle"/>
+          </a:ln>
+        </p:spPr>
+        <p:style>
+          <a:lnRef idx="2">
+            <a:schemeClr val="accent1"/>
+          </a:lnRef>
+          <a:fillRef idx="0">
+            <a:schemeClr val="accent1"/>
+          </a:fillRef>
+          <a:effectRef idx="1">
+            <a:schemeClr val="accent1"/>
+          </a:effectRef>
+          <a:fontRef idx="minor">
+            <a:schemeClr val="tx1"/>
+          </a:fontRef>
+        </p:style>
+      </p:cxnSp>
+      <p:cxnSp>
+        <p:nvCxnSpPr>
+          <p:cNvPr id="10" name="Straight Arrow Connector 9">
+            <a:extLst>
+              <a:ext uri="{FF2B5EF4-FFF2-40B4-BE49-F238E27FC236}">
+                <a16:creationId xmlns:a16="http://schemas.microsoft.com/office/drawing/2014/main" id="{B4E46198-F4D5-2873-2D20-5EB142DD6950}"/>
+              </a:ext>
+            </a:extLst>
+          </p:cNvPr>
+          <p:cNvCxnSpPr>
+            <a:cxnSpLocks/>
+          </p:cNvCxnSpPr>
+          <p:nvPr/>
+        </p:nvCxnSpPr>
+        <p:spPr>
+          <a:xfrm>
+            <a:off x="2582562" y="2755557"/>
+            <a:ext cx="1062681" cy="1287985"/>
+          </a:xfrm>
+          <a:prstGeom prst="straightConnector1">
+            <a:avLst/>
+          </a:prstGeom>
+          <a:ln>
+            <a:tailEnd type="triangle"/>
+          </a:ln>
+        </p:spPr>
+        <p:style>
+          <a:lnRef idx="2">
+            <a:schemeClr val="accent1"/>
+          </a:lnRef>
+          <a:fillRef idx="0">
+            <a:schemeClr val="accent1"/>
+          </a:fillRef>
+          <a:effectRef idx="1">
+            <a:schemeClr val="accent1"/>
+          </a:effectRef>
+          <a:fontRef idx="minor">
+            <a:schemeClr val="tx1"/>
+          </a:fontRef>
+        </p:style>
+      </p:cxnSp>
     </p:spTree>
   </p:cSld>
   <p:clrMapOvr>
@@ -6792,7 +6837,7 @@
                 </a:solidFill>
                 <a:latin typeface="Menlo"/>
               </a:rPr>
-              <a:t>STACKING · ONE LAYER FEEDS THE NEXT (I-DO)</a:t>
+              <a:t>STACKING · YOUR TURN, TWO LAYERS (YOU-DO)</a:t>
             </a:r>
           </a:p>
         </p:txBody>
@@ -6806,7 +6851,7 @@
         <p:spPr>
           <a:xfrm>
             <a:off x="548640" y="731520"/>
-            <a:ext cx="11064240" cy="1127760"/>
+            <a:ext cx="11064240" cy="1005840"/>
           </a:xfrm>
           <a:prstGeom prst="rect">
             <a:avLst/>
@@ -6826,14 +6871,14 @@
                 </a:solidFill>
                 <a:latin typeface="Avenir Next"/>
               </a:rPr>
-              <a:t>Deep = repeat the move, feeding each layer the last</a:t>
+              <a:t>Your two-layer pass — compute it</a:t>
             </a:r>
           </a:p>
         </p:txBody>
       </p:sp>
       <p:pic>
         <p:nvPicPr>
-          <p:cNvPr id="5" name="Picture 4" descr="fig_twolayer_ido.png"/>
+          <p:cNvPr id="5" name="Picture 4" descr="fig_twolayer_youdo.png"/>
           <p:cNvPicPr>
             <a:picLocks noChangeAspect="1"/>
           </p:cNvPicPr>
@@ -6874,7 +6919,7 @@
           </a:solidFill>
           <a:ln w="12700">
             <a:solidFill>
-              <a:srgbClr val="3D444C"/>
+              <a:srgbClr val="E09E2F"/>
             </a:solidFill>
           </a:ln>
           <a:effectLst/>
@@ -6899,132 +6944,26 @@
           <a:p>
             <a:pPr algn="ctr"/>
             <a:r>
+              <a:rPr sz="1200" b="1" i="0">
+                <a:solidFill>
+                  <a:srgbClr val="E09E2F"/>
+                </a:solidFill>
+                <a:latin typeface="Menlo"/>
+              </a:rPr>
+              <a:t>CHECKPOINT · </a:t>
+            </a:r>
+            <a:r>
               <a:rPr sz="1700" b="0" i="0">
                 <a:solidFill>
                   <a:srgbClr val="3D444C"/>
                 </a:solidFill>
                 <a:latin typeface="Avenir Next"/>
               </a:rPr>
-              <a:t>A layer's output is the next layer's input — stack it and you have depth.</a:t>
-            </a:r>
-          </a:p>
-        </p:txBody>
-      </p:sp>
-      <p:pic>
-        <p:nvPicPr>
-          <p:cNvPr id="7" name="Picture 6">
-            <a:extLst>
-              <a:ext uri="{FF2B5EF4-FFF2-40B4-BE49-F238E27FC236}">
-                <a16:creationId xmlns:a16="http://schemas.microsoft.com/office/drawing/2014/main" id="{55440B74-926C-470A-217F-401D3736D9FB}"/>
-              </a:ext>
-            </a:extLst>
-          </p:cNvPr>
-          <p:cNvPicPr>
-            <a:picLocks noChangeAspect="1"/>
-          </p:cNvPicPr>
-          <p:nvPr/>
-        </p:nvPicPr>
-        <p:blipFill>
-          <a:blip r:embed="rId4"/>
-          <a:stretch>
-            <a:fillRect/>
-          </a:stretch>
-        </p:blipFill>
-        <p:spPr>
-          <a:xfrm>
-            <a:off x="193031" y="1914144"/>
-            <a:ext cx="2566703" cy="1309950"/>
-          </a:xfrm>
-          <a:prstGeom prst="rect">
-            <a:avLst/>
-          </a:prstGeom>
-          <a:ln>
-            <a:solidFill>
-              <a:schemeClr val="tx1"/>
-            </a:solidFill>
-          </a:ln>
-        </p:spPr>
-      </p:pic>
-      <p:cxnSp>
-        <p:nvCxnSpPr>
-          <p:cNvPr id="9" name="Straight Arrow Connector 8">
-            <a:extLst>
-              <a:ext uri="{FF2B5EF4-FFF2-40B4-BE49-F238E27FC236}">
-                <a16:creationId xmlns:a16="http://schemas.microsoft.com/office/drawing/2014/main" id="{A133478A-F178-AEAA-2ABD-A97DDF9BBB63}"/>
-              </a:ext>
-            </a:extLst>
-          </p:cNvPr>
-          <p:cNvCxnSpPr/>
-          <p:nvPr/>
-        </p:nvCxnSpPr>
-        <p:spPr>
-          <a:xfrm>
-            <a:off x="2814598" y="2125362"/>
-            <a:ext cx="830645" cy="630195"/>
-          </a:xfrm>
-          <a:prstGeom prst="straightConnector1">
-            <a:avLst/>
-          </a:prstGeom>
-          <a:ln>
-            <a:tailEnd type="triangle"/>
-          </a:ln>
-        </p:spPr>
-        <p:style>
-          <a:lnRef idx="2">
-            <a:schemeClr val="accent1"/>
-          </a:lnRef>
-          <a:fillRef idx="0">
-            <a:schemeClr val="accent1"/>
-          </a:fillRef>
-          <a:effectRef idx="1">
-            <a:schemeClr val="accent1"/>
-          </a:effectRef>
-          <a:fontRef idx="minor">
-            <a:schemeClr val="tx1"/>
-          </a:fontRef>
-        </p:style>
-      </p:cxnSp>
-      <p:cxnSp>
-        <p:nvCxnSpPr>
-          <p:cNvPr id="10" name="Straight Arrow Connector 9">
-            <a:extLst>
-              <a:ext uri="{FF2B5EF4-FFF2-40B4-BE49-F238E27FC236}">
-                <a16:creationId xmlns:a16="http://schemas.microsoft.com/office/drawing/2014/main" id="{B4E46198-F4D5-2873-2D20-5EB142DD6950}"/>
-              </a:ext>
-            </a:extLst>
-          </p:cNvPr>
-          <p:cNvCxnSpPr>
-            <a:cxnSpLocks/>
-          </p:cNvCxnSpPr>
-          <p:nvPr/>
-        </p:nvCxnSpPr>
-        <p:spPr>
-          <a:xfrm>
-            <a:off x="2707506" y="2498947"/>
-            <a:ext cx="937737" cy="1544595"/>
-          </a:xfrm>
-          <a:prstGeom prst="straightConnector1">
-            <a:avLst/>
-          </a:prstGeom>
-          <a:ln>
-            <a:tailEnd type="triangle"/>
-          </a:ln>
-        </p:spPr>
-        <p:style>
-          <a:lnRef idx="2">
-            <a:schemeClr val="accent1"/>
-          </a:lnRef>
-          <a:fillRef idx="0">
-            <a:schemeClr val="accent1"/>
-          </a:fillRef>
-          <a:effectRef idx="1">
-            <a:schemeClr val="accent1"/>
-          </a:effectRef>
-          <a:fontRef idx="minor">
-            <a:schemeClr val="tx1"/>
-          </a:fontRef>
-        </p:style>
-      </p:cxnSp>
+              <a:t>Your turn → Quiz 1, Q6. Run layer 1 (W₁x + b₁, then ReLU) for the hidden vector, then layer 2 for y. Worked answer in the notes.</a:t>
+            </a:r>
+          </a:p>
+        </p:txBody>
+      </p:sp>
     </p:spTree>
   </p:cSld>
   <p:clrMapOvr>
@@ -7124,7 +7063,7 @@
                 </a:solidFill>
                 <a:latin typeface="Menlo"/>
               </a:rPr>
-              <a:t>STACKING · YOUR TURN, TWO LAYERS (YOU-DO)</a:t>
+              <a:t>STACKING · WHY GO DEEP</a:t>
             </a:r>
           </a:p>
         </p:txBody>
@@ -7158,14 +7097,14 @@
                 </a:solidFill>
                 <a:latin typeface="Avenir Next"/>
               </a:rPr>
-              <a:t>Your two-layer pass — compute it</a:t>
+              <a:t>Depth = a hierarchy of features</a:t>
             </a:r>
           </a:p>
         </p:txBody>
       </p:sp>
       <p:pic>
         <p:nvPicPr>
-          <p:cNvPr id="5" name="Picture 4" descr="fig_twolayer_youdo.png"/>
+          <p:cNvPr id="5" name="Picture 4" descr="cat_hierarchy.png"/>
           <p:cNvPicPr>
             <a:picLocks noChangeAspect="1"/>
           </p:cNvPicPr>
@@ -7179,8 +7118,8 @@
         </p:blipFill>
         <p:spPr>
           <a:xfrm>
-            <a:off x="2814598" y="1828800"/>
-            <a:ext cx="6532323" cy="3200400"/>
+            <a:off x="986790" y="1828800"/>
+            <a:ext cx="10187940" cy="3200400"/>
           </a:xfrm>
           <a:prstGeom prst="rect">
             <a:avLst/>
@@ -7189,13 +7128,48 @@
       </p:pic>
       <p:sp>
         <p:nvSpPr>
-          <p:cNvPr id="6" name="Rectangle 5"/>
+          <p:cNvPr id="6" name="TextBox 5"/>
+          <p:cNvSpPr txBox="1"/>
+          <p:nvPr/>
+        </p:nvSpPr>
+        <p:spPr>
+          <a:xfrm>
+            <a:off x="548640" y="5084064"/>
+            <a:ext cx="11064240" cy="411480"/>
+          </a:xfrm>
+          <a:prstGeom prst="rect">
+            <a:avLst/>
+          </a:prstGeom>
+          <a:noFill/>
+        </p:spPr>
+        <p:txBody>
+          <a:bodyPr wrap="square" anchor="t">
+            <a:spAutoFit/>
+          </a:bodyPr>
+          <a:lstStyle/>
+          <a:p>
+            <a:pPr algn="ctr"/>
+            <a:r>
+              <a:rPr sz="1200" b="0" i="1">
+                <a:solidFill>
+                  <a:srgbClr val="8A9099"/>
+                </a:solidFill>
+                <a:latin typeface="Avenir Next"/>
+              </a:rPr>
+              <a:t>one photo, abstracted further at each layer · cat: Alvesgaspar, Wikimedia Commons, CC BY-SA 3.0</a:t>
+            </a:r>
+          </a:p>
+        </p:txBody>
+      </p:sp>
+      <p:sp>
+        <p:nvSpPr>
+          <p:cNvPr id="7" name="Rectangle 6"/>
           <p:cNvSpPr/>
           <p:nvPr/>
         </p:nvSpPr>
         <p:spPr>
           <a:xfrm>
-            <a:off x="548640" y="5120640"/>
+            <a:off x="548640" y="5586984"/>
             <a:ext cx="10515600" cy="914400"/>
           </a:xfrm>
           <a:prstGeom prst="rect">
@@ -7206,7 +7180,7 @@
           </a:solidFill>
           <a:ln w="12700">
             <a:solidFill>
-              <a:srgbClr val="E09E2F"/>
+              <a:srgbClr val="3D444C"/>
             </a:solidFill>
           </a:ln>
           <a:effectLst/>
@@ -7231,22 +7205,13 @@
           <a:p>
             <a:pPr algn="ctr"/>
             <a:r>
-              <a:rPr sz="1200" b="1" i="0">
-                <a:solidFill>
-                  <a:srgbClr val="E09E2F"/>
-                </a:solidFill>
-                <a:latin typeface="Menlo"/>
-              </a:rPr>
-              <a:t>CHECKPOINT · </a:t>
-            </a:r>
-            <a:r>
-              <a:rPr sz="1700" b="0" i="0">
+              <a:rPr sz="1700" b="0" i="0" dirty="0">
                 <a:solidFill>
                   <a:srgbClr val="3D444C"/>
                 </a:solidFill>
                 <a:latin typeface="Avenir Next"/>
               </a:rPr>
-              <a:t>Your turn → Quiz 1, Q6. Run layer 1 (W₁x + b₁, then ReLU) for the hidden vector, then layer 2 for y. Worked answer in the notes.</a:t>
+              <a:t>No one told it to look at edges first — it LEARNED that edges build into parts, and parts into whole objects. That is why 'deep.'</a:t>
             </a:r>
           </a:p>
         </p:txBody>
@@ -7350,519 +7315,6 @@
                 </a:solidFill>
                 <a:latin typeface="Menlo"/>
               </a:rPr>
-              <a:t>STACKING · WHY GO DEEP</a:t>
-            </a:r>
-          </a:p>
-        </p:txBody>
-      </p:sp>
-      <p:sp>
-        <p:nvSpPr>
-          <p:cNvPr id="4" name="TextBox 3"/>
-          <p:cNvSpPr txBox="1"/>
-          <p:nvPr/>
-        </p:nvSpPr>
-        <p:spPr>
-          <a:xfrm>
-            <a:off x="548640" y="731520"/>
-            <a:ext cx="11064240" cy="1005840"/>
-          </a:xfrm>
-          <a:prstGeom prst="rect">
-            <a:avLst/>
-          </a:prstGeom>
-          <a:noFill/>
-        </p:spPr>
-        <p:txBody>
-          <a:bodyPr wrap="square" anchor="t">
-            <a:spAutoFit/>
-          </a:bodyPr>
-          <a:lstStyle/>
-          <a:p>
-            <a:r>
-              <a:rPr sz="3400" b="1" i="0">
-                <a:solidFill>
-                  <a:srgbClr val="1B2025"/>
-                </a:solidFill>
-                <a:latin typeface="Avenir Next"/>
-              </a:rPr>
-              <a:t>Depth = a hierarchy of features</a:t>
-            </a:r>
-          </a:p>
-        </p:txBody>
-      </p:sp>
-      <p:pic>
-        <p:nvPicPr>
-          <p:cNvPr id="5" name="Picture 4" descr="cat_hierarchy.png"/>
-          <p:cNvPicPr>
-            <a:picLocks noChangeAspect="1"/>
-          </p:cNvPicPr>
-          <p:nvPr/>
-        </p:nvPicPr>
-        <p:blipFill>
-          <a:blip r:embed="rId3"/>
-          <a:stretch>
-            <a:fillRect/>
-          </a:stretch>
-        </p:blipFill>
-        <p:spPr>
-          <a:xfrm>
-            <a:off x="986790" y="1828800"/>
-            <a:ext cx="10187940" cy="3200400"/>
-          </a:xfrm>
-          <a:prstGeom prst="rect">
-            <a:avLst/>
-          </a:prstGeom>
-        </p:spPr>
-      </p:pic>
-      <p:sp>
-        <p:nvSpPr>
-          <p:cNvPr id="6" name="TextBox 5"/>
-          <p:cNvSpPr txBox="1"/>
-          <p:nvPr/>
-        </p:nvSpPr>
-        <p:spPr>
-          <a:xfrm>
-            <a:off x="548640" y="5084064"/>
-            <a:ext cx="11064240" cy="411480"/>
-          </a:xfrm>
-          <a:prstGeom prst="rect">
-            <a:avLst/>
-          </a:prstGeom>
-          <a:noFill/>
-        </p:spPr>
-        <p:txBody>
-          <a:bodyPr wrap="square" anchor="t">
-            <a:spAutoFit/>
-          </a:bodyPr>
-          <a:lstStyle/>
-          <a:p>
-            <a:pPr algn="ctr"/>
-            <a:r>
-              <a:rPr sz="1200" b="0" i="1">
-                <a:solidFill>
-                  <a:srgbClr val="8A9099"/>
-                </a:solidFill>
-                <a:latin typeface="Avenir Next"/>
-              </a:rPr>
-              <a:t>one photo, abstracted further at each layer · cat: Alvesgaspar, Wikimedia Commons, CC BY-SA 3.0</a:t>
-            </a:r>
-          </a:p>
-        </p:txBody>
-      </p:sp>
-      <p:sp>
-        <p:nvSpPr>
-          <p:cNvPr id="7" name="Rectangle 6"/>
-          <p:cNvSpPr/>
-          <p:nvPr/>
-        </p:nvSpPr>
-        <p:spPr>
-          <a:xfrm>
-            <a:off x="548640" y="5586984"/>
-            <a:ext cx="10515600" cy="914400"/>
-          </a:xfrm>
-          <a:prstGeom prst="rect">
-            <a:avLst/>
-          </a:prstGeom>
-          <a:solidFill>
-            <a:srgbClr val="F1F1EC"/>
-          </a:solidFill>
-          <a:ln w="12700">
-            <a:solidFill>
-              <a:srgbClr val="3D444C"/>
-            </a:solidFill>
-          </a:ln>
-          <a:effectLst/>
-        </p:spPr>
-        <p:style>
-          <a:lnRef idx="1">
-            <a:schemeClr val="accent1"/>
-          </a:lnRef>
-          <a:fillRef idx="3">
-            <a:schemeClr val="accent1"/>
-          </a:fillRef>
-          <a:effectRef idx="2">
-            <a:schemeClr val="accent1"/>
-          </a:effectRef>
-          <a:fontRef idx="minor">
-            <a:schemeClr val="lt1"/>
-          </a:fontRef>
-        </p:style>
-        <p:txBody>
-          <a:bodyPr wrap="square" lIns="182880" rIns="182880" rtlCol="0" anchor="ctr"/>
-          <a:lstStyle/>
-          <a:p>
-            <a:pPr algn="ctr"/>
-            <a:r>
-              <a:rPr sz="1700" b="0" i="0" dirty="0">
-                <a:solidFill>
-                  <a:srgbClr val="3D444C"/>
-                </a:solidFill>
-                <a:latin typeface="Avenir Next"/>
-              </a:rPr>
-              <a:t>No one told it to look at edges first — it LEARNED that edges build into parts, and parts into whole objects. That is why 'deep.'</a:t>
-            </a:r>
-          </a:p>
-        </p:txBody>
-      </p:sp>
-    </p:spTree>
-  </p:cSld>
-  <p:clrMapOvr>
-    <a:masterClrMapping/>
-  </p:clrMapOvr>
-</p:sld>
-</file>
-
-<file path=ppt/slides/slide23.xml><?xml version="1.0" encoding="utf-8"?>
-<p:sld xmlns:a="http://schemas.openxmlformats.org/drawingml/2006/main" xmlns:r="http://schemas.openxmlformats.org/officeDocument/2006/relationships" xmlns:p="http://schemas.openxmlformats.org/presentationml/2006/main">
-  <p:cSld>
-    <p:spTree>
-      <p:nvGrpSpPr>
-        <p:cNvPr id="1" name=""/>
-        <p:cNvGrpSpPr/>
-        <p:nvPr/>
-      </p:nvGrpSpPr>
-      <p:grpSpPr>
-        <a:xfrm>
-          <a:off x="0" y="0"/>
-          <a:ext cx="0" cy="0"/>
-          <a:chOff x="0" y="0"/>
-          <a:chExt cx="0" cy="0"/>
-        </a:xfrm>
-      </p:grpSpPr>
-      <p:sp>
-        <p:nvSpPr>
-          <p:cNvPr id="2" name="Rectangle 1"/>
-          <p:cNvSpPr/>
-          <p:nvPr/>
-        </p:nvSpPr>
-        <p:spPr>
-          <a:xfrm>
-            <a:off x="0" y="0"/>
-            <a:ext cx="12191695" cy="6858000"/>
-          </a:xfrm>
-          <a:prstGeom prst="rect">
-            <a:avLst/>
-          </a:prstGeom>
-          <a:solidFill>
-            <a:srgbClr val="FBFBF8"/>
-          </a:solidFill>
-          <a:ln>
-            <a:noFill/>
-          </a:ln>
-          <a:effectLst/>
-        </p:spPr>
-        <p:style>
-          <a:lnRef idx="1">
-            <a:schemeClr val="accent1"/>
-          </a:lnRef>
-          <a:fillRef idx="3">
-            <a:schemeClr val="accent1"/>
-          </a:fillRef>
-          <a:effectRef idx="2">
-            <a:schemeClr val="accent1"/>
-          </a:effectRef>
-          <a:fontRef idx="minor">
-            <a:schemeClr val="lt1"/>
-          </a:fontRef>
-        </p:style>
-        <p:txBody>
-          <a:bodyPr rtlCol="0" anchor="ctr"/>
-          <a:lstStyle/>
-          <a:p>
-            <a:pPr algn="ctr"/>
-            <a:endParaRPr/>
-          </a:p>
-        </p:txBody>
-      </p:sp>
-      <p:sp>
-        <p:nvSpPr>
-          <p:cNvPr id="3" name="TextBox 2"/>
-          <p:cNvSpPr txBox="1"/>
-          <p:nvPr/>
-        </p:nvSpPr>
-        <p:spPr>
-          <a:xfrm>
-            <a:off x="548640" y="320040"/>
-            <a:ext cx="10972800" cy="365760"/>
-          </a:xfrm>
-          <a:prstGeom prst="rect">
-            <a:avLst/>
-          </a:prstGeom>
-          <a:noFill/>
-        </p:spPr>
-        <p:txBody>
-          <a:bodyPr wrap="square" anchor="t">
-            <a:spAutoFit/>
-          </a:bodyPr>
-          <a:lstStyle/>
-          <a:p>
-            <a:r>
-              <a:rPr sz="1300" b="1" i="0">
-                <a:solidFill>
-                  <a:srgbClr val="8A9099"/>
-                </a:solidFill>
-                <a:latin typeface="Menlo"/>
-              </a:rPr>
-              <a:t>MASS SPEC ANCHOR · YOUR DATA WORKS THE SAME WAY</a:t>
-            </a:r>
-          </a:p>
-        </p:txBody>
-      </p:sp>
-      <p:sp>
-        <p:nvSpPr>
-          <p:cNvPr id="4" name="TextBox 3"/>
-          <p:cNvSpPr txBox="1"/>
-          <p:nvPr/>
-        </p:nvSpPr>
-        <p:spPr>
-          <a:xfrm>
-            <a:off x="548640" y="731520"/>
-            <a:ext cx="11064240" cy="1005840"/>
-          </a:xfrm>
-          <a:prstGeom prst="rect">
-            <a:avLst/>
-          </a:prstGeom>
-          <a:noFill/>
-        </p:spPr>
-        <p:txBody>
-          <a:bodyPr wrap="square" anchor="t">
-            <a:spAutoFit/>
-          </a:bodyPr>
-          <a:lstStyle/>
-          <a:p>
-            <a:r>
-              <a:rPr sz="3400" b="1" i="0">
-                <a:solidFill>
-                  <a:srgbClr val="1B2025"/>
-                </a:solidFill>
-                <a:latin typeface="Avenir Next"/>
-              </a:rPr>
-              <a:t>The same hierarchy on a real spectrum</a:t>
-            </a:r>
-          </a:p>
-        </p:txBody>
-      </p:sp>
-      <p:pic>
-        <p:nvPicPr>
-          <p:cNvPr id="5" name="Picture 4" descr="fig_driams_mrsa.png"/>
-          <p:cNvPicPr>
-            <a:picLocks noChangeAspect="1"/>
-          </p:cNvPicPr>
-          <p:nvPr/>
-        </p:nvPicPr>
-        <p:blipFill>
-          <a:blip r:embed="rId3"/>
-          <a:stretch>
-            <a:fillRect/>
-          </a:stretch>
-        </p:blipFill>
-        <p:spPr>
-          <a:xfrm>
-            <a:off x="2611939" y="1828800"/>
-            <a:ext cx="6937641" cy="3200400"/>
-          </a:xfrm>
-          <a:prstGeom prst="rect">
-            <a:avLst/>
-          </a:prstGeom>
-        </p:spPr>
-      </p:pic>
-      <p:sp>
-        <p:nvSpPr>
-          <p:cNvPr id="6" name="TextBox 5"/>
-          <p:cNvSpPr txBox="1"/>
-          <p:nvPr/>
-        </p:nvSpPr>
-        <p:spPr>
-          <a:xfrm>
-            <a:off x="548640" y="5084064"/>
-            <a:ext cx="11064240" cy="411480"/>
-          </a:xfrm>
-          <a:prstGeom prst="rect">
-            <a:avLst/>
-          </a:prstGeom>
-          <a:noFill/>
-        </p:spPr>
-        <p:txBody>
-          <a:bodyPr wrap="square" anchor="t">
-            <a:spAutoFit/>
-          </a:bodyPr>
-          <a:lstStyle/>
-          <a:p>
-            <a:pPr algn="ctr"/>
-            <a:r>
-              <a:rPr sz="1200" b="0" i="1">
-                <a:solidFill>
-                  <a:srgbClr val="8A9099"/>
-                </a:solidFill>
-                <a:latin typeface="Avenir Next"/>
-              </a:rPr>
-              <a:t>real clinical MALDI-TOF spectrum · S. aureus + oxacillin (MRSA) · DRIAMS, Dryad doi:10.5061/dryad.bzkh1899q, CC0</a:t>
-            </a:r>
-          </a:p>
-        </p:txBody>
-      </p:sp>
-      <p:sp>
-        <p:nvSpPr>
-          <p:cNvPr id="7" name="Rectangle 6"/>
-          <p:cNvSpPr/>
-          <p:nvPr/>
-        </p:nvSpPr>
-        <p:spPr>
-          <a:xfrm>
-            <a:off x="548640" y="5586984"/>
-            <a:ext cx="10515600" cy="923544"/>
-          </a:xfrm>
-          <a:prstGeom prst="rect">
-            <a:avLst/>
-          </a:prstGeom>
-          <a:solidFill>
-            <a:srgbClr val="E3F0EF"/>
-          </a:solidFill>
-          <a:ln w="12700">
-            <a:solidFill>
-              <a:srgbClr val="0E7C7B"/>
-            </a:solidFill>
-          </a:ln>
-          <a:effectLst/>
-        </p:spPr>
-        <p:style>
-          <a:lnRef idx="1">
-            <a:schemeClr val="accent1"/>
-          </a:lnRef>
-          <a:fillRef idx="3">
-            <a:schemeClr val="accent1"/>
-          </a:fillRef>
-          <a:effectRef idx="2">
-            <a:schemeClr val="accent1"/>
-          </a:effectRef>
-          <a:fontRef idx="minor">
-            <a:schemeClr val="lt1"/>
-          </a:fontRef>
-        </p:style>
-        <p:txBody>
-          <a:bodyPr wrap="square" lIns="182880" rIns="182880" rtlCol="0" anchor="ctr"/>
-          <a:lstStyle/>
-          <a:p>
-            <a:pPr algn="ctr"/>
-            <a:r>
-              <a:rPr sz="1200" b="1" i="0">
-                <a:solidFill>
-                  <a:srgbClr val="0E7C7B"/>
-                </a:solidFill>
-                <a:latin typeface="Menlo"/>
-              </a:rPr>
-              <a:t>MASS SPEC · </a:t>
-            </a:r>
-            <a:r>
-              <a:rPr sz="1700" b="0" i="0">
-                <a:solidFill>
-                  <a:srgbClr val="3D444C"/>
-                </a:solidFill>
-                <a:latin typeface="Avenir Next"/>
-              </a:rPr>
-              <a:t>Raw intensities → peak-shaped bumps → clusters → a signature → the call (susceptible / resistant). Exactly the neuron math you just did, stacked on your data.</a:t>
-            </a:r>
-          </a:p>
-        </p:txBody>
-      </p:sp>
-    </p:spTree>
-  </p:cSld>
-  <p:clrMapOvr>
-    <a:masterClrMapping/>
-  </p:clrMapOvr>
-</p:sld>
-</file>
-
-<file path=ppt/slides/slide24.xml><?xml version="1.0" encoding="utf-8"?>
-<p:sld xmlns:a="http://schemas.openxmlformats.org/drawingml/2006/main" xmlns:r="http://schemas.openxmlformats.org/officeDocument/2006/relationships" xmlns:p="http://schemas.openxmlformats.org/presentationml/2006/main">
-  <p:cSld>
-    <p:spTree>
-      <p:nvGrpSpPr>
-        <p:cNvPr id="1" name=""/>
-        <p:cNvGrpSpPr/>
-        <p:nvPr/>
-      </p:nvGrpSpPr>
-      <p:grpSpPr>
-        <a:xfrm>
-          <a:off x="0" y="0"/>
-          <a:ext cx="0" cy="0"/>
-          <a:chOff x="0" y="0"/>
-          <a:chExt cx="0" cy="0"/>
-        </a:xfrm>
-      </p:grpSpPr>
-      <p:sp>
-        <p:nvSpPr>
-          <p:cNvPr id="2" name="Rectangle 1"/>
-          <p:cNvSpPr/>
-          <p:nvPr/>
-        </p:nvSpPr>
-        <p:spPr>
-          <a:xfrm>
-            <a:off x="0" y="0"/>
-            <a:ext cx="12191695" cy="6858000"/>
-          </a:xfrm>
-          <a:prstGeom prst="rect">
-            <a:avLst/>
-          </a:prstGeom>
-          <a:solidFill>
-            <a:srgbClr val="FBFBF8"/>
-          </a:solidFill>
-          <a:ln>
-            <a:noFill/>
-          </a:ln>
-          <a:effectLst/>
-        </p:spPr>
-        <p:style>
-          <a:lnRef idx="1">
-            <a:schemeClr val="accent1"/>
-          </a:lnRef>
-          <a:fillRef idx="3">
-            <a:schemeClr val="accent1"/>
-          </a:fillRef>
-          <a:effectRef idx="2">
-            <a:schemeClr val="accent1"/>
-          </a:effectRef>
-          <a:fontRef idx="minor">
-            <a:schemeClr val="lt1"/>
-          </a:fontRef>
-        </p:style>
-        <p:txBody>
-          <a:bodyPr rtlCol="0" anchor="ctr"/>
-          <a:lstStyle/>
-          <a:p>
-            <a:pPr algn="ctr"/>
-            <a:endParaRPr/>
-          </a:p>
-        </p:txBody>
-      </p:sp>
-      <p:sp>
-        <p:nvSpPr>
-          <p:cNvPr id="3" name="TextBox 2"/>
-          <p:cNvSpPr txBox="1"/>
-          <p:nvPr/>
-        </p:nvSpPr>
-        <p:spPr>
-          <a:xfrm>
-            <a:off x="548640" y="320040"/>
-            <a:ext cx="10972800" cy="365760"/>
-          </a:xfrm>
-          <a:prstGeom prst="rect">
-            <a:avLst/>
-          </a:prstGeom>
-          <a:noFill/>
-        </p:spPr>
-        <p:txBody>
-          <a:bodyPr wrap="square" anchor="t">
-            <a:spAutoFit/>
-          </a:bodyPr>
-          <a:lstStyle/>
-          <a:p>
-            <a:r>
-              <a:rPr sz="1300" b="1" i="0">
-                <a:solidFill>
-                  <a:srgbClr val="8A9099"/>
-                </a:solidFill>
-                <a:latin typeface="Menlo"/>
-              </a:rPr>
               <a:t>LECTURE 1 · DISCUSSION (PAIR)</a:t>
             </a:r>
           </a:p>
@@ -8461,61 +7913,6 @@
                 <a:latin typeface="Avenir Next"/>
               </a:rPr>
               <a:t>Judgment: the good, the bad, and the ugly of deep learning</a:t>
-            </a:r>
-          </a:p>
-        </p:txBody>
-      </p:sp>
-      <p:sp>
-        <p:nvSpPr>
-          <p:cNvPr id="6" name="Rectangle 5"/>
-          <p:cNvSpPr/>
-          <p:nvPr/>
-        </p:nvSpPr>
-        <p:spPr>
-          <a:xfrm>
-            <a:off x="548640" y="5120639"/>
-            <a:ext cx="10515600" cy="923544"/>
-          </a:xfrm>
-          <a:prstGeom prst="rect">
-            <a:avLst/>
-          </a:prstGeom>
-          <a:solidFill>
-            <a:srgbClr val="F1F1EC"/>
-          </a:solidFill>
-          <a:ln w="12700">
-            <a:solidFill>
-              <a:srgbClr val="3D444C"/>
-            </a:solidFill>
-          </a:ln>
-          <a:effectLst/>
-        </p:spPr>
-        <p:style>
-          <a:lnRef idx="1">
-            <a:schemeClr val="accent1"/>
-          </a:lnRef>
-          <a:fillRef idx="3">
-            <a:schemeClr val="accent1"/>
-          </a:fillRef>
-          <a:effectRef idx="2">
-            <a:schemeClr val="accent1"/>
-          </a:effectRef>
-          <a:fontRef idx="minor">
-            <a:schemeClr val="lt1"/>
-          </a:fontRef>
-        </p:style>
-        <p:txBody>
-          <a:bodyPr wrap="square" lIns="182880" rIns="182880" rtlCol="0" anchor="ctr"/>
-          <a:lstStyle/>
-          <a:p>
-            <a:pPr algn="ctr"/>
-            <a:r>
-              <a:rPr sz="1700" b="0" i="0">
-                <a:solidFill>
-                  <a:srgbClr val="3D444C"/>
-                </a:solidFill>
-                <a:latin typeface="Avenir Next"/>
-              </a:rPr>
-              <a:t>Goal — leave able to APPLY deep learning to your own assay, and to JUDGE when a simpler tool wins. You never write a network from scratch; you fill in blanks and read code.</a:t>
             </a:r>
           </a:p>
         </p:txBody>
@@ -9159,13 +8556,52 @@
           <a:p>
             <a:pPr algn="ctr"/>
             <a:r>
+              <a:rPr lang="en-US" sz="1700" b="0" i="0" u="sng" dirty="0">
+                <a:solidFill>
+                  <a:srgbClr val="3D444C"/>
+                </a:solidFill>
+                <a:latin typeface="Avenir Next"/>
+              </a:rPr>
+              <a:t>Every lecture </a:t>
+            </a:r>
+            <a:r>
               <a:rPr lang="en-US" sz="1700" b="0" i="0" dirty="0">
                 <a:solidFill>
                   <a:srgbClr val="3D444C"/>
                 </a:solidFill>
                 <a:latin typeface="Avenir Next"/>
               </a:rPr>
-              <a:t>Every lecture (1 hour) has a paper quiz/worksheet. The third hour of </a:t>
+              <a:t>(1 hour) has a </a:t>
+            </a:r>
+            <a:r>
+              <a:rPr lang="en-US" sz="1700" b="1" i="0" dirty="0">
+                <a:solidFill>
+                  <a:srgbClr val="3D444C"/>
+                </a:solidFill>
+                <a:latin typeface="Avenir Next"/>
+              </a:rPr>
+              <a:t>paper quiz/worksheet. </a:t>
+            </a:r>
+          </a:p>
+          <a:p>
+            <a:pPr algn="ctr"/>
+            <a:r>
+              <a:rPr lang="en-US" sz="1700" b="0" i="0" u="sng" dirty="0">
+                <a:solidFill>
+                  <a:srgbClr val="3D444C"/>
+                </a:solidFill>
+                <a:latin typeface="Avenir Next"/>
+              </a:rPr>
+              <a:t>The third hour </a:t>
+            </a:r>
+            <a:r>
+              <a:rPr lang="en-US" sz="1700" b="0" i="0" dirty="0">
+                <a:solidFill>
+                  <a:srgbClr val="3D444C"/>
+                </a:solidFill>
+                <a:latin typeface="Avenir Next"/>
+              </a:rPr>
+              <a:t>of </a:t>
             </a:r>
             <a:r>
               <a:rPr lang="en-US" sz="1700" dirty="0">
@@ -9204,7 +8640,7 @@
               <a:t> </a:t>
             </a:r>
             <a:r>
-              <a:rPr sz="1700" b="0" i="0" dirty="0" err="1">
+              <a:rPr sz="1700" b="1" i="0" dirty="0" err="1">
                 <a:solidFill>
                   <a:srgbClr val="3D444C"/>
                 </a:solidFill>
@@ -9213,7 +8649,7 @@
               <a:t>Colab</a:t>
             </a:r>
             <a:r>
-              <a:rPr lang="en-US" sz="1700" b="0" i="0" dirty="0">
+              <a:rPr lang="en-US" sz="1700" b="1" i="0" dirty="0">
                 <a:solidFill>
                   <a:srgbClr val="3D444C"/>
                 </a:solidFill>
@@ -9222,7 +8658,7 @@
               <a:t>-based </a:t>
             </a:r>
             <a:r>
-              <a:rPr lang="en-US" sz="1700" b="0" i="0" dirty="0" err="1">
+              <a:rPr lang="en-US" sz="1700" b="1" i="0" dirty="0" err="1">
                 <a:solidFill>
                   <a:srgbClr val="3D444C"/>
                 </a:solidFill>
@@ -9231,7 +8667,7 @@
               <a:t>Pytorch</a:t>
             </a:r>
             <a:r>
-              <a:rPr lang="en-US" sz="1700" b="0" i="0" dirty="0">
+              <a:rPr lang="en-US" sz="1700" b="1" i="0" dirty="0">
                 <a:solidFill>
                   <a:srgbClr val="3D444C"/>
                 </a:solidFill>
@@ -9240,13 +8676,22 @@
               <a:t> hands-on</a:t>
             </a:r>
             <a:r>
+              <a:rPr sz="1700" b="1" i="0" dirty="0">
+                <a:solidFill>
+                  <a:srgbClr val="3D444C"/>
+                </a:solidFill>
+                <a:latin typeface="Avenir Next"/>
+              </a:rPr>
+              <a:t> lab</a:t>
+            </a:r>
+            <a:r>
               <a:rPr sz="1700" b="0" i="0" dirty="0">
                 <a:solidFill>
                   <a:srgbClr val="3D444C"/>
                 </a:solidFill>
                 <a:latin typeface="Avenir Next"/>
               </a:rPr>
-              <a:t> lab.</a:t>
+              <a:t>.</a:t>
             </a:r>
           </a:p>
         </p:txBody>
@@ -9285,6 +8730,251 @@
                                     <p:set>
                                       <p:cBhvr>
                                         <p:cTn id="6" dur="1" fill="hold">
+                                          <p:stCondLst>
+                                            <p:cond delay="0"/>
+                                          </p:stCondLst>
+                                        </p:cTn>
+                                        <p:tgtEl>
+                                          <p:spTgt spid="5">
+                                            <p:txEl>
+                                              <p:pRg st="0" end="0"/>
+                                            </p:txEl>
+                                          </p:spTgt>
+                                        </p:tgtEl>
+                                        <p:attrNameLst>
+                                          <p:attrName>style.visibility</p:attrName>
+                                        </p:attrNameLst>
+                                      </p:cBhvr>
+                                      <p:to>
+                                        <p:strVal val="visible"/>
+                                      </p:to>
+                                    </p:set>
+                                  </p:childTnLst>
+                                </p:cTn>
+                              </p:par>
+                            </p:childTnLst>
+                          </p:cTn>
+                        </p:par>
+                      </p:childTnLst>
+                    </p:cTn>
+                  </p:par>
+                  <p:par>
+                    <p:cTn id="7" fill="hold">
+                      <p:stCondLst>
+                        <p:cond delay="indefinite"/>
+                      </p:stCondLst>
+                      <p:childTnLst>
+                        <p:par>
+                          <p:cTn id="8" fill="hold">
+                            <p:stCondLst>
+                              <p:cond delay="0"/>
+                            </p:stCondLst>
+                            <p:childTnLst>
+                              <p:par>
+                                <p:cTn id="9" presetID="1" presetClass="entr" presetSubtype="0" fill="hold" grpId="0" nodeType="clickEffect">
+                                  <p:stCondLst>
+                                    <p:cond delay="0"/>
+                                  </p:stCondLst>
+                                  <p:childTnLst>
+                                    <p:set>
+                                      <p:cBhvr>
+                                        <p:cTn id="10" dur="1" fill="hold">
+                                          <p:stCondLst>
+                                            <p:cond delay="0"/>
+                                          </p:stCondLst>
+                                        </p:cTn>
+                                        <p:tgtEl>
+                                          <p:spTgt spid="5">
+                                            <p:txEl>
+                                              <p:pRg st="1" end="1"/>
+                                            </p:txEl>
+                                          </p:spTgt>
+                                        </p:tgtEl>
+                                        <p:attrNameLst>
+                                          <p:attrName>style.visibility</p:attrName>
+                                        </p:attrNameLst>
+                                      </p:cBhvr>
+                                      <p:to>
+                                        <p:strVal val="visible"/>
+                                      </p:to>
+                                    </p:set>
+                                  </p:childTnLst>
+                                </p:cTn>
+                              </p:par>
+                            </p:childTnLst>
+                          </p:cTn>
+                        </p:par>
+                      </p:childTnLst>
+                    </p:cTn>
+                  </p:par>
+                  <p:par>
+                    <p:cTn id="11" fill="hold">
+                      <p:stCondLst>
+                        <p:cond delay="indefinite"/>
+                      </p:stCondLst>
+                      <p:childTnLst>
+                        <p:par>
+                          <p:cTn id="12" fill="hold">
+                            <p:stCondLst>
+                              <p:cond delay="0"/>
+                            </p:stCondLst>
+                            <p:childTnLst>
+                              <p:par>
+                                <p:cTn id="13" presetID="1" presetClass="entr" presetSubtype="0" fill="hold" grpId="0" nodeType="clickEffect">
+                                  <p:stCondLst>
+                                    <p:cond delay="0"/>
+                                  </p:stCondLst>
+                                  <p:childTnLst>
+                                    <p:set>
+                                      <p:cBhvr>
+                                        <p:cTn id="14" dur="1" fill="hold">
+                                          <p:stCondLst>
+                                            <p:cond delay="0"/>
+                                          </p:stCondLst>
+                                        </p:cTn>
+                                        <p:tgtEl>
+                                          <p:spTgt spid="5">
+                                            <p:txEl>
+                                              <p:pRg st="2" end="2"/>
+                                            </p:txEl>
+                                          </p:spTgt>
+                                        </p:tgtEl>
+                                        <p:attrNameLst>
+                                          <p:attrName>style.visibility</p:attrName>
+                                        </p:attrNameLst>
+                                      </p:cBhvr>
+                                      <p:to>
+                                        <p:strVal val="visible"/>
+                                      </p:to>
+                                    </p:set>
+                                  </p:childTnLst>
+                                </p:cTn>
+                              </p:par>
+                            </p:childTnLst>
+                          </p:cTn>
+                        </p:par>
+                      </p:childTnLst>
+                    </p:cTn>
+                  </p:par>
+                  <p:par>
+                    <p:cTn id="15" fill="hold">
+                      <p:stCondLst>
+                        <p:cond delay="indefinite"/>
+                      </p:stCondLst>
+                      <p:childTnLst>
+                        <p:par>
+                          <p:cTn id="16" fill="hold">
+                            <p:stCondLst>
+                              <p:cond delay="0"/>
+                            </p:stCondLst>
+                            <p:childTnLst>
+                              <p:par>
+                                <p:cTn id="17" presetID="1" presetClass="entr" presetSubtype="0" fill="hold" grpId="0" nodeType="clickEffect">
+                                  <p:stCondLst>
+                                    <p:cond delay="0"/>
+                                  </p:stCondLst>
+                                  <p:childTnLst>
+                                    <p:set>
+                                      <p:cBhvr>
+                                        <p:cTn id="18" dur="1" fill="hold">
+                                          <p:stCondLst>
+                                            <p:cond delay="0"/>
+                                          </p:stCondLst>
+                                        </p:cTn>
+                                        <p:tgtEl>
+                                          <p:spTgt spid="5">
+                                            <p:txEl>
+                                              <p:pRg st="3" end="3"/>
+                                            </p:txEl>
+                                          </p:spTgt>
+                                        </p:tgtEl>
+                                        <p:attrNameLst>
+                                          <p:attrName>style.visibility</p:attrName>
+                                        </p:attrNameLst>
+                                      </p:cBhvr>
+                                      <p:to>
+                                        <p:strVal val="visible"/>
+                                      </p:to>
+                                    </p:set>
+                                  </p:childTnLst>
+                                </p:cTn>
+                              </p:par>
+                            </p:childTnLst>
+                          </p:cTn>
+                        </p:par>
+                      </p:childTnLst>
+                    </p:cTn>
+                  </p:par>
+                  <p:par>
+                    <p:cTn id="19" fill="hold">
+                      <p:stCondLst>
+                        <p:cond delay="indefinite"/>
+                      </p:stCondLst>
+                      <p:childTnLst>
+                        <p:par>
+                          <p:cTn id="20" fill="hold">
+                            <p:stCondLst>
+                              <p:cond delay="0"/>
+                            </p:stCondLst>
+                            <p:childTnLst>
+                              <p:par>
+                                <p:cTn id="21" presetID="1" presetClass="entr" presetSubtype="0" fill="hold" grpId="0" nodeType="clickEffect">
+                                  <p:stCondLst>
+                                    <p:cond delay="0"/>
+                                  </p:stCondLst>
+                                  <p:childTnLst>
+                                    <p:set>
+                                      <p:cBhvr>
+                                        <p:cTn id="22" dur="1" fill="hold">
+                                          <p:stCondLst>
+                                            <p:cond delay="0"/>
+                                          </p:stCondLst>
+                                        </p:cTn>
+                                        <p:tgtEl>
+                                          <p:spTgt spid="5">
+                                            <p:txEl>
+                                              <p:pRg st="4" end="4"/>
+                                            </p:txEl>
+                                          </p:spTgt>
+                                        </p:tgtEl>
+                                        <p:attrNameLst>
+                                          <p:attrName>style.visibility</p:attrName>
+                                        </p:attrNameLst>
+                                      </p:cBhvr>
+                                      <p:to>
+                                        <p:strVal val="visible"/>
+                                      </p:to>
+                                    </p:set>
+                                  </p:childTnLst>
+                                </p:cTn>
+                              </p:par>
+                            </p:childTnLst>
+                          </p:cTn>
+                        </p:par>
+                      </p:childTnLst>
+                    </p:cTn>
+                  </p:par>
+                  <p:par>
+                    <p:cTn id="23" fill="hold">
+                      <p:stCondLst>
+                        <p:cond delay="indefinite"/>
+                      </p:stCondLst>
+                      <p:childTnLst>
+                        <p:par>
+                          <p:cTn id="24" fill="hold">
+                            <p:stCondLst>
+                              <p:cond delay="0"/>
+                            </p:stCondLst>
+                            <p:childTnLst>
+                              <p:par>
+                                <p:cTn id="25" presetID="1" presetClass="entr" presetSubtype="0" fill="hold" grpId="0" nodeType="clickEffect">
+                                  <p:stCondLst>
+                                    <p:cond delay="0"/>
+                                  </p:stCondLst>
+                                  <p:childTnLst>
+                                    <p:set>
+                                      <p:cBhvr>
+                                        <p:cTn id="26" dur="1" fill="hold">
                                           <p:stCondLst>
                                             <p:cond delay="0"/>
                                           </p:stCondLst>
@@ -9331,6 +9021,7 @@
       </p:par>
     </p:tnLst>
     <p:bldLst>
+      <p:bldP spid="5" grpId="0" build="p"/>
       <p:bldP spid="6" grpId="0" animBg="1"/>
     </p:bldLst>
   </p:timing>
@@ -10420,7 +10111,7 @@
         <p:spPr>
           <a:xfrm>
             <a:off x="6309360" y="2011680"/>
-            <a:ext cx="5394960" cy="2441448"/>
+            <a:ext cx="5394960" cy="2154436"/>
           </a:xfrm>
           <a:prstGeom prst="rect">
             <a:avLst/>
@@ -10461,7 +10152,29 @@
                 </a:solidFill>
                 <a:latin typeface="Avenir Next"/>
               </a:rPr>
-              <a:t>Strength: interpretable, data-thrifty. Ceiling: only as good as the features you thought to compute.</a:t>
+              <a:t>Strength: interpretable, data-thrifty. </a:t>
+            </a:r>
+            <a:endParaRPr lang="en-US" sz="1900" b="0" i="0" dirty="0">
+              <a:solidFill>
+                <a:srgbClr val="1B2025"/>
+              </a:solidFill>
+              <a:latin typeface="Avenir Next"/>
+            </a:endParaRPr>
+          </a:p>
+          <a:p>
+            <a:pPr>
+              <a:spcAft>
+                <a:spcPts val="1200"/>
+              </a:spcAft>
+            </a:pPr>
+            <a:r>
+              <a:rPr sz="1900" b="0" i="0" dirty="0">
+                <a:solidFill>
+                  <a:srgbClr val="1B2025"/>
+                </a:solidFill>
+                <a:latin typeface="Avenir Next"/>
+              </a:rPr>
+              <a:t>Ceiling: only as good as the features you thought to compute.</a:t>
             </a:r>
           </a:p>
         </p:txBody>
@@ -10561,6 +10274,51 @@
                                     <p:set>
                                       <p:cBhvr>
                                         <p:cTn id="6" dur="1" fill="hold">
+                                          <p:stCondLst>
+                                            <p:cond delay="0"/>
+                                          </p:stCondLst>
+                                        </p:cTn>
+                                        <p:tgtEl>
+                                          <p:spTgt spid="7"/>
+                                        </p:tgtEl>
+                                        <p:attrNameLst>
+                                          <p:attrName>style.visibility</p:attrName>
+                                        </p:attrNameLst>
+                                      </p:cBhvr>
+                                      <p:to>
+                                        <p:strVal val="visible"/>
+                                      </p:to>
+                                    </p:set>
+                                  </p:childTnLst>
+                                </p:cTn>
+                              </p:par>
+                            </p:childTnLst>
+                          </p:cTn>
+                        </p:par>
+                      </p:childTnLst>
+                    </p:cTn>
+                  </p:par>
+                  <p:par>
+                    <p:cTn id="7" fill="hold">
+                      <p:stCondLst>
+                        <p:cond delay="indefinite"/>
+                      </p:stCondLst>
+                      <p:childTnLst>
+                        <p:par>
+                          <p:cTn id="8" fill="hold">
+                            <p:stCondLst>
+                              <p:cond delay="0"/>
+                            </p:stCondLst>
+                            <p:childTnLst>
+                              <p:par>
+                                <p:cTn id="9" presetID="1" presetClass="entr" presetSubtype="0" fill="hold" grpId="0" nodeType="clickEffect">
+                                  <p:stCondLst>
+                                    <p:cond delay="0"/>
+                                  </p:stCondLst>
+                                  <p:childTnLst>
+                                    <p:set>
+                                      <p:cBhvr>
+                                        <p:cTn id="10" dur="1" fill="hold">
                                           <p:stCondLst>
                                             <p:cond delay="0"/>
                                           </p:stCondLst>
@@ -10607,6 +10365,7 @@
       </p:par>
     </p:tnLst>
     <p:bldLst>
+      <p:bldP spid="7" grpId="0"/>
       <p:bldP spid="8" grpId="0" animBg="1"/>
     </p:bldLst>
   </p:timing>
@@ -10834,7 +10593,52 @@
                 </a:solidFill>
                 <a:latin typeface="Avenir Next"/>
               </a:rPr>
-              <a:t>Trade-off: less feature-guessing, but more data, more compute, less interpretability</a:t>
+              <a:t>Trade-off: less feature-guessing, but </a:t>
+            </a:r>
+            <a:r>
+              <a:rPr sz="2600" b="1" i="0" dirty="0">
+                <a:solidFill>
+                  <a:srgbClr val="1B2025"/>
+                </a:solidFill>
+                <a:latin typeface="Avenir Next"/>
+              </a:rPr>
+              <a:t>more data</a:t>
+            </a:r>
+            <a:r>
+              <a:rPr sz="2600" b="0" i="0" dirty="0">
+                <a:solidFill>
+                  <a:srgbClr val="1B2025"/>
+                </a:solidFill>
+                <a:latin typeface="Avenir Next"/>
+              </a:rPr>
+              <a:t>, </a:t>
+            </a:r>
+            <a:r>
+              <a:rPr sz="2600" b="1" i="0" dirty="0">
+                <a:solidFill>
+                  <a:srgbClr val="1B2025"/>
+                </a:solidFill>
+                <a:latin typeface="Avenir Next"/>
+              </a:rPr>
+              <a:t>more compute</a:t>
+            </a:r>
+            <a:r>
+              <a:rPr sz="2600" b="0" i="0" dirty="0">
+                <a:solidFill>
+                  <a:srgbClr val="1B2025"/>
+                </a:solidFill>
+                <a:latin typeface="Avenir Next"/>
+              </a:rPr>
+              <a:t>, </a:t>
+            </a:r>
+            <a:r>
+              <a:rPr sz="2600" b="1" i="0" dirty="0">
+                <a:solidFill>
+                  <a:srgbClr val="1B2025"/>
+                </a:solidFill>
+                <a:latin typeface="Avenir Next"/>
+              </a:rPr>
+              <a:t>less interpretability</a:t>
             </a:r>
           </a:p>
         </p:txBody>
@@ -10997,11 +10801,362 @@
           </a:p>
         </p:txBody>
       </p:sp>
+      <p:pic>
+        <p:nvPicPr>
+          <p:cNvPr id="2" name="Picture 1" descr="cat.jpg">
+            <a:extLst>
+              <a:ext uri="{FF2B5EF4-FFF2-40B4-BE49-F238E27FC236}">
+                <a16:creationId xmlns:a16="http://schemas.microsoft.com/office/drawing/2014/main" id="{19DFA121-74FE-0673-DC14-E3BEFAF4E282}"/>
+              </a:ext>
+            </a:extLst>
+          </p:cNvPr>
+          <p:cNvPicPr>
+            <a:picLocks noChangeAspect="1"/>
+          </p:cNvPicPr>
+          <p:nvPr/>
+        </p:nvPicPr>
+        <p:blipFill>
+          <a:blip r:embed="rId3"/>
+          <a:stretch>
+            <a:fillRect/>
+          </a:stretch>
+        </p:blipFill>
+        <p:spPr>
+          <a:xfrm>
+            <a:off x="9695770" y="1370372"/>
+            <a:ext cx="1642790" cy="2195615"/>
+          </a:xfrm>
+          <a:prstGeom prst="rect">
+            <a:avLst/>
+          </a:prstGeom>
+        </p:spPr>
+      </p:pic>
     </p:spTree>
   </p:cSld>
   <p:clrMapOvr>
     <a:masterClrMapping/>
   </p:clrMapOvr>
+  <p:timing>
+    <p:tnLst>
+      <p:par>
+        <p:cTn id="1" dur="indefinite" restart="never" nodeType="tmRoot">
+          <p:childTnLst>
+            <p:seq concurrent="1" nextAc="seek">
+              <p:cTn id="2" dur="indefinite" nodeType="mainSeq">
+                <p:childTnLst>
+                  <p:par>
+                    <p:cTn id="3" fill="hold">
+                      <p:stCondLst>
+                        <p:cond delay="indefinite"/>
+                      </p:stCondLst>
+                      <p:childTnLst>
+                        <p:par>
+                          <p:cTn id="4" fill="hold">
+                            <p:stCondLst>
+                              <p:cond delay="0"/>
+                            </p:stCondLst>
+                            <p:childTnLst>
+                              <p:par>
+                                <p:cTn id="5" presetID="1" presetClass="entr" presetSubtype="0" fill="hold" grpId="0" nodeType="clickEffect">
+                                  <p:stCondLst>
+                                    <p:cond delay="0"/>
+                                  </p:stCondLst>
+                                  <p:childTnLst>
+                                    <p:set>
+                                      <p:cBhvr>
+                                        <p:cTn id="6" dur="1" fill="hold">
+                                          <p:stCondLst>
+                                            <p:cond delay="0"/>
+                                          </p:stCondLst>
+                                        </p:cTn>
+                                        <p:tgtEl>
+                                          <p:spTgt spid="5">
+                                            <p:txEl>
+                                              <p:pRg st="0" end="0"/>
+                                            </p:txEl>
+                                          </p:spTgt>
+                                        </p:tgtEl>
+                                        <p:attrNameLst>
+                                          <p:attrName>style.visibility</p:attrName>
+                                        </p:attrNameLst>
+                                      </p:cBhvr>
+                                      <p:to>
+                                        <p:strVal val="visible"/>
+                                      </p:to>
+                                    </p:set>
+                                  </p:childTnLst>
+                                </p:cTn>
+                              </p:par>
+                            </p:childTnLst>
+                          </p:cTn>
+                        </p:par>
+                      </p:childTnLst>
+                    </p:cTn>
+                  </p:par>
+                  <p:par>
+                    <p:cTn id="7" fill="hold">
+                      <p:stCondLst>
+                        <p:cond delay="indefinite"/>
+                      </p:stCondLst>
+                      <p:childTnLst>
+                        <p:par>
+                          <p:cTn id="8" fill="hold">
+                            <p:stCondLst>
+                              <p:cond delay="0"/>
+                            </p:stCondLst>
+                            <p:childTnLst>
+                              <p:par>
+                                <p:cTn id="9" presetID="1" presetClass="entr" presetSubtype="0" fill="hold" grpId="0" nodeType="clickEffect">
+                                  <p:stCondLst>
+                                    <p:cond delay="0"/>
+                                  </p:stCondLst>
+                                  <p:childTnLst>
+                                    <p:set>
+                                      <p:cBhvr>
+                                        <p:cTn id="10" dur="1" fill="hold">
+                                          <p:stCondLst>
+                                            <p:cond delay="0"/>
+                                          </p:stCondLst>
+                                        </p:cTn>
+                                        <p:tgtEl>
+                                          <p:spTgt spid="5">
+                                            <p:txEl>
+                                              <p:pRg st="1" end="1"/>
+                                            </p:txEl>
+                                          </p:spTgt>
+                                        </p:tgtEl>
+                                        <p:attrNameLst>
+                                          <p:attrName>style.visibility</p:attrName>
+                                        </p:attrNameLst>
+                                      </p:cBhvr>
+                                      <p:to>
+                                        <p:strVal val="visible"/>
+                                      </p:to>
+                                    </p:set>
+                                  </p:childTnLst>
+                                </p:cTn>
+                              </p:par>
+                            </p:childTnLst>
+                          </p:cTn>
+                        </p:par>
+                      </p:childTnLst>
+                    </p:cTn>
+                  </p:par>
+                  <p:par>
+                    <p:cTn id="11" fill="hold">
+                      <p:stCondLst>
+                        <p:cond delay="indefinite"/>
+                      </p:stCondLst>
+                      <p:childTnLst>
+                        <p:par>
+                          <p:cTn id="12" fill="hold">
+                            <p:stCondLst>
+                              <p:cond delay="0"/>
+                            </p:stCondLst>
+                            <p:childTnLst>
+                              <p:par>
+                                <p:cTn id="13" presetID="1" presetClass="entr" presetSubtype="0" fill="hold" grpId="0" nodeType="clickEffect">
+                                  <p:stCondLst>
+                                    <p:cond delay="0"/>
+                                  </p:stCondLst>
+                                  <p:childTnLst>
+                                    <p:set>
+                                      <p:cBhvr>
+                                        <p:cTn id="14" dur="1" fill="hold">
+                                          <p:stCondLst>
+                                            <p:cond delay="0"/>
+                                          </p:stCondLst>
+                                        </p:cTn>
+                                        <p:tgtEl>
+                                          <p:spTgt spid="5">
+                                            <p:txEl>
+                                              <p:pRg st="2" end="2"/>
+                                            </p:txEl>
+                                          </p:spTgt>
+                                        </p:tgtEl>
+                                        <p:attrNameLst>
+                                          <p:attrName>style.visibility</p:attrName>
+                                        </p:attrNameLst>
+                                      </p:cBhvr>
+                                      <p:to>
+                                        <p:strVal val="visible"/>
+                                      </p:to>
+                                    </p:set>
+                                  </p:childTnLst>
+                                </p:cTn>
+                              </p:par>
+                            </p:childTnLst>
+                          </p:cTn>
+                        </p:par>
+                      </p:childTnLst>
+                    </p:cTn>
+                  </p:par>
+                  <p:par>
+                    <p:cTn id="15" fill="hold">
+                      <p:stCondLst>
+                        <p:cond delay="indefinite"/>
+                      </p:stCondLst>
+                      <p:childTnLst>
+                        <p:par>
+                          <p:cTn id="16" fill="hold">
+                            <p:stCondLst>
+                              <p:cond delay="0"/>
+                            </p:stCondLst>
+                            <p:childTnLst>
+                              <p:par>
+                                <p:cTn id="17" presetID="1" presetClass="entr" presetSubtype="0" fill="hold" grpId="0" nodeType="clickEffect">
+                                  <p:stCondLst>
+                                    <p:cond delay="0"/>
+                                  </p:stCondLst>
+                                  <p:childTnLst>
+                                    <p:set>
+                                      <p:cBhvr>
+                                        <p:cTn id="18" dur="1" fill="hold">
+                                          <p:stCondLst>
+                                            <p:cond delay="0"/>
+                                          </p:stCondLst>
+                                        </p:cTn>
+                                        <p:tgtEl>
+                                          <p:spTgt spid="5">
+                                            <p:txEl>
+                                              <p:pRg st="3" end="3"/>
+                                            </p:txEl>
+                                          </p:spTgt>
+                                        </p:tgtEl>
+                                        <p:attrNameLst>
+                                          <p:attrName>style.visibility</p:attrName>
+                                        </p:attrNameLst>
+                                      </p:cBhvr>
+                                      <p:to>
+                                        <p:strVal val="visible"/>
+                                      </p:to>
+                                    </p:set>
+                                  </p:childTnLst>
+                                </p:cTn>
+                              </p:par>
+                            </p:childTnLst>
+                          </p:cTn>
+                        </p:par>
+                      </p:childTnLst>
+                    </p:cTn>
+                  </p:par>
+                  <p:par>
+                    <p:cTn id="19" fill="hold">
+                      <p:stCondLst>
+                        <p:cond delay="indefinite"/>
+                      </p:stCondLst>
+                      <p:childTnLst>
+                        <p:par>
+                          <p:cTn id="20" fill="hold">
+                            <p:stCondLst>
+                              <p:cond delay="0"/>
+                            </p:stCondLst>
+                            <p:childTnLst>
+                              <p:par>
+                                <p:cTn id="21" presetID="1" presetClass="entr" presetSubtype="0" fill="hold" grpId="0" nodeType="clickEffect">
+                                  <p:stCondLst>
+                                    <p:cond delay="0"/>
+                                  </p:stCondLst>
+                                  <p:childTnLst>
+                                    <p:set>
+                                      <p:cBhvr>
+                                        <p:cTn id="22" dur="1" fill="hold">
+                                          <p:stCondLst>
+                                            <p:cond delay="0"/>
+                                          </p:stCondLst>
+                                        </p:cTn>
+                                        <p:tgtEl>
+                                          <p:spTgt spid="7"/>
+                                        </p:tgtEl>
+                                        <p:attrNameLst>
+                                          <p:attrName>style.visibility</p:attrName>
+                                        </p:attrNameLst>
+                                      </p:cBhvr>
+                                      <p:to>
+                                        <p:strVal val="visible"/>
+                                      </p:to>
+                                    </p:set>
+                                  </p:childTnLst>
+                                </p:cTn>
+                              </p:par>
+                            </p:childTnLst>
+                          </p:cTn>
+                        </p:par>
+                      </p:childTnLst>
+                    </p:cTn>
+                  </p:par>
+                  <p:par>
+                    <p:cTn id="23" fill="hold">
+                      <p:stCondLst>
+                        <p:cond delay="indefinite"/>
+                      </p:stCondLst>
+                      <p:childTnLst>
+                        <p:par>
+                          <p:cTn id="24" fill="hold">
+                            <p:stCondLst>
+                              <p:cond delay="0"/>
+                            </p:stCondLst>
+                            <p:childTnLst>
+                              <p:par>
+                                <p:cTn id="25" presetID="1" presetClass="entr" presetSubtype="0" fill="hold" grpId="0" nodeType="clickEffect">
+                                  <p:stCondLst>
+                                    <p:cond delay="0"/>
+                                  </p:stCondLst>
+                                  <p:childTnLst>
+                                    <p:set>
+                                      <p:cBhvr>
+                                        <p:cTn id="26" dur="1" fill="hold">
+                                          <p:stCondLst>
+                                            <p:cond delay="0"/>
+                                          </p:stCondLst>
+                                        </p:cTn>
+                                        <p:tgtEl>
+                                          <p:spTgt spid="6"/>
+                                        </p:tgtEl>
+                                        <p:attrNameLst>
+                                          <p:attrName>style.visibility</p:attrName>
+                                        </p:attrNameLst>
+                                      </p:cBhvr>
+                                      <p:to>
+                                        <p:strVal val="visible"/>
+                                      </p:to>
+                                    </p:set>
+                                  </p:childTnLst>
+                                </p:cTn>
+                              </p:par>
+                            </p:childTnLst>
+                          </p:cTn>
+                        </p:par>
+                      </p:childTnLst>
+                    </p:cTn>
+                  </p:par>
+                </p:childTnLst>
+              </p:cTn>
+              <p:prevCondLst>
+                <p:cond evt="onPrev" delay="0">
+                  <p:tgtEl>
+                    <p:sldTgt/>
+                  </p:tgtEl>
+                </p:cond>
+              </p:prevCondLst>
+              <p:nextCondLst>
+                <p:cond evt="onNext" delay="0">
+                  <p:tgtEl>
+                    <p:sldTgt/>
+                  </p:tgtEl>
+                </p:cond>
+              </p:nextCondLst>
+            </p:seq>
+          </p:childTnLst>
+        </p:cTn>
+      </p:par>
+    </p:tnLst>
+    <p:bldLst>
+      <p:bldP spid="5" grpId="0" build="p"/>
+      <p:bldP spid="6" grpId="0" animBg="1"/>
+      <p:bldP spid="7" grpId="0" animBg="1"/>
+    </p:bldLst>
+  </p:timing>
 </p:sld>
 </file>
 

</xml_diff>

<commit_message>
slides: give every slide a proper header
A sanity pass over the eyebrow (the small uppercase header above each title)
on all ten decks. About thirty headers are rewritten to their deck's own
SECTION · TOPIC scheme in the standard eyebrow style (Menlo 13 pt bold grey):

- mixed-case or hyphenated headers on slides built from the template's
  layouts, several carrying a cap="none" override from copy-paste, so they
  did not render in capitals like their neighbours (lectures 1, 2, 5, 7, 8,
  10, 11);
- two Lecture 4 content slides wearing the part-divider header, and three
  Lecture 11 slides wearing a neighbour's header that did not describe them;
- Lecture 4's loss steps renumbered 1-2-3-4 to match the slide order the
  2026-09-14 commit chose, with slide 6's stale "the next slide writes the
  formula out" corrected.

Titles and body text are otherwise untouched; slide count unchanged.

Co-Authored-By: Claude Opus 5.5 <noreply@anthropic.com>
</commit_message>
<xml_diff>
--- a/slides/pptx/lecture01_intro.pptx
+++ b/slides/pptx/lecture01_intro.pptx
@@ -3058,8 +3058,13 @@
           <a:lstStyle/>
           <a:p>
             <a:r>
-              <a:rPr lang="en-US" dirty="0"/>
-              <a:t>Intro to Neural networks</a:t>
+              <a:rPr sz="1300" b="1" i="0">
+                <a:solidFill>
+                  <a:srgbClr val="8A9099"/>
+                </a:solidFill>
+                <a:latin typeface="Menlo"/>
+              </a:rPr>
+              <a:t>LECTURE 1 · THEORY FUNDAMENTALS</a:t>
             </a:r>
           </a:p>
         </p:txBody>
@@ -3176,8 +3181,13 @@
           <a:lstStyle/>
           <a:p>
             <a:r>
-              <a:rPr lang="en-US" dirty="0"/>
-              <a:t>The basic unit of neural networks</a:t>
+              <a:rPr sz="1300" b="1" i="0">
+                <a:solidFill>
+                  <a:srgbClr val="8A9099"/>
+                </a:solidFill>
+                <a:latin typeface="Menlo"/>
+              </a:rPr>
+              <a:t>THE NEURON · THE PERCEPTRON</a:t>
             </a:r>
           </a:p>
         </p:txBody>
@@ -6282,8 +6292,13 @@
           <a:lstStyle/>
           <a:p>
             <a:r>
-              <a:rPr lang="en-US" dirty="0"/>
-              <a:t>Instructor – Lixing song</a:t>
+              <a:rPr sz="1300" b="1" i="0">
+                <a:solidFill>
+                  <a:srgbClr val="8A9099"/>
+                </a:solidFill>
+                <a:latin typeface="Menlo"/>
+              </a:rPr>
+              <a:t>LECTURE 1 · YOUR INSTRUCTOR</a:t>
             </a:r>
           </a:p>
         </p:txBody>
@@ -9611,31 +9626,13 @@
           <a:lstStyle/>
           <a:p>
             <a:r>
-              <a:rPr sz="1300" b="1" i="0" dirty="0">
+              <a:rPr sz="1300" b="1" i="0">
                 <a:solidFill>
                   <a:srgbClr val="8A9099"/>
                 </a:solidFill>
                 <a:latin typeface="Menlo"/>
               </a:rPr>
-              <a:t>WHAT </a:t>
-            </a:r>
-            <a:r>
-              <a:rPr lang="en-US" sz="1300" b="1" dirty="0">
-                <a:solidFill>
-                  <a:srgbClr val="8A9099"/>
-                </a:solidFill>
-                <a:latin typeface="Menlo"/>
-              </a:rPr>
-              <a:t>AI</a:t>
-            </a:r>
-            <a:r>
-              <a:rPr sz="1300" b="1" i="0" dirty="0">
-                <a:solidFill>
-                  <a:srgbClr val="8A9099"/>
-                </a:solidFill>
-                <a:latin typeface="Menlo"/>
-              </a:rPr>
-              <a:t> IS </a:t>
+              <a:t>WHAT AI IS · THE BIGGER PICTURE</a:t>
             </a:r>
           </a:p>
         </p:txBody>

</xml_diff>

<commit_message>
no-mistakes(review): slides: suffix duplicate eyebrow headers in lectures 1, 4, 11
</commit_message>
<xml_diff>
--- a/slides/pptx/lecture01_intro.pptx
+++ b/slides/pptx/lecture01_intro.pptx
@@ -3011,7 +3011,7 @@
 </file>
 
 <file path=ppt/slides/slide10.xml><?xml version="1.0" encoding="utf-8"?>
-<p:sld xmlns:a="http://schemas.openxmlformats.org/drawingml/2006/main" xmlns:r="http://schemas.openxmlformats.org/officeDocument/2006/relationships" xmlns:p="http://schemas.openxmlformats.org/presentationml/2006/main">
+<p:sld xmlns:a="http://schemas.openxmlformats.org/drawingml/2006/main" xmlns:p="http://schemas.openxmlformats.org/presentationml/2006/main" xmlns:r="http://schemas.openxmlformats.org/officeDocument/2006/relationships">
   <p:cSld>
     <p:spTree>
       <p:nvGrpSpPr>
@@ -3019,89 +3019,72 @@
         <p:cNvGrpSpPr/>
         <p:nvPr/>
       </p:nvGrpSpPr>
-      <p:grpSpPr>
-        <a:xfrm>
-          <a:off x="0" y="0"/>
-          <a:ext cx="0" cy="0"/>
-          <a:chOff x="0" y="0"/>
-          <a:chExt cx="0" cy="0"/>
-        </a:xfrm>
-      </p:grpSpPr>
-      <p:sp>
-        <p:nvSpPr>
-          <p:cNvPr id="2" name="Title 1">
-            <a:extLst>
-              <a:ext uri="{FF2B5EF4-FFF2-40B4-BE49-F238E27FC236}">
-                <a16:creationId xmlns:a16="http://schemas.microsoft.com/office/drawing/2014/main" id="{D6AB81F4-B2FF-068C-190A-C106497FA303}"/>
-              </a:ext>
-            </a:extLst>
-          </p:cNvPr>
-          <p:cNvSpPr>
-            <a:spLocks noGrp="1"/>
-          </p:cNvSpPr>
-          <p:nvPr>
-            <p:ph type="ctrTitle"/>
-          </p:nvPr>
-        </p:nvSpPr>
-        <p:spPr/>
-        <p:txBody>
-          <a:bodyPr/>
-          <a:lstStyle/>
-          <a:p>
-            <a:r>
-              <a:rPr lang="en-US" dirty="0"/>
-              <a:t>Theory Fundamentals</a:t>
-            </a:r>
-          </a:p>
-        </p:txBody>
-      </p:sp>
-      <p:sp>
-        <p:nvSpPr>
-          <p:cNvPr id="3" name="Subtitle 2">
-            <a:extLst>
-              <a:ext uri="{FF2B5EF4-FFF2-40B4-BE49-F238E27FC236}">
-                <a16:creationId xmlns:a16="http://schemas.microsoft.com/office/drawing/2014/main" id="{7A9C44CD-5B94-8AE3-FEDD-36103A713499}"/>
-              </a:ext>
-            </a:extLst>
-          </p:cNvPr>
-          <p:cNvSpPr>
-            <a:spLocks noGrp="1"/>
-          </p:cNvSpPr>
-          <p:nvPr>
-            <p:ph type="subTitle" idx="1"/>
-          </p:nvPr>
-        </p:nvSpPr>
-        <p:spPr/>
-        <p:txBody>
-          <a:bodyPr/>
-          <a:lstStyle/>
-          <a:p>
-            <a:r>
-              <a:rPr lang="en-US" dirty="0"/>
-              <a:t>The “simple” math behind the neural networks</a:t>
-            </a:r>
-          </a:p>
-        </p:txBody>
-      </p:sp>
-      <p:sp>
-        <p:nvSpPr>
-          <p:cNvPr id="4" name="Text Placeholder 3">
-            <a:extLst>
-              <a:ext uri="{FF2B5EF4-FFF2-40B4-BE49-F238E27FC236}">
-                <a16:creationId xmlns:a16="http://schemas.microsoft.com/office/drawing/2014/main" id="{6ABB0AFC-E766-C851-5E5A-57A0340DDFF0}"/>
-              </a:ext>
-            </a:extLst>
-          </p:cNvPr>
-          <p:cNvSpPr>
-            <a:spLocks noGrp="1"/>
-          </p:cNvSpPr>
-          <p:nvPr>
-            <p:ph type="body" sz="quarter" idx="13"/>
-          </p:nvPr>
-        </p:nvSpPr>
-        <p:spPr/>
-        <p:txBody>
-          <a:bodyPr/>
+      <p:grpSpPr/>
+      <p:sp>
+        <p:nvSpPr>
+          <p:cNvPr id="2" name="Rectangle 1"/>
+          <p:cNvSpPr/>
+          <p:nvPr/>
+        </p:nvSpPr>
+        <p:spPr>
+          <a:xfrm>
+            <a:off x="0" y="0"/>
+            <a:ext cx="12191695" cy="6858000"/>
+          </a:xfrm>
+          <a:prstGeom prst="rect">
+            <a:avLst/>
+          </a:prstGeom>
+          <a:solidFill>
+            <a:srgbClr val="FBFBF8"/>
+          </a:solidFill>
+          <a:ln>
+            <a:noFill/>
+          </a:ln>
+          <a:effectLst/>
+        </p:spPr>
+        <p:style>
+          <a:lnRef idx="1">
+            <a:schemeClr val="accent1"/>
+          </a:lnRef>
+          <a:fillRef idx="3">
+            <a:schemeClr val="accent1"/>
+          </a:fillRef>
+          <a:effectRef idx="2">
+            <a:schemeClr val="accent1"/>
+          </a:effectRef>
+          <a:fontRef idx="minor">
+            <a:schemeClr val="lt1"/>
+          </a:fontRef>
+        </p:style>
+        <p:txBody>
+          <a:bodyPr rtlCol="0" anchor="ctr"/>
+          <a:lstStyle/>
+          <a:p>
+            <a:pPr algn="ctr"/>
+            <a:endParaRPr/>
+          </a:p>
+        </p:txBody>
+      </p:sp>
+      <p:sp>
+        <p:nvSpPr>
+          <p:cNvPr id="3" name="TextBox 2"/>
+          <p:cNvSpPr txBox="1"/>
+          <p:nvPr/>
+        </p:nvSpPr>
+        <p:spPr>
+          <a:xfrm>
+            <a:off x="548640" y="320040"/>
+            <a:ext cx="10972800" cy="365760"/>
+          </a:xfrm>
+          <a:prstGeom prst="rect">
+            <a:avLst/>
+          </a:prstGeom>
+          <a:noFill/>
+        </p:spPr>
+        <p:txBody>
+          <a:bodyPr wrap="square" anchor="t">
+            <a:spAutoFit/>
+          </a:bodyPr>
           <a:lstStyle/>
           <a:p>
             <a:r>
@@ -3111,17 +3094,394 @@
                 </a:solidFill>
                 <a:latin typeface="Menlo"/>
               </a:rPr>
-              <a:t>LECTURE 1 · THEORY FUNDAMENTALS</a:t>
+              <a:t>ENGINEERED VS. LEARNED · YOUR TURN (YOU-DO = Q4)</a:t>
+            </a:r>
+          </a:p>
+        </p:txBody>
+      </p:sp>
+      <p:sp>
+        <p:nvSpPr>
+          <p:cNvPr id="4" name="TextBox 3"/>
+          <p:cNvSpPr txBox="1"/>
+          <p:nvPr/>
+        </p:nvSpPr>
+        <p:spPr>
+          <a:xfrm>
+            <a:off x="548640" y="731520"/>
+            <a:ext cx="11064240" cy="1005840"/>
+          </a:xfrm>
+          <a:prstGeom prst="rect">
+            <a:avLst/>
+          </a:prstGeom>
+          <a:noFill/>
+        </p:spPr>
+        <p:txBody>
+          <a:bodyPr wrap="square" anchor="t">
+            <a:spAutoFit/>
+          </a:bodyPr>
+          <a:lstStyle/>
+          <a:p>
+            <a:r>
+              <a:rPr sz="3400" b="1" i="0">
+                <a:solidFill>
+                  <a:srgbClr val="1B2025"/>
+                </a:solidFill>
+                <a:latin typeface="Avenir Next"/>
+              </a:rPr>
+              <a:t>Your turn — engineered or learned?</a:t>
+            </a:r>
+          </a:p>
+        </p:txBody>
+      </p:sp>
+      <p:sp>
+        <p:nvSpPr>
+          <p:cNvPr id="6" name="Rectangle 5"/>
+          <p:cNvSpPr/>
+          <p:nvPr/>
+        </p:nvSpPr>
+        <p:spPr>
+          <a:xfrm>
+            <a:off x="548640" y="5120640"/>
+            <a:ext cx="10515600" cy="923544"/>
+          </a:xfrm>
+          <a:prstGeom prst="rect">
+            <a:avLst/>
+          </a:prstGeom>
+          <a:solidFill>
+            <a:srgbClr val="F1F1EC"/>
+          </a:solidFill>
+          <a:ln w="12700">
+            <a:solidFill>
+              <a:srgbClr val="E09E2F"/>
+            </a:solidFill>
+          </a:ln>
+          <a:effectLst/>
+        </p:spPr>
+        <p:style>
+          <a:lnRef idx="1">
+            <a:schemeClr val="accent1"/>
+          </a:lnRef>
+          <a:fillRef idx="3">
+            <a:schemeClr val="accent1"/>
+          </a:fillRef>
+          <a:effectRef idx="2">
+            <a:schemeClr val="accent1"/>
+          </a:effectRef>
+          <a:fontRef idx="minor">
+            <a:schemeClr val="lt1"/>
+          </a:fontRef>
+        </p:style>
+        <p:txBody>
+          <a:bodyPr wrap="square" lIns="182880" rIns="182880" rtlCol="0" anchor="ctr"/>
+          <a:lstStyle/>
+          <a:p>
+            <a:pPr algn="ctr"/>
+            <a:r>
+              <a:rPr sz="1200" b="1" i="0" dirty="0">
+                <a:solidFill>
+                  <a:srgbClr val="E09E2F"/>
+                </a:solidFill>
+                <a:latin typeface="Menlo"/>
+              </a:rPr>
+              <a:t>CHECKPOINT · </a:t>
+            </a:r>
+            <a:r>
+              <a:rPr sz="1700" b="0" i="0" dirty="0">
+                <a:solidFill>
+                  <a:srgbClr val="3D444C"/>
+                </a:solidFill>
+                <a:latin typeface="Avenir Next"/>
+              </a:rPr>
+              <a:t>Your turn → Quiz 1, Q4. Two ways to call resistant vs. susceptible from the same MALDI-TOF spectrum. Which pipeline uses HAND-ENGINEERED features, and which uses LEARNED features? 1 minute — answer in the notes.</a:t>
+            </a:r>
+          </a:p>
+        </p:txBody>
+      </p:sp>
+      <p:sp>
+        <p:nvSpPr>
+          <p:cNvPr id="7" name="Rounded Rectangle 6"/>
+          <p:cNvSpPr/>
+          <p:nvPr/>
+        </p:nvSpPr>
+        <p:spPr>
+          <a:xfrm>
+            <a:off x="548640" y="1888800"/>
+            <a:ext cx="5143500" cy="1500000"/>
+          </a:xfrm>
+          <a:prstGeom prst="roundRect">
+            <a:avLst>
+              <a:gd name="adj" fmla="val 8000"/>
+            </a:avLst>
+          </a:prstGeom>
+          <a:solidFill>
+            <a:srgbClr val="FFFFFF"/>
+          </a:solidFill>
+          <a:ln w="12700">
+            <a:solidFill>
+              <a:srgbClr val="D9D9D2"/>
+            </a:solidFill>
+          </a:ln>
+          <a:effectLst/>
+        </p:spPr>
+        <p:style>
+          <a:lnRef idx="1">
+            <a:schemeClr val="accent1"/>
+          </a:lnRef>
+          <a:fillRef idx="3">
+            <a:schemeClr val="accent1"/>
+          </a:fillRef>
+          <a:effectRef idx="2">
+            <a:schemeClr val="accent1"/>
+          </a:effectRef>
+          <a:fontRef idx="minor">
+            <a:schemeClr val="lt1"/>
+          </a:fontRef>
+        </p:style>
+        <p:txBody>
+          <a:bodyPr rtlCol="0" anchor="ctr"/>
+          <a:lstStyle/>
+          <a:p/>
+        </p:txBody>
+      </p:sp>
+      <p:sp>
+        <p:nvSpPr>
+          <p:cNvPr id="8" name="TextBox 7"/>
+          <p:cNvSpPr txBox="1"/>
+          <p:nvPr/>
+        </p:nvSpPr>
+        <p:spPr>
+          <a:xfrm>
+            <a:off x="640080" y="1948800"/>
+            <a:ext cx="4960620" cy="1380000"/>
+          </a:xfrm>
+          <a:prstGeom prst="rect">
+            <a:avLst/>
+          </a:prstGeom>
+          <a:noFill/>
+        </p:spPr>
+        <p:txBody>
+          <a:bodyPr wrap="square" lIns="45720" rIns="45720" tIns="27432" bIns="27432" anchor="t">
+            <a:spAutoFit/>
+          </a:bodyPr>
+          <a:lstStyle/>
+          <a:p>
+            <a:pPr algn="l">
+              <a:spcAft>
+                <a:spcPts val="400"/>
+              </a:spcAft>
+            </a:pPr>
+            <a:r>
+              <a:rPr sz="1800" b="1">
+                <a:solidFill>
+                  <a:srgbClr val="0E7C7B"/>
+                </a:solidFill>
+                <a:latin typeface="Avenir Next"/>
+              </a:rPr>
+              <a:t>Pipeline A</a:t>
+            </a:r>
+          </a:p>
+          <a:p>
+            <a:pPr algn="l">
+              <a:spcAft>
+                <a:spcPts val="400"/>
+              </a:spcAft>
+            </a:pPr>
+            <a:r>
+              <a:rPr sz="1600" b="0">
+                <a:solidFill>
+                  <a:srgbClr val="1B2025"/>
+                </a:solidFill>
+                <a:latin typeface="Avenir Next"/>
+              </a:rPr>
+              <a:t>A technician computes the peak area at m/z 2415 and the 2415/4100 ratio, then feeds those two numbers to logistic regression.</a:t>
+            </a:r>
+          </a:p>
+        </p:txBody>
+      </p:sp>
+      <p:sp>
+        <p:nvSpPr>
+          <p:cNvPr id="9" name="Rounded Rectangle 8"/>
+          <p:cNvSpPr/>
+          <p:nvPr/>
+        </p:nvSpPr>
+        <p:spPr>
+          <a:xfrm>
+            <a:off x="5920740" y="1888800"/>
+            <a:ext cx="5143500" cy="1500000"/>
+          </a:xfrm>
+          <a:prstGeom prst="roundRect">
+            <a:avLst>
+              <a:gd name="adj" fmla="val 8000"/>
+            </a:avLst>
+          </a:prstGeom>
+          <a:solidFill>
+            <a:srgbClr val="FFFFFF"/>
+          </a:solidFill>
+          <a:ln w="12700">
+            <a:solidFill>
+              <a:srgbClr val="D9D9D2"/>
+            </a:solidFill>
+          </a:ln>
+          <a:effectLst/>
+        </p:spPr>
+        <p:style>
+          <a:lnRef idx="1">
+            <a:schemeClr val="accent1"/>
+          </a:lnRef>
+          <a:fillRef idx="3">
+            <a:schemeClr val="accent1"/>
+          </a:fillRef>
+          <a:effectRef idx="2">
+            <a:schemeClr val="accent1"/>
+          </a:effectRef>
+          <a:fontRef idx="minor">
+            <a:schemeClr val="lt1"/>
+          </a:fontRef>
+        </p:style>
+        <p:txBody>
+          <a:bodyPr rtlCol="0" anchor="ctr"/>
+          <a:lstStyle/>
+          <a:p/>
+        </p:txBody>
+      </p:sp>
+      <p:sp>
+        <p:nvSpPr>
+          <p:cNvPr id="10" name="TextBox 9"/>
+          <p:cNvSpPr txBox="1"/>
+          <p:nvPr/>
+        </p:nvSpPr>
+        <p:spPr>
+          <a:xfrm>
+            <a:off x="6012180" y="1948800"/>
+            <a:ext cx="4960620" cy="1380000"/>
+          </a:xfrm>
+          <a:prstGeom prst="rect">
+            <a:avLst/>
+          </a:prstGeom>
+          <a:noFill/>
+        </p:spPr>
+        <p:txBody>
+          <a:bodyPr wrap="square" lIns="45720" rIns="45720" tIns="27432" bIns="27432" anchor="t">
+            <a:spAutoFit/>
+          </a:bodyPr>
+          <a:lstStyle/>
+          <a:p>
+            <a:pPr algn="l">
+              <a:spcAft>
+                <a:spcPts val="400"/>
+              </a:spcAft>
+            </a:pPr>
+            <a:r>
+              <a:rPr sz="1800" b="1">
+                <a:solidFill>
+                  <a:srgbClr val="0E7C7B"/>
+                </a:solidFill>
+                <a:latin typeface="Avenir Next"/>
+              </a:rPr>
+              <a:t>Pipeline B</a:t>
+            </a:r>
+          </a:p>
+          <a:p>
+            <a:pPr algn="l">
+              <a:spcAft>
+                <a:spcPts val="400"/>
+              </a:spcAft>
+            </a:pPr>
+            <a:r>
+              <a:rPr sz="1600" b="0">
+                <a:solidFill>
+                  <a:srgbClr val="1B2025"/>
+                </a:solidFill>
+                <a:latin typeface="Avenir Next"/>
+              </a:rPr>
+              <a:t>The raw 6,000-bin spectrum goes straight into a neural network, which forms its own internal “peak-ish here” detector in an early layer.</a:t>
+            </a:r>
+          </a:p>
+        </p:txBody>
+      </p:sp>
+      <p:sp>
+        <p:nvSpPr>
+          <p:cNvPr id="11" name="TextBox 10"/>
+          <p:cNvSpPr txBox="1"/>
+          <p:nvPr/>
+        </p:nvSpPr>
+        <p:spPr>
+          <a:xfrm>
+            <a:off x="548640" y="3568800"/>
+            <a:ext cx="10515600" cy="900000"/>
+          </a:xfrm>
+          <a:prstGeom prst="rect">
+            <a:avLst/>
+          </a:prstGeom>
+          <a:noFill/>
+        </p:spPr>
+        <p:txBody>
+          <a:bodyPr wrap="square" lIns="45720" rIns="45720" tIns="27432" bIns="27432" anchor="t">
+            <a:spAutoFit/>
+          </a:bodyPr>
+          <a:lstStyle/>
+          <a:p>
+            <a:pPr algn="ctr">
+              <a:spcAft>
+                <a:spcPts val="400"/>
+              </a:spcAft>
+            </a:pPr>
+            <a:r>
+              <a:rPr sz="1700" b="0">
+                <a:solidFill>
+                  <a:srgbClr val="1B2025"/>
+                </a:solidFill>
+                <a:latin typeface="Avenir Next"/>
+              </a:rPr>
+              <a:t>Two ways to call resistant vs. susceptible from one MALDI-TOF spectrum.</a:t>
+            </a:r>
+          </a:p>
+          <a:p>
+            <a:pPr algn="ctr">
+              <a:spcAft>
+                <a:spcPts val="400"/>
+              </a:spcAft>
+            </a:pPr>
+            <a:r>
+              <a:rPr sz="1700" b="1">
+                <a:solidFill>
+                  <a:srgbClr val="1B2025"/>
+                </a:solidFill>
+                <a:latin typeface="Avenir Next"/>
+              </a:rPr>
+              <a:t>hand-engineered  →  Pipeline </a:t>
+            </a:r>
+            <a:r>
+              <a:rPr sz="1700" b="1">
+                <a:solidFill>
+                  <a:srgbClr val="0E7C7B"/>
+                </a:solidFill>
+                <a:latin typeface="Avenir Next"/>
+              </a:rPr>
+              <a:t>________</a:t>
+            </a:r>
+            <a:r>
+              <a:rPr sz="1700" b="1">
+                <a:solidFill>
+                  <a:srgbClr val="1B2025"/>
+                </a:solidFill>
+                <a:latin typeface="Avenir Next"/>
+              </a:rPr>
+              <a:t>          learned  →  Pipeline </a:t>
+            </a:r>
+            <a:r>
+              <a:rPr sz="1700" b="1">
+                <a:solidFill>
+                  <a:srgbClr val="0E7C7B"/>
+                </a:solidFill>
+                <a:latin typeface="Avenir Next"/>
+              </a:rPr>
+              <a:t>________</a:t>
             </a:r>
           </a:p>
         </p:txBody>
       </p:sp>
     </p:spTree>
-    <p:extLst>
-      <p:ext uri="{BB962C8B-B14F-4D97-AF65-F5344CB8AC3E}">
-        <p14:creationId xmlns:p14="http://schemas.microsoft.com/office/powerpoint/2010/main" val="3712791734"/>
-      </p:ext>
-    </p:extLst>
   </p:cSld>
   <p:clrMapOvr>
     <a:masterClrMapping/>
@@ -3151,6 +3511,125 @@
           <p:cNvPr id="2" name="Title 1">
             <a:extLst>
               <a:ext uri="{FF2B5EF4-FFF2-40B4-BE49-F238E27FC236}">
+                <a16:creationId xmlns:a16="http://schemas.microsoft.com/office/drawing/2014/main" id="{D6AB81F4-B2FF-068C-190A-C106497FA303}"/>
+              </a:ext>
+            </a:extLst>
+          </p:cNvPr>
+          <p:cNvSpPr>
+            <a:spLocks noGrp="1"/>
+          </p:cNvSpPr>
+          <p:nvPr>
+            <p:ph type="ctrTitle"/>
+          </p:nvPr>
+        </p:nvSpPr>
+        <p:spPr/>
+        <p:txBody>
+          <a:bodyPr/>
+          <a:lstStyle/>
+          <a:p>
+            <a:r>
+              <a:rPr lang="en-US" dirty="0"/>
+              <a:t>Theory Fundamentals</a:t>
+            </a:r>
+          </a:p>
+        </p:txBody>
+      </p:sp>
+      <p:sp>
+        <p:nvSpPr>
+          <p:cNvPr id="3" name="Subtitle 2">
+            <a:extLst>
+              <a:ext uri="{FF2B5EF4-FFF2-40B4-BE49-F238E27FC236}">
+                <a16:creationId xmlns:a16="http://schemas.microsoft.com/office/drawing/2014/main" id="{7A9C44CD-5B94-8AE3-FEDD-36103A713499}"/>
+              </a:ext>
+            </a:extLst>
+          </p:cNvPr>
+          <p:cNvSpPr>
+            <a:spLocks noGrp="1"/>
+          </p:cNvSpPr>
+          <p:nvPr>
+            <p:ph type="subTitle" idx="1"/>
+          </p:nvPr>
+        </p:nvSpPr>
+        <p:spPr/>
+        <p:txBody>
+          <a:bodyPr/>
+          <a:lstStyle/>
+          <a:p>
+            <a:r>
+              <a:rPr lang="en-US" dirty="0"/>
+              <a:t>The “simple” math behind the neural networks</a:t>
+            </a:r>
+          </a:p>
+        </p:txBody>
+      </p:sp>
+      <p:sp>
+        <p:nvSpPr>
+          <p:cNvPr id="4" name="Text Placeholder 3">
+            <a:extLst>
+              <a:ext uri="{FF2B5EF4-FFF2-40B4-BE49-F238E27FC236}">
+                <a16:creationId xmlns:a16="http://schemas.microsoft.com/office/drawing/2014/main" id="{6ABB0AFC-E766-C851-5E5A-57A0340DDFF0}"/>
+              </a:ext>
+            </a:extLst>
+          </p:cNvPr>
+          <p:cNvSpPr>
+            <a:spLocks noGrp="1"/>
+          </p:cNvSpPr>
+          <p:nvPr>
+            <p:ph type="body" sz="quarter" idx="13"/>
+          </p:nvPr>
+        </p:nvSpPr>
+        <p:spPr/>
+        <p:txBody>
+          <a:bodyPr/>
+          <a:lstStyle/>
+          <a:p>
+            <a:r>
+              <a:rPr sz="1300" b="1" i="0">
+                <a:solidFill>
+                  <a:srgbClr val="8A9099"/>
+                </a:solidFill>
+                <a:latin typeface="Menlo"/>
+              </a:rPr>
+              <a:t>LECTURE 1 · THEORY FUNDAMENTALS</a:t>
+            </a:r>
+          </a:p>
+        </p:txBody>
+      </p:sp>
+    </p:spTree>
+    <p:extLst>
+      <p:ext uri="{BB962C8B-B14F-4D97-AF65-F5344CB8AC3E}">
+        <p14:creationId xmlns:p14="http://schemas.microsoft.com/office/powerpoint/2010/main" val="3712791734"/>
+      </p:ext>
+    </p:extLst>
+  </p:cSld>
+  <p:clrMapOvr>
+    <a:masterClrMapping/>
+  </p:clrMapOvr>
+</p:sld>
+</file>
+
+<file path=ppt/slides/slide12.xml><?xml version="1.0" encoding="utf-8"?>
+<p:sld xmlns:a="http://schemas.openxmlformats.org/drawingml/2006/main" xmlns:r="http://schemas.openxmlformats.org/officeDocument/2006/relationships" xmlns:p="http://schemas.openxmlformats.org/presentationml/2006/main">
+  <p:cSld>
+    <p:spTree>
+      <p:nvGrpSpPr>
+        <p:cNvPr id="1" name=""/>
+        <p:cNvGrpSpPr/>
+        <p:nvPr/>
+      </p:nvGrpSpPr>
+      <p:grpSpPr>
+        <a:xfrm>
+          <a:off x="0" y="0"/>
+          <a:ext cx="0" cy="0"/>
+          <a:chOff x="0" y="0"/>
+          <a:chExt cx="0" cy="0"/>
+        </a:xfrm>
+      </p:grpSpPr>
+      <p:sp>
+        <p:nvSpPr>
+          <p:cNvPr id="2" name="Title 1">
+            <a:extLst>
+              <a:ext uri="{FF2B5EF4-FFF2-40B4-BE49-F238E27FC236}">
                 <a16:creationId xmlns:a16="http://schemas.microsoft.com/office/drawing/2014/main" id="{0184CEE6-6646-5540-BB09-6449CC7486C3}"/>
               </a:ext>
             </a:extLst>
@@ -3252,7 +3731,7 @@
 </p:sld>
 </file>
 
-<file path=ppt/slides/slide12.xml><?xml version="1.0" encoding="utf-8"?>
+<file path=ppt/slides/slide13.xml><?xml version="1.0" encoding="utf-8"?>
 <p:sld xmlns:a="http://schemas.openxmlformats.org/drawingml/2006/main" xmlns:r="http://schemas.openxmlformats.org/officeDocument/2006/relationships" xmlns:p="http://schemas.openxmlformats.org/presentationml/2006/main">
   <p:cSld>
     <p:spTree>
@@ -4104,7 +4583,7 @@
 </p:sld>
 </file>
 
-<file path=ppt/slides/slide13.xml><?xml version="1.0" encoding="utf-8"?>
+<file path=ppt/slides/slide14.xml><?xml version="1.0" encoding="utf-8"?>
 <p:sld xmlns:a="http://schemas.openxmlformats.org/drawingml/2006/main" xmlns:r="http://schemas.openxmlformats.org/officeDocument/2006/relationships" xmlns:p="http://schemas.openxmlformats.org/presentationml/2006/main">
   <p:cSld>
     <p:spTree>
@@ -4195,7 +4674,7 @@
                 </a:solidFill>
                 <a:latin typeface="Menlo"/>
               </a:rPr>
-              <a:t>THE NEURON · YOUR TURN (YOU-DO)</a:t>
+              <a:t>THE NEURON · YOUR TURN (YOU-DO = Q1)</a:t>
             </a:r>
           </a:p>
         </p:txBody>
@@ -4521,259 +5000,6 @@
 </p:sld>
 </file>
 
-<file path=ppt/slides/slide14.xml><?xml version="1.0" encoding="utf-8"?>
-<p:sld xmlns:a="http://schemas.openxmlformats.org/drawingml/2006/main" xmlns:r="http://schemas.openxmlformats.org/officeDocument/2006/relationships" xmlns:p="http://schemas.openxmlformats.org/presentationml/2006/main">
-  <p:cSld>
-    <p:spTree>
-      <p:nvGrpSpPr>
-        <p:cNvPr id="1" name=""/>
-        <p:cNvGrpSpPr/>
-        <p:nvPr/>
-      </p:nvGrpSpPr>
-      <p:grpSpPr>
-        <a:xfrm>
-          <a:off x="0" y="0"/>
-          <a:ext cx="0" cy="0"/>
-          <a:chOff x="0" y="0"/>
-          <a:chExt cx="0" cy="0"/>
-        </a:xfrm>
-      </p:grpSpPr>
-      <p:sp>
-        <p:nvSpPr>
-          <p:cNvPr id="2" name="Rectangle 1"/>
-          <p:cNvSpPr/>
-          <p:nvPr/>
-        </p:nvSpPr>
-        <p:spPr>
-          <a:xfrm>
-            <a:off x="0" y="0"/>
-            <a:ext cx="12191695" cy="6858000"/>
-          </a:xfrm>
-          <a:prstGeom prst="rect">
-            <a:avLst/>
-          </a:prstGeom>
-          <a:solidFill>
-            <a:srgbClr val="FBFBF8"/>
-          </a:solidFill>
-          <a:ln>
-            <a:noFill/>
-          </a:ln>
-          <a:effectLst/>
-        </p:spPr>
-        <p:style>
-          <a:lnRef idx="1">
-            <a:schemeClr val="accent1"/>
-          </a:lnRef>
-          <a:fillRef idx="3">
-            <a:schemeClr val="accent1"/>
-          </a:fillRef>
-          <a:effectRef idx="2">
-            <a:schemeClr val="accent1"/>
-          </a:effectRef>
-          <a:fontRef idx="minor">
-            <a:schemeClr val="lt1"/>
-          </a:fontRef>
-        </p:style>
-        <p:txBody>
-          <a:bodyPr rtlCol="0" anchor="ctr"/>
-          <a:lstStyle/>
-          <a:p>
-            <a:pPr algn="ctr"/>
-            <a:endParaRPr/>
-          </a:p>
-        </p:txBody>
-      </p:sp>
-      <p:sp>
-        <p:nvSpPr>
-          <p:cNvPr id="3" name="TextBox 2"/>
-          <p:cNvSpPr txBox="1"/>
-          <p:nvPr/>
-        </p:nvSpPr>
-        <p:spPr>
-          <a:xfrm>
-            <a:off x="548640" y="320040"/>
-            <a:ext cx="10972800" cy="365760"/>
-          </a:xfrm>
-          <a:prstGeom prst="rect">
-            <a:avLst/>
-          </a:prstGeom>
-          <a:noFill/>
-        </p:spPr>
-        <p:txBody>
-          <a:bodyPr wrap="square" anchor="t">
-            <a:spAutoFit/>
-          </a:bodyPr>
-          <a:lstStyle/>
-          <a:p>
-            <a:r>
-              <a:rPr sz="1300" b="1" i="0">
-                <a:solidFill>
-                  <a:srgbClr val="8A9099"/>
-                </a:solidFill>
-                <a:latin typeface="Menlo"/>
-              </a:rPr>
-              <a:t>THE NEURON · WORKED BY HAND (I-DO)</a:t>
-            </a:r>
-          </a:p>
-        </p:txBody>
-      </p:sp>
-      <p:sp>
-        <p:nvSpPr>
-          <p:cNvPr id="4" name="TextBox 3"/>
-          <p:cNvSpPr txBox="1"/>
-          <p:nvPr/>
-        </p:nvSpPr>
-        <p:spPr>
-          <a:xfrm>
-            <a:off x="548640" y="731520"/>
-            <a:ext cx="11064240" cy="1005840"/>
-          </a:xfrm>
-          <a:prstGeom prst="rect">
-            <a:avLst/>
-          </a:prstGeom>
-          <a:noFill/>
-        </p:spPr>
-        <p:txBody>
-          <a:bodyPr wrap="square" anchor="t">
-            <a:spAutoFit/>
-          </a:bodyPr>
-          <a:lstStyle/>
-          <a:p>
-            <a:r>
-              <a:rPr sz="3400" b="1" i="0">
-                <a:solidFill>
-                  <a:srgbClr val="1B2025"/>
-                </a:solidFill>
-                <a:latin typeface="Avenir Next"/>
-              </a:rPr>
-              <a:t>One neuron, real numbers</a:t>
-            </a:r>
-          </a:p>
-        </p:txBody>
-      </p:sp>
-      <p:pic>
-        <p:nvPicPr>
-          <p:cNvPr id="5" name="Picture 4" descr="fig_neuron_ido.png"/>
-          <p:cNvPicPr>
-            <a:picLocks noChangeAspect="1"/>
-          </p:cNvPicPr>
-          <p:nvPr/>
-        </p:nvPicPr>
-        <p:blipFill>
-          <a:blip r:embed="rId3"/>
-          <a:stretch>
-            <a:fillRect/>
-          </a:stretch>
-        </p:blipFill>
-        <p:spPr>
-          <a:xfrm>
-            <a:off x="2632553" y="1828800"/>
-            <a:ext cx="6896413" cy="3200400"/>
-          </a:xfrm>
-          <a:prstGeom prst="rect">
-            <a:avLst/>
-          </a:prstGeom>
-        </p:spPr>
-      </p:pic>
-      <p:sp>
-        <p:nvSpPr>
-          <p:cNvPr id="6" name="Rectangle 5"/>
-          <p:cNvSpPr/>
-          <p:nvPr/>
-        </p:nvSpPr>
-        <p:spPr>
-          <a:xfrm>
-            <a:off x="548640" y="5120640"/>
-            <a:ext cx="10515600" cy="914400"/>
-          </a:xfrm>
-          <a:prstGeom prst="rect">
-            <a:avLst/>
-          </a:prstGeom>
-          <a:solidFill>
-            <a:srgbClr val="E3F0EF"/>
-          </a:solidFill>
-          <a:ln w="12700">
-            <a:solidFill>
-              <a:srgbClr val="0E7C7B"/>
-            </a:solidFill>
-          </a:ln>
-          <a:effectLst/>
-        </p:spPr>
-        <p:style>
-          <a:lnRef idx="1">
-            <a:schemeClr val="accent1"/>
-          </a:lnRef>
-          <a:fillRef idx="3">
-            <a:schemeClr val="accent1"/>
-          </a:fillRef>
-          <a:effectRef idx="2">
-            <a:schemeClr val="accent1"/>
-          </a:effectRef>
-          <a:fontRef idx="minor">
-            <a:schemeClr val="lt1"/>
-          </a:fontRef>
-        </p:style>
-        <p:txBody>
-          <a:bodyPr wrap="square" lIns="182880" rIns="182880" rtlCol="0" anchor="ctr"/>
-          <a:lstStyle/>
-          <a:p>
-            <a:pPr algn="ctr"/>
-            <a:r>
-              <a:rPr lang="en-US" sz="1200" b="1" i="0" dirty="0">
-                <a:solidFill>
-                  <a:srgbClr val="0E7C7B"/>
-                </a:solidFill>
-                <a:latin typeface="Menlo"/>
-              </a:rPr>
-              <a:t>Math</a:t>
-            </a:r>
-            <a:r>
-              <a:rPr sz="1200" b="1" i="0" dirty="0">
-                <a:solidFill>
-                  <a:srgbClr val="0E7C7B"/>
-                </a:solidFill>
-                <a:latin typeface="Menlo"/>
-              </a:rPr>
-              <a:t>· </a:t>
-            </a:r>
-            <a:r>
-              <a:rPr sz="1700" b="0" i="0" dirty="0">
-                <a:solidFill>
-                  <a:srgbClr val="3D444C"/>
-                </a:solidFill>
-                <a:latin typeface="Avenir Next"/>
-              </a:rPr>
-              <a:t>z = (2·3) + (−1·2) + 1 = 5, so </a:t>
-            </a:r>
-            <a:r>
-              <a:rPr sz="1700" b="0" i="0" dirty="0" err="1">
-                <a:solidFill>
-                  <a:srgbClr val="3D444C"/>
-                </a:solidFill>
-                <a:latin typeface="Avenir Next"/>
-              </a:rPr>
-              <a:t>ReLU</a:t>
-            </a:r>
-            <a:r>
-              <a:rPr sz="1700" b="0" i="0" dirty="0">
-                <a:solidFill>
-                  <a:srgbClr val="3D444C"/>
-                </a:solidFill>
-                <a:latin typeface="Avenir Next"/>
-              </a:rPr>
-              <a:t>(5) = 5 — the neuron fires. Read x as two peak intensities: this neuron likes input 1 and distrusts input 2.</a:t>
-            </a:r>
-          </a:p>
-        </p:txBody>
-      </p:sp>
-    </p:spTree>
-  </p:cSld>
-  <p:clrMapOvr>
-    <a:masterClrMapping/>
-  </p:clrMapOvr>
-</p:sld>
-</file>
-
 <file path=ppt/slides/slide15.xml><?xml version="1.0" encoding="utf-8"?>
 <p:sld xmlns:a="http://schemas.openxmlformats.org/drawingml/2006/main" xmlns:r="http://schemas.openxmlformats.org/officeDocument/2006/relationships" xmlns:p="http://schemas.openxmlformats.org/presentationml/2006/main">
   <p:cSld>
@@ -4865,7 +5091,7 @@
                 </a:solidFill>
                 <a:latin typeface="Menlo"/>
               </a:rPr>
-              <a:t>THE NEURON · YOUR TURN (YOU-DO)</a:t>
+              <a:t>THE NEURON · WORKED BY HAND (I-DO)</a:t>
             </a:r>
           </a:p>
         </p:txBody>
@@ -4899,14 +5125,14 @@
                 </a:solidFill>
                 <a:latin typeface="Avenir Next"/>
               </a:rPr>
-              <a:t>Your neuron — compute it</a:t>
+              <a:t>One neuron, real numbers</a:t>
             </a:r>
           </a:p>
         </p:txBody>
       </p:sp>
       <p:pic>
         <p:nvPicPr>
-          <p:cNvPr id="5" name="Picture 4" descr="fig_neuron_youdo.png"/>
+          <p:cNvPr id="5" name="Picture 4" descr="fig_neuron_ido.png"/>
           <p:cNvPicPr>
             <a:picLocks noChangeAspect="1"/>
           </p:cNvPicPr>
@@ -4943,11 +5169,11 @@
             <a:avLst/>
           </a:prstGeom>
           <a:solidFill>
-            <a:srgbClr val="F1F1EC"/>
+            <a:srgbClr val="E3F0EF"/>
           </a:solidFill>
           <a:ln w="12700">
             <a:solidFill>
-              <a:srgbClr val="E09E2F"/>
+              <a:srgbClr val="0E7C7B"/>
             </a:solidFill>
           </a:ln>
           <a:effectLst/>
@@ -4972,22 +5198,49 @@
           <a:p>
             <a:pPr algn="ctr"/>
             <a:r>
-              <a:rPr sz="1200" b="1" i="0">
-                <a:solidFill>
-                  <a:srgbClr val="E09E2F"/>
+              <a:rPr lang="en-US" sz="1200" b="1" i="0" dirty="0">
+                <a:solidFill>
+                  <a:srgbClr val="0E7C7B"/>
                 </a:solidFill>
                 <a:latin typeface="Menlo"/>
               </a:rPr>
-              <a:t>CHECKPOINT · </a:t>
-            </a:r>
-            <a:r>
-              <a:rPr sz="1700" b="0" i="0">
+              <a:t>Math</a:t>
+            </a:r>
+            <a:r>
+              <a:rPr sz="1200" b="1" i="0" dirty="0">
+                <a:solidFill>
+                  <a:srgbClr val="0E7C7B"/>
+                </a:solidFill>
+                <a:latin typeface="Menlo"/>
+              </a:rPr>
+              <a:t>· </a:t>
+            </a:r>
+            <a:r>
+              <a:rPr sz="1700" b="0" i="0" dirty="0">
                 <a:solidFill>
                   <a:srgbClr val="3D444C"/>
                 </a:solidFill>
                 <a:latin typeface="Avenir Next"/>
               </a:rPr>
-              <a:t>Your turn → Quiz 1, Q2. Compute z = w·x + b, then apply ReLU. 90 seconds with a neighbour — worked answer in the notes.</a:t>
+              <a:t>z = (2·3) + (−1·2) + 1 = 5, so </a:t>
+            </a:r>
+            <a:r>
+              <a:rPr sz="1700" b="0" i="0" dirty="0" err="1">
+                <a:solidFill>
+                  <a:srgbClr val="3D444C"/>
+                </a:solidFill>
+                <a:latin typeface="Avenir Next"/>
+              </a:rPr>
+              <a:t>ReLU</a:t>
+            </a:r>
+            <a:r>
+              <a:rPr sz="1700" b="0" i="0" dirty="0">
+                <a:solidFill>
+                  <a:srgbClr val="3D444C"/>
+                </a:solidFill>
+                <a:latin typeface="Avenir Next"/>
+              </a:rPr>
+              <a:t>(5) = 5 — the neuron fires. Read x as two peak intensities: this neuron likes input 1 and distrusts input 2.</a:t>
             </a:r>
           </a:p>
         </p:txBody>
@@ -5091,7 +5344,7 @@
                 </a:solidFill>
                 <a:latin typeface="Menlo"/>
               </a:rPr>
-              <a:t>STACKING · A LAYER IS A MATRIX, ROW 1 (I-DO)</a:t>
+              <a:t>THE NEURON · YOUR TURN (YOU-DO = Q2)</a:t>
             </a:r>
           </a:p>
         </p:txBody>
@@ -5125,14 +5378,14 @@
                 </a:solidFill>
                 <a:latin typeface="Avenir Next"/>
               </a:rPr>
-              <a:t>Two neurons, three inputs — row 1</a:t>
+              <a:t>Your neuron — compute it</a:t>
             </a:r>
           </a:p>
         </p:txBody>
       </p:sp>
       <p:pic>
         <p:nvPicPr>
-          <p:cNvPr id="5" name="Picture 4" descr="fig_matvec_row1.png"/>
+          <p:cNvPr id="5" name="Picture 4" descr="fig_neuron_youdo.png"/>
           <p:cNvPicPr>
             <a:picLocks noChangeAspect="1"/>
           </p:cNvPicPr>
@@ -5146,8 +5399,8 @@
         </p:blipFill>
         <p:spPr>
           <a:xfrm>
-            <a:off x="1573154" y="1828800"/>
-            <a:ext cx="9015211" cy="3200400"/>
+            <a:off x="2632553" y="1828800"/>
+            <a:ext cx="6896413" cy="3200400"/>
           </a:xfrm>
           <a:prstGeom prst="rect">
             <a:avLst/>
@@ -5173,7 +5426,7 @@
           </a:solidFill>
           <a:ln w="12700">
             <a:solidFill>
-              <a:srgbClr val="3D444C"/>
+              <a:srgbClr val="E09E2F"/>
             </a:solidFill>
           </a:ln>
           <a:effectLst/>
@@ -5198,13 +5451,22 @@
           <a:p>
             <a:pPr algn="ctr"/>
             <a:r>
+              <a:rPr sz="1200" b="1" i="0">
+                <a:solidFill>
+                  <a:srgbClr val="E09E2F"/>
+                </a:solidFill>
+                <a:latin typeface="Menlo"/>
+              </a:rPr>
+              <a:t>CHECKPOINT · </a:t>
+            </a:r>
+            <a:r>
               <a:rPr sz="1700" b="0" i="0">
                 <a:solidFill>
                   <a:srgbClr val="3D444C"/>
                 </a:solidFill>
                 <a:latin typeface="Avenir Next"/>
               </a:rPr>
-              <a:t>Each ROW of W is one neuron; running the layer is W·x. Shapes must click: 3 inputs → 3 columns · 2 neurons → 2 rows → 2 outputs. Row 1 = (1·2)+(0·1)+(2·0) = 2.</a:t>
+              <a:t>Your turn → Quiz 1, Q2. Compute z = w·x + b, then apply ReLU. 90 seconds with a neighbour — worked answer in the notes.</a:t>
             </a:r>
           </a:p>
         </p:txBody>
@@ -5308,6 +5570,223 @@
                 </a:solidFill>
                 <a:latin typeface="Menlo"/>
               </a:rPr>
+              <a:t>STACKING · A LAYER IS A MATRIX, ROW 1 (I-DO)</a:t>
+            </a:r>
+          </a:p>
+        </p:txBody>
+      </p:sp>
+      <p:sp>
+        <p:nvSpPr>
+          <p:cNvPr id="4" name="TextBox 3"/>
+          <p:cNvSpPr txBox="1"/>
+          <p:nvPr/>
+        </p:nvSpPr>
+        <p:spPr>
+          <a:xfrm>
+            <a:off x="548640" y="731520"/>
+            <a:ext cx="11064240" cy="1005840"/>
+          </a:xfrm>
+          <a:prstGeom prst="rect">
+            <a:avLst/>
+          </a:prstGeom>
+          <a:noFill/>
+        </p:spPr>
+        <p:txBody>
+          <a:bodyPr wrap="square" anchor="t">
+            <a:spAutoFit/>
+          </a:bodyPr>
+          <a:lstStyle/>
+          <a:p>
+            <a:r>
+              <a:rPr sz="3400" b="1" i="0">
+                <a:solidFill>
+                  <a:srgbClr val="1B2025"/>
+                </a:solidFill>
+                <a:latin typeface="Avenir Next"/>
+              </a:rPr>
+              <a:t>Two neurons, three inputs — row 1</a:t>
+            </a:r>
+          </a:p>
+        </p:txBody>
+      </p:sp>
+      <p:pic>
+        <p:nvPicPr>
+          <p:cNvPr id="5" name="Picture 4" descr="fig_matvec_row1.png"/>
+          <p:cNvPicPr>
+            <a:picLocks noChangeAspect="1"/>
+          </p:cNvPicPr>
+          <p:nvPr/>
+        </p:nvPicPr>
+        <p:blipFill>
+          <a:blip r:embed="rId3"/>
+          <a:stretch>
+            <a:fillRect/>
+          </a:stretch>
+        </p:blipFill>
+        <p:spPr>
+          <a:xfrm>
+            <a:off x="1573154" y="1828800"/>
+            <a:ext cx="9015211" cy="3200400"/>
+          </a:xfrm>
+          <a:prstGeom prst="rect">
+            <a:avLst/>
+          </a:prstGeom>
+        </p:spPr>
+      </p:pic>
+      <p:sp>
+        <p:nvSpPr>
+          <p:cNvPr id="6" name="Rectangle 5"/>
+          <p:cNvSpPr/>
+          <p:nvPr/>
+        </p:nvSpPr>
+        <p:spPr>
+          <a:xfrm>
+            <a:off x="548640" y="5120640"/>
+            <a:ext cx="10515600" cy="914400"/>
+          </a:xfrm>
+          <a:prstGeom prst="rect">
+            <a:avLst/>
+          </a:prstGeom>
+          <a:solidFill>
+            <a:srgbClr val="F1F1EC"/>
+          </a:solidFill>
+          <a:ln w="12700">
+            <a:solidFill>
+              <a:srgbClr val="3D444C"/>
+            </a:solidFill>
+          </a:ln>
+          <a:effectLst/>
+        </p:spPr>
+        <p:style>
+          <a:lnRef idx="1">
+            <a:schemeClr val="accent1"/>
+          </a:lnRef>
+          <a:fillRef idx="3">
+            <a:schemeClr val="accent1"/>
+          </a:fillRef>
+          <a:effectRef idx="2">
+            <a:schemeClr val="accent1"/>
+          </a:effectRef>
+          <a:fontRef idx="minor">
+            <a:schemeClr val="lt1"/>
+          </a:fontRef>
+        </p:style>
+        <p:txBody>
+          <a:bodyPr wrap="square" lIns="182880" rIns="182880" rtlCol="0" anchor="ctr"/>
+          <a:lstStyle/>
+          <a:p>
+            <a:pPr algn="ctr"/>
+            <a:r>
+              <a:rPr sz="1700" b="0" i="0">
+                <a:solidFill>
+                  <a:srgbClr val="3D444C"/>
+                </a:solidFill>
+                <a:latin typeface="Avenir Next"/>
+              </a:rPr>
+              <a:t>Each ROW of W is one neuron; running the layer is W·x. Shapes must click: 3 inputs → 3 columns · 2 neurons → 2 rows → 2 outputs. Row 1 = (1·2)+(0·1)+(2·0) = 2.</a:t>
+            </a:r>
+          </a:p>
+        </p:txBody>
+      </p:sp>
+    </p:spTree>
+  </p:cSld>
+  <p:clrMapOvr>
+    <a:masterClrMapping/>
+  </p:clrMapOvr>
+</p:sld>
+</file>
+
+<file path=ppt/slides/slide18.xml><?xml version="1.0" encoding="utf-8"?>
+<p:sld xmlns:a="http://schemas.openxmlformats.org/drawingml/2006/main" xmlns:r="http://schemas.openxmlformats.org/officeDocument/2006/relationships" xmlns:p="http://schemas.openxmlformats.org/presentationml/2006/main">
+  <p:cSld>
+    <p:spTree>
+      <p:nvGrpSpPr>
+        <p:cNvPr id="1" name=""/>
+        <p:cNvGrpSpPr/>
+        <p:nvPr/>
+      </p:nvGrpSpPr>
+      <p:grpSpPr>
+        <a:xfrm>
+          <a:off x="0" y="0"/>
+          <a:ext cx="0" cy="0"/>
+          <a:chOff x="0" y="0"/>
+          <a:chExt cx="0" cy="0"/>
+        </a:xfrm>
+      </p:grpSpPr>
+      <p:sp>
+        <p:nvSpPr>
+          <p:cNvPr id="2" name="Rectangle 1"/>
+          <p:cNvSpPr/>
+          <p:nvPr/>
+        </p:nvSpPr>
+        <p:spPr>
+          <a:xfrm>
+            <a:off x="0" y="0"/>
+            <a:ext cx="12191695" cy="6858000"/>
+          </a:xfrm>
+          <a:prstGeom prst="rect">
+            <a:avLst/>
+          </a:prstGeom>
+          <a:solidFill>
+            <a:srgbClr val="FBFBF8"/>
+          </a:solidFill>
+          <a:ln>
+            <a:noFill/>
+          </a:ln>
+          <a:effectLst/>
+        </p:spPr>
+        <p:style>
+          <a:lnRef idx="1">
+            <a:schemeClr val="accent1"/>
+          </a:lnRef>
+          <a:fillRef idx="3">
+            <a:schemeClr val="accent1"/>
+          </a:fillRef>
+          <a:effectRef idx="2">
+            <a:schemeClr val="accent1"/>
+          </a:effectRef>
+          <a:fontRef idx="minor">
+            <a:schemeClr val="lt1"/>
+          </a:fontRef>
+        </p:style>
+        <p:txBody>
+          <a:bodyPr rtlCol="0" anchor="ctr"/>
+          <a:lstStyle/>
+          <a:p>
+            <a:pPr algn="ctr"/>
+            <a:endParaRPr/>
+          </a:p>
+        </p:txBody>
+      </p:sp>
+      <p:sp>
+        <p:nvSpPr>
+          <p:cNvPr id="3" name="TextBox 2"/>
+          <p:cNvSpPr txBox="1"/>
+          <p:nvPr/>
+        </p:nvSpPr>
+        <p:spPr>
+          <a:xfrm>
+            <a:off x="548640" y="320040"/>
+            <a:ext cx="10972800" cy="365760"/>
+          </a:xfrm>
+          <a:prstGeom prst="rect">
+            <a:avLst/>
+          </a:prstGeom>
+          <a:noFill/>
+        </p:spPr>
+        <p:txBody>
+          <a:bodyPr wrap="square" anchor="t">
+            <a:spAutoFit/>
+          </a:bodyPr>
+          <a:lstStyle/>
+          <a:p>
+            <a:r>
+              <a:rPr sz="1300" b="1" i="0">
+                <a:solidFill>
+                  <a:srgbClr val="8A9099"/>
+                </a:solidFill>
+                <a:latin typeface="Menlo"/>
+              </a:rPr>
               <a:t>STACKING · YOUR TURN, ROW 2 (YOU-DO)</a:t>
             </a:r>
           </a:p>
@@ -5443,7 +5922,7 @@
 </p:sld>
 </file>
 
-<file path=ppt/slides/slide18.xml><?xml version="1.0" encoding="utf-8"?>
+<file path=ppt/slides/slide19.xml><?xml version="1.0" encoding="utf-8"?>
 <p:sld xmlns:a="http://schemas.openxmlformats.org/drawingml/2006/main" xmlns:r="http://schemas.openxmlformats.org/officeDocument/2006/relationships" xmlns:p="http://schemas.openxmlformats.org/presentationml/2006/main">
   <p:cSld>
     <p:spTree>
@@ -5879,340 +6358,6 @@
       <p:bldP spid="6" grpId="0" animBg="1"/>
     </p:bldLst>
   </p:timing>
-</p:sld>
-</file>
-
-<file path=ppt/slides/slide19.xml><?xml version="1.0" encoding="utf-8"?>
-<p:sld xmlns:a="http://schemas.openxmlformats.org/drawingml/2006/main" xmlns:r="http://schemas.openxmlformats.org/officeDocument/2006/relationships" xmlns:p="http://schemas.openxmlformats.org/presentationml/2006/main">
-  <p:cSld>
-    <p:spTree>
-      <p:nvGrpSpPr>
-        <p:cNvPr id="1" name=""/>
-        <p:cNvGrpSpPr/>
-        <p:nvPr/>
-      </p:nvGrpSpPr>
-      <p:grpSpPr>
-        <a:xfrm>
-          <a:off x="0" y="0"/>
-          <a:ext cx="0" cy="0"/>
-          <a:chOff x="0" y="0"/>
-          <a:chExt cx="0" cy="0"/>
-        </a:xfrm>
-      </p:grpSpPr>
-      <p:sp>
-        <p:nvSpPr>
-          <p:cNvPr id="2" name="Rectangle 1"/>
-          <p:cNvSpPr/>
-          <p:nvPr/>
-        </p:nvSpPr>
-        <p:spPr>
-          <a:xfrm>
-            <a:off x="0" y="0"/>
-            <a:ext cx="12191695" cy="6858000"/>
-          </a:xfrm>
-          <a:prstGeom prst="rect">
-            <a:avLst/>
-          </a:prstGeom>
-          <a:solidFill>
-            <a:srgbClr val="FBFBF8"/>
-          </a:solidFill>
-          <a:ln>
-            <a:noFill/>
-          </a:ln>
-          <a:effectLst/>
-        </p:spPr>
-        <p:style>
-          <a:lnRef idx="1">
-            <a:schemeClr val="accent1"/>
-          </a:lnRef>
-          <a:fillRef idx="3">
-            <a:schemeClr val="accent1"/>
-          </a:fillRef>
-          <a:effectRef idx="2">
-            <a:schemeClr val="accent1"/>
-          </a:effectRef>
-          <a:fontRef idx="minor">
-            <a:schemeClr val="lt1"/>
-          </a:fontRef>
-        </p:style>
-        <p:txBody>
-          <a:bodyPr rtlCol="0" anchor="ctr"/>
-          <a:lstStyle/>
-          <a:p>
-            <a:pPr algn="ctr"/>
-            <a:endParaRPr/>
-          </a:p>
-        </p:txBody>
-      </p:sp>
-      <p:sp>
-        <p:nvSpPr>
-          <p:cNvPr id="3" name="TextBox 2"/>
-          <p:cNvSpPr txBox="1"/>
-          <p:nvPr/>
-        </p:nvSpPr>
-        <p:spPr>
-          <a:xfrm>
-            <a:off x="548640" y="320040"/>
-            <a:ext cx="10972800" cy="365760"/>
-          </a:xfrm>
-          <a:prstGeom prst="rect">
-            <a:avLst/>
-          </a:prstGeom>
-          <a:noFill/>
-        </p:spPr>
-        <p:txBody>
-          <a:bodyPr wrap="square" anchor="t">
-            <a:spAutoFit/>
-          </a:bodyPr>
-          <a:lstStyle/>
-          <a:p>
-            <a:r>
-              <a:rPr sz="1300" b="1" i="0">
-                <a:solidFill>
-                  <a:srgbClr val="8A9099"/>
-                </a:solidFill>
-                <a:latin typeface="Menlo"/>
-              </a:rPr>
-              <a:t>STACKING · ONE LAYER FEEDS THE NEXT (I-DO)</a:t>
-            </a:r>
-          </a:p>
-        </p:txBody>
-      </p:sp>
-      <p:sp>
-        <p:nvSpPr>
-          <p:cNvPr id="4" name="TextBox 3"/>
-          <p:cNvSpPr txBox="1"/>
-          <p:nvPr/>
-        </p:nvSpPr>
-        <p:spPr>
-          <a:xfrm>
-            <a:off x="548640" y="731520"/>
-            <a:ext cx="11064240" cy="1127760"/>
-          </a:xfrm>
-          <a:prstGeom prst="rect">
-            <a:avLst/>
-          </a:prstGeom>
-          <a:noFill/>
-        </p:spPr>
-        <p:txBody>
-          <a:bodyPr wrap="square" anchor="t">
-            <a:spAutoFit/>
-          </a:bodyPr>
-          <a:lstStyle/>
-          <a:p>
-            <a:r>
-              <a:rPr sz="3400" b="1" i="0">
-                <a:solidFill>
-                  <a:srgbClr val="1B2025"/>
-                </a:solidFill>
-                <a:latin typeface="Avenir Next"/>
-              </a:rPr>
-              <a:t>Deep = repeat the move, feeding each layer the last</a:t>
-            </a:r>
-          </a:p>
-        </p:txBody>
-      </p:sp>
-      <p:pic>
-        <p:nvPicPr>
-          <p:cNvPr id="5" name="Picture 4" descr="fig_twolayer_ido.png"/>
-          <p:cNvPicPr>
-            <a:picLocks noChangeAspect="1"/>
-          </p:cNvPicPr>
-          <p:nvPr/>
-        </p:nvPicPr>
-        <p:blipFill>
-          <a:blip r:embed="rId3"/>
-          <a:stretch>
-            <a:fillRect/>
-          </a:stretch>
-        </p:blipFill>
-        <p:spPr>
-          <a:xfrm>
-            <a:off x="2814598" y="1828800"/>
-            <a:ext cx="6532323" cy="3200400"/>
-          </a:xfrm>
-          <a:prstGeom prst="rect">
-            <a:avLst/>
-          </a:prstGeom>
-        </p:spPr>
-      </p:pic>
-      <p:sp>
-        <p:nvSpPr>
-          <p:cNvPr id="6" name="Rectangle 5"/>
-          <p:cNvSpPr/>
-          <p:nvPr/>
-        </p:nvSpPr>
-        <p:spPr>
-          <a:xfrm>
-            <a:off x="548640" y="5120640"/>
-            <a:ext cx="10515600" cy="914400"/>
-          </a:xfrm>
-          <a:prstGeom prst="rect">
-            <a:avLst/>
-          </a:prstGeom>
-          <a:solidFill>
-            <a:srgbClr val="F1F1EC"/>
-          </a:solidFill>
-          <a:ln w="12700">
-            <a:solidFill>
-              <a:srgbClr val="3D444C"/>
-            </a:solidFill>
-          </a:ln>
-          <a:effectLst/>
-        </p:spPr>
-        <p:style>
-          <a:lnRef idx="1">
-            <a:schemeClr val="accent1"/>
-          </a:lnRef>
-          <a:fillRef idx="3">
-            <a:schemeClr val="accent1"/>
-          </a:fillRef>
-          <a:effectRef idx="2">
-            <a:schemeClr val="accent1"/>
-          </a:effectRef>
-          <a:fontRef idx="minor">
-            <a:schemeClr val="lt1"/>
-          </a:fontRef>
-        </p:style>
-        <p:txBody>
-          <a:bodyPr wrap="square" lIns="182880" rIns="182880" rtlCol="0" anchor="ctr"/>
-          <a:lstStyle/>
-          <a:p>
-            <a:pPr algn="ctr"/>
-            <a:r>
-              <a:rPr sz="1700" b="0" i="0">
-                <a:solidFill>
-                  <a:srgbClr val="3D444C"/>
-                </a:solidFill>
-                <a:latin typeface="Avenir Next"/>
-              </a:rPr>
-              <a:t>A layer's output is the next layer's input — stack it and you have depth.</a:t>
-            </a:r>
-          </a:p>
-        </p:txBody>
-      </p:sp>
-      <p:pic>
-        <p:nvPicPr>
-          <p:cNvPr id="7" name="Picture 6">
-            <a:extLst>
-              <a:ext uri="{FF2B5EF4-FFF2-40B4-BE49-F238E27FC236}">
-                <a16:creationId xmlns:a16="http://schemas.microsoft.com/office/drawing/2014/main" id="{55440B74-926C-470A-217F-401D3736D9FB}"/>
-              </a:ext>
-            </a:extLst>
-          </p:cNvPr>
-          <p:cNvPicPr>
-            <a:picLocks noChangeAspect="1"/>
-          </p:cNvPicPr>
-          <p:nvPr/>
-        </p:nvPicPr>
-        <p:blipFill>
-          <a:blip r:embed="rId4"/>
-          <a:stretch>
-            <a:fillRect/>
-          </a:stretch>
-        </p:blipFill>
-        <p:spPr>
-          <a:xfrm>
-            <a:off x="193031" y="1914144"/>
-            <a:ext cx="2566703" cy="1309950"/>
-          </a:xfrm>
-          <a:prstGeom prst="rect">
-            <a:avLst/>
-          </a:prstGeom>
-          <a:ln>
-            <a:solidFill>
-              <a:schemeClr val="tx1"/>
-            </a:solidFill>
-          </a:ln>
-        </p:spPr>
-      </p:pic>
-      <p:cxnSp>
-        <p:nvCxnSpPr>
-          <p:cNvPr id="9" name="Straight Arrow Connector 8">
-            <a:extLst>
-              <a:ext uri="{FF2B5EF4-FFF2-40B4-BE49-F238E27FC236}">
-                <a16:creationId xmlns:a16="http://schemas.microsoft.com/office/drawing/2014/main" id="{A133478A-F178-AEAA-2ABD-A97DDF9BBB63}"/>
-              </a:ext>
-            </a:extLst>
-          </p:cNvPr>
-          <p:cNvCxnSpPr>
-            <a:cxnSpLocks/>
-          </p:cNvCxnSpPr>
-          <p:nvPr/>
-        </p:nvCxnSpPr>
-        <p:spPr>
-          <a:xfrm>
-            <a:off x="2582562" y="2384854"/>
-            <a:ext cx="1062681" cy="370703"/>
-          </a:xfrm>
-          <a:prstGeom prst="straightConnector1">
-            <a:avLst/>
-          </a:prstGeom>
-          <a:ln>
-            <a:tailEnd type="triangle"/>
-          </a:ln>
-        </p:spPr>
-        <p:style>
-          <a:lnRef idx="2">
-            <a:schemeClr val="accent1"/>
-          </a:lnRef>
-          <a:fillRef idx="0">
-            <a:schemeClr val="accent1"/>
-          </a:fillRef>
-          <a:effectRef idx="1">
-            <a:schemeClr val="accent1"/>
-          </a:effectRef>
-          <a:fontRef idx="minor">
-            <a:schemeClr val="tx1"/>
-          </a:fontRef>
-        </p:style>
-      </p:cxnSp>
-      <p:cxnSp>
-        <p:nvCxnSpPr>
-          <p:cNvPr id="10" name="Straight Arrow Connector 9">
-            <a:extLst>
-              <a:ext uri="{FF2B5EF4-FFF2-40B4-BE49-F238E27FC236}">
-                <a16:creationId xmlns:a16="http://schemas.microsoft.com/office/drawing/2014/main" id="{B4E46198-F4D5-2873-2D20-5EB142DD6950}"/>
-              </a:ext>
-            </a:extLst>
-          </p:cNvPr>
-          <p:cNvCxnSpPr>
-            <a:cxnSpLocks/>
-          </p:cNvCxnSpPr>
-          <p:nvPr/>
-        </p:nvCxnSpPr>
-        <p:spPr>
-          <a:xfrm>
-            <a:off x="2582562" y="2755557"/>
-            <a:ext cx="1062681" cy="1287985"/>
-          </a:xfrm>
-          <a:prstGeom prst="straightConnector1">
-            <a:avLst/>
-          </a:prstGeom>
-          <a:ln>
-            <a:tailEnd type="triangle"/>
-          </a:ln>
-        </p:spPr>
-        <p:style>
-          <a:lnRef idx="2">
-            <a:schemeClr val="accent1"/>
-          </a:lnRef>
-          <a:fillRef idx="0">
-            <a:schemeClr val="accent1"/>
-          </a:fillRef>
-          <a:effectRef idx="1">
-            <a:schemeClr val="accent1"/>
-          </a:effectRef>
-          <a:fontRef idx="minor">
-            <a:schemeClr val="tx1"/>
-          </a:fontRef>
-        </p:style>
-      </p:cxnSp>
-    </p:spTree>
-  </p:cSld>
-  <p:clrMapOvr>
-    <a:masterClrMapping/>
-  </p:clrMapOvr>
 </p:sld>
 </file>
 
@@ -6899,7 +7044,7 @@
                 </a:solidFill>
                 <a:latin typeface="Menlo"/>
               </a:rPr>
-              <a:t>STACKING · YOUR TURN, TWO LAYERS (YOU-DO)</a:t>
+              <a:t>STACKING · ONE LAYER FEEDS THE NEXT (I-DO)</a:t>
             </a:r>
           </a:p>
         </p:txBody>
@@ -6913,7 +7058,7 @@
         <p:spPr>
           <a:xfrm>
             <a:off x="548640" y="731520"/>
-            <a:ext cx="11064240" cy="1005840"/>
+            <a:ext cx="11064240" cy="1127760"/>
           </a:xfrm>
           <a:prstGeom prst="rect">
             <a:avLst/>
@@ -6933,14 +7078,14 @@
                 </a:solidFill>
                 <a:latin typeface="Avenir Next"/>
               </a:rPr>
-              <a:t>Your two-layer pass — compute it</a:t>
+              <a:t>Deep = repeat the move, feeding each layer the last</a:t>
             </a:r>
           </a:p>
         </p:txBody>
       </p:sp>
       <p:pic>
         <p:nvPicPr>
-          <p:cNvPr id="5" name="Picture 4" descr="fig_twolayer_youdo.png"/>
+          <p:cNvPr id="5" name="Picture 4" descr="fig_twolayer_ido.png"/>
           <p:cNvPicPr>
             <a:picLocks noChangeAspect="1"/>
           </p:cNvPicPr>
@@ -6981,7 +7126,7 @@
           </a:solidFill>
           <a:ln w="12700">
             <a:solidFill>
-              <a:srgbClr val="E09E2F"/>
+              <a:srgbClr val="3D444C"/>
             </a:solidFill>
           </a:ln>
           <a:effectLst/>
@@ -7006,26 +7151,134 @@
           <a:p>
             <a:pPr algn="ctr"/>
             <a:r>
-              <a:rPr sz="1200" b="1" i="0">
-                <a:solidFill>
-                  <a:srgbClr val="E09E2F"/>
-                </a:solidFill>
-                <a:latin typeface="Menlo"/>
-              </a:rPr>
-              <a:t>CHECKPOINT · </a:t>
-            </a:r>
-            <a:r>
               <a:rPr sz="1700" b="0" i="0">
                 <a:solidFill>
                   <a:srgbClr val="3D444C"/>
                 </a:solidFill>
                 <a:latin typeface="Avenir Next"/>
               </a:rPr>
-              <a:t>Your turn → Quiz 1, Q6. Run layer 1 (W₁x + b₁, then ReLU) for the hidden vector, then layer 2 for y. Worked answer in the notes.</a:t>
-            </a:r>
-          </a:p>
-        </p:txBody>
-      </p:sp>
+              <a:t>A layer's output is the next layer's input — stack it and you have depth.</a:t>
+            </a:r>
+          </a:p>
+        </p:txBody>
+      </p:sp>
+      <p:pic>
+        <p:nvPicPr>
+          <p:cNvPr id="7" name="Picture 6">
+            <a:extLst>
+              <a:ext uri="{FF2B5EF4-FFF2-40B4-BE49-F238E27FC236}">
+                <a16:creationId xmlns:a16="http://schemas.microsoft.com/office/drawing/2014/main" id="{55440B74-926C-470A-217F-401D3736D9FB}"/>
+              </a:ext>
+            </a:extLst>
+          </p:cNvPr>
+          <p:cNvPicPr>
+            <a:picLocks noChangeAspect="1"/>
+          </p:cNvPicPr>
+          <p:nvPr/>
+        </p:nvPicPr>
+        <p:blipFill>
+          <a:blip r:embed="rId4"/>
+          <a:stretch>
+            <a:fillRect/>
+          </a:stretch>
+        </p:blipFill>
+        <p:spPr>
+          <a:xfrm>
+            <a:off x="193031" y="1914144"/>
+            <a:ext cx="2566703" cy="1309950"/>
+          </a:xfrm>
+          <a:prstGeom prst="rect">
+            <a:avLst/>
+          </a:prstGeom>
+          <a:ln>
+            <a:solidFill>
+              <a:schemeClr val="tx1"/>
+            </a:solidFill>
+          </a:ln>
+        </p:spPr>
+      </p:pic>
+      <p:cxnSp>
+        <p:nvCxnSpPr>
+          <p:cNvPr id="9" name="Straight Arrow Connector 8">
+            <a:extLst>
+              <a:ext uri="{FF2B5EF4-FFF2-40B4-BE49-F238E27FC236}">
+                <a16:creationId xmlns:a16="http://schemas.microsoft.com/office/drawing/2014/main" id="{A133478A-F178-AEAA-2ABD-A97DDF9BBB63}"/>
+              </a:ext>
+            </a:extLst>
+          </p:cNvPr>
+          <p:cNvCxnSpPr>
+            <a:cxnSpLocks/>
+          </p:cNvCxnSpPr>
+          <p:nvPr/>
+        </p:nvCxnSpPr>
+        <p:spPr>
+          <a:xfrm>
+            <a:off x="2582562" y="2384854"/>
+            <a:ext cx="1062681" cy="370703"/>
+          </a:xfrm>
+          <a:prstGeom prst="straightConnector1">
+            <a:avLst/>
+          </a:prstGeom>
+          <a:ln>
+            <a:tailEnd type="triangle"/>
+          </a:ln>
+        </p:spPr>
+        <p:style>
+          <a:lnRef idx="2">
+            <a:schemeClr val="accent1"/>
+          </a:lnRef>
+          <a:fillRef idx="0">
+            <a:schemeClr val="accent1"/>
+          </a:fillRef>
+          <a:effectRef idx="1">
+            <a:schemeClr val="accent1"/>
+          </a:effectRef>
+          <a:fontRef idx="minor">
+            <a:schemeClr val="tx1"/>
+          </a:fontRef>
+        </p:style>
+      </p:cxnSp>
+      <p:cxnSp>
+        <p:nvCxnSpPr>
+          <p:cNvPr id="10" name="Straight Arrow Connector 9">
+            <a:extLst>
+              <a:ext uri="{FF2B5EF4-FFF2-40B4-BE49-F238E27FC236}">
+                <a16:creationId xmlns:a16="http://schemas.microsoft.com/office/drawing/2014/main" id="{B4E46198-F4D5-2873-2D20-5EB142DD6950}"/>
+              </a:ext>
+            </a:extLst>
+          </p:cNvPr>
+          <p:cNvCxnSpPr>
+            <a:cxnSpLocks/>
+          </p:cNvCxnSpPr>
+          <p:nvPr/>
+        </p:nvCxnSpPr>
+        <p:spPr>
+          <a:xfrm>
+            <a:off x="2582562" y="2755557"/>
+            <a:ext cx="1062681" cy="1287985"/>
+          </a:xfrm>
+          <a:prstGeom prst="straightConnector1">
+            <a:avLst/>
+          </a:prstGeom>
+          <a:ln>
+            <a:tailEnd type="triangle"/>
+          </a:ln>
+        </p:spPr>
+        <p:style>
+          <a:lnRef idx="2">
+            <a:schemeClr val="accent1"/>
+          </a:lnRef>
+          <a:fillRef idx="0">
+            <a:schemeClr val="accent1"/>
+          </a:fillRef>
+          <a:effectRef idx="1">
+            <a:schemeClr val="accent1"/>
+          </a:effectRef>
+          <a:fontRef idx="minor">
+            <a:schemeClr val="tx1"/>
+          </a:fontRef>
+        </p:style>
+      </p:cxnSp>
     </p:spTree>
   </p:cSld>
   <p:clrMapOvr>
@@ -7125,7 +7378,7 @@
                 </a:solidFill>
                 <a:latin typeface="Menlo"/>
               </a:rPr>
-              <a:t>STACKING · WHY GO DEEP</a:t>
+              <a:t>STACKING · YOUR TURN, TWO LAYERS (YOU-DO)</a:t>
             </a:r>
           </a:p>
         </p:txBody>
@@ -7159,14 +7412,14 @@
                 </a:solidFill>
                 <a:latin typeface="Avenir Next"/>
               </a:rPr>
-              <a:t>Depth = a hierarchy of features</a:t>
+              <a:t>Your two-layer pass — compute it</a:t>
             </a:r>
           </a:p>
         </p:txBody>
       </p:sp>
       <p:pic>
         <p:nvPicPr>
-          <p:cNvPr id="5" name="Picture 4" descr="cat_hierarchy.png"/>
+          <p:cNvPr id="5" name="Picture 4" descr="fig_twolayer_youdo.png"/>
           <p:cNvPicPr>
             <a:picLocks noChangeAspect="1"/>
           </p:cNvPicPr>
@@ -7180,8 +7433,8 @@
         </p:blipFill>
         <p:spPr>
           <a:xfrm>
-            <a:off x="986790" y="1828800"/>
-            <a:ext cx="10187940" cy="3200400"/>
+            <a:off x="2814598" y="1828800"/>
+            <a:ext cx="6532323" cy="3200400"/>
           </a:xfrm>
           <a:prstGeom prst="rect">
             <a:avLst/>
@@ -7190,48 +7443,13 @@
       </p:pic>
       <p:sp>
         <p:nvSpPr>
-          <p:cNvPr id="6" name="TextBox 5"/>
-          <p:cNvSpPr txBox="1"/>
-          <p:nvPr/>
-        </p:nvSpPr>
-        <p:spPr>
-          <a:xfrm>
-            <a:off x="548640" y="5084064"/>
-            <a:ext cx="11064240" cy="411480"/>
-          </a:xfrm>
-          <a:prstGeom prst="rect">
-            <a:avLst/>
-          </a:prstGeom>
-          <a:noFill/>
-        </p:spPr>
-        <p:txBody>
-          <a:bodyPr wrap="square" anchor="t">
-            <a:spAutoFit/>
-          </a:bodyPr>
-          <a:lstStyle/>
-          <a:p>
-            <a:pPr algn="ctr"/>
-            <a:r>
-              <a:rPr sz="1200" b="0" i="1">
-                <a:solidFill>
-                  <a:srgbClr val="8A9099"/>
-                </a:solidFill>
-                <a:latin typeface="Avenir Next"/>
-              </a:rPr>
-              <a:t>one photo, abstracted further at each layer · cat: Alvesgaspar, Wikimedia Commons, CC BY-SA 3.0</a:t>
-            </a:r>
-          </a:p>
-        </p:txBody>
-      </p:sp>
-      <p:sp>
-        <p:nvSpPr>
-          <p:cNvPr id="7" name="Rectangle 6"/>
+          <p:cNvPr id="6" name="Rectangle 5"/>
           <p:cNvSpPr/>
           <p:nvPr/>
         </p:nvSpPr>
         <p:spPr>
           <a:xfrm>
-            <a:off x="548640" y="5586984"/>
+            <a:off x="548640" y="5120640"/>
             <a:ext cx="10515600" cy="914400"/>
           </a:xfrm>
           <a:prstGeom prst="rect">
@@ -7242,7 +7460,7 @@
           </a:solidFill>
           <a:ln w="12700">
             <a:solidFill>
-              <a:srgbClr val="3D444C"/>
+              <a:srgbClr val="E09E2F"/>
             </a:solidFill>
           </a:ln>
           <a:effectLst/>
@@ -7267,13 +7485,22 @@
           <a:p>
             <a:pPr algn="ctr"/>
             <a:r>
-              <a:rPr sz="1700" b="0" i="0" dirty="0">
+              <a:rPr sz="1200" b="1" i="0">
+                <a:solidFill>
+                  <a:srgbClr val="E09E2F"/>
+                </a:solidFill>
+                <a:latin typeface="Menlo"/>
+              </a:rPr>
+              <a:t>CHECKPOINT · </a:t>
+            </a:r>
+            <a:r>
+              <a:rPr sz="1700" b="0" i="0">
                 <a:solidFill>
                   <a:srgbClr val="3D444C"/>
                 </a:solidFill>
                 <a:latin typeface="Avenir Next"/>
               </a:rPr>
-              <a:t>No one told it to look at edges first — it LEARNED that edges build into parts, and parts into whole objects. That is why 'deep.'</a:t>
+              <a:t>Your turn → Quiz 1, Q6. Run layer 1 (W₁x + b₁, then ReLU) for the hidden vector, then layer 2 for y. Worked answer in the notes.</a:t>
             </a:r>
           </a:p>
         </p:txBody>
@@ -7377,6 +7604,258 @@
                 </a:solidFill>
                 <a:latin typeface="Menlo"/>
               </a:rPr>
+              <a:t>STACKING · WHY GO DEEP</a:t>
+            </a:r>
+          </a:p>
+        </p:txBody>
+      </p:sp>
+      <p:sp>
+        <p:nvSpPr>
+          <p:cNvPr id="4" name="TextBox 3"/>
+          <p:cNvSpPr txBox="1"/>
+          <p:nvPr/>
+        </p:nvSpPr>
+        <p:spPr>
+          <a:xfrm>
+            <a:off x="548640" y="731520"/>
+            <a:ext cx="11064240" cy="1005840"/>
+          </a:xfrm>
+          <a:prstGeom prst="rect">
+            <a:avLst/>
+          </a:prstGeom>
+          <a:noFill/>
+        </p:spPr>
+        <p:txBody>
+          <a:bodyPr wrap="square" anchor="t">
+            <a:spAutoFit/>
+          </a:bodyPr>
+          <a:lstStyle/>
+          <a:p>
+            <a:r>
+              <a:rPr sz="3400" b="1" i="0">
+                <a:solidFill>
+                  <a:srgbClr val="1B2025"/>
+                </a:solidFill>
+                <a:latin typeface="Avenir Next"/>
+              </a:rPr>
+              <a:t>Depth = a hierarchy of features</a:t>
+            </a:r>
+          </a:p>
+        </p:txBody>
+      </p:sp>
+      <p:pic>
+        <p:nvPicPr>
+          <p:cNvPr id="5" name="Picture 4" descr="cat_hierarchy.png"/>
+          <p:cNvPicPr>
+            <a:picLocks noChangeAspect="1"/>
+          </p:cNvPicPr>
+          <p:nvPr/>
+        </p:nvPicPr>
+        <p:blipFill>
+          <a:blip r:embed="rId3"/>
+          <a:stretch>
+            <a:fillRect/>
+          </a:stretch>
+        </p:blipFill>
+        <p:spPr>
+          <a:xfrm>
+            <a:off x="986790" y="1828800"/>
+            <a:ext cx="10187940" cy="3200400"/>
+          </a:xfrm>
+          <a:prstGeom prst="rect">
+            <a:avLst/>
+          </a:prstGeom>
+        </p:spPr>
+      </p:pic>
+      <p:sp>
+        <p:nvSpPr>
+          <p:cNvPr id="6" name="TextBox 5"/>
+          <p:cNvSpPr txBox="1"/>
+          <p:nvPr/>
+        </p:nvSpPr>
+        <p:spPr>
+          <a:xfrm>
+            <a:off x="548640" y="5084064"/>
+            <a:ext cx="11064240" cy="411480"/>
+          </a:xfrm>
+          <a:prstGeom prst="rect">
+            <a:avLst/>
+          </a:prstGeom>
+          <a:noFill/>
+        </p:spPr>
+        <p:txBody>
+          <a:bodyPr wrap="square" anchor="t">
+            <a:spAutoFit/>
+          </a:bodyPr>
+          <a:lstStyle/>
+          <a:p>
+            <a:pPr algn="ctr"/>
+            <a:r>
+              <a:rPr sz="1200" b="0" i="1">
+                <a:solidFill>
+                  <a:srgbClr val="8A9099"/>
+                </a:solidFill>
+                <a:latin typeface="Avenir Next"/>
+              </a:rPr>
+              <a:t>one photo, abstracted further at each layer · cat: Alvesgaspar, Wikimedia Commons, CC BY-SA 3.0</a:t>
+            </a:r>
+          </a:p>
+        </p:txBody>
+      </p:sp>
+      <p:sp>
+        <p:nvSpPr>
+          <p:cNvPr id="7" name="Rectangle 6"/>
+          <p:cNvSpPr/>
+          <p:nvPr/>
+        </p:nvSpPr>
+        <p:spPr>
+          <a:xfrm>
+            <a:off x="548640" y="5586984"/>
+            <a:ext cx="10515600" cy="914400"/>
+          </a:xfrm>
+          <a:prstGeom prst="rect">
+            <a:avLst/>
+          </a:prstGeom>
+          <a:solidFill>
+            <a:srgbClr val="F1F1EC"/>
+          </a:solidFill>
+          <a:ln w="12700">
+            <a:solidFill>
+              <a:srgbClr val="3D444C"/>
+            </a:solidFill>
+          </a:ln>
+          <a:effectLst/>
+        </p:spPr>
+        <p:style>
+          <a:lnRef idx="1">
+            <a:schemeClr val="accent1"/>
+          </a:lnRef>
+          <a:fillRef idx="3">
+            <a:schemeClr val="accent1"/>
+          </a:fillRef>
+          <a:effectRef idx="2">
+            <a:schemeClr val="accent1"/>
+          </a:effectRef>
+          <a:fontRef idx="minor">
+            <a:schemeClr val="lt1"/>
+          </a:fontRef>
+        </p:style>
+        <p:txBody>
+          <a:bodyPr wrap="square" lIns="182880" rIns="182880" rtlCol="0" anchor="ctr"/>
+          <a:lstStyle/>
+          <a:p>
+            <a:pPr algn="ctr"/>
+            <a:r>
+              <a:rPr sz="1700" b="0" i="0" dirty="0">
+                <a:solidFill>
+                  <a:srgbClr val="3D444C"/>
+                </a:solidFill>
+                <a:latin typeface="Avenir Next"/>
+              </a:rPr>
+              <a:t>No one told it to look at edges first — it LEARNED that edges build into parts, and parts into whole objects. That is why 'deep.'</a:t>
+            </a:r>
+          </a:p>
+        </p:txBody>
+      </p:sp>
+    </p:spTree>
+  </p:cSld>
+  <p:clrMapOvr>
+    <a:masterClrMapping/>
+  </p:clrMapOvr>
+</p:sld>
+</file>
+
+<file path=ppt/slides/slide23.xml><?xml version="1.0" encoding="utf-8"?>
+<p:sld xmlns:a="http://schemas.openxmlformats.org/drawingml/2006/main" xmlns:r="http://schemas.openxmlformats.org/officeDocument/2006/relationships" xmlns:p="http://schemas.openxmlformats.org/presentationml/2006/main">
+  <p:cSld>
+    <p:spTree>
+      <p:nvGrpSpPr>
+        <p:cNvPr id="1" name=""/>
+        <p:cNvGrpSpPr/>
+        <p:nvPr/>
+      </p:nvGrpSpPr>
+      <p:grpSpPr>
+        <a:xfrm>
+          <a:off x="0" y="0"/>
+          <a:ext cx="0" cy="0"/>
+          <a:chOff x="0" y="0"/>
+          <a:chExt cx="0" cy="0"/>
+        </a:xfrm>
+      </p:grpSpPr>
+      <p:sp>
+        <p:nvSpPr>
+          <p:cNvPr id="2" name="Rectangle 1"/>
+          <p:cNvSpPr/>
+          <p:nvPr/>
+        </p:nvSpPr>
+        <p:spPr>
+          <a:xfrm>
+            <a:off x="0" y="0"/>
+            <a:ext cx="12191695" cy="6858000"/>
+          </a:xfrm>
+          <a:prstGeom prst="rect">
+            <a:avLst/>
+          </a:prstGeom>
+          <a:solidFill>
+            <a:srgbClr val="FBFBF8"/>
+          </a:solidFill>
+          <a:ln>
+            <a:noFill/>
+          </a:ln>
+          <a:effectLst/>
+        </p:spPr>
+        <p:style>
+          <a:lnRef idx="1">
+            <a:schemeClr val="accent1"/>
+          </a:lnRef>
+          <a:fillRef idx="3">
+            <a:schemeClr val="accent1"/>
+          </a:fillRef>
+          <a:effectRef idx="2">
+            <a:schemeClr val="accent1"/>
+          </a:effectRef>
+          <a:fontRef idx="minor">
+            <a:schemeClr val="lt1"/>
+          </a:fontRef>
+        </p:style>
+        <p:txBody>
+          <a:bodyPr rtlCol="0" anchor="ctr"/>
+          <a:lstStyle/>
+          <a:p>
+            <a:pPr algn="ctr"/>
+            <a:endParaRPr/>
+          </a:p>
+        </p:txBody>
+      </p:sp>
+      <p:sp>
+        <p:nvSpPr>
+          <p:cNvPr id="3" name="TextBox 2"/>
+          <p:cNvSpPr txBox="1"/>
+          <p:nvPr/>
+        </p:nvSpPr>
+        <p:spPr>
+          <a:xfrm>
+            <a:off x="548640" y="320040"/>
+            <a:ext cx="10972800" cy="365760"/>
+          </a:xfrm>
+          <a:prstGeom prst="rect">
+            <a:avLst/>
+          </a:prstGeom>
+          <a:noFill/>
+        </p:spPr>
+        <p:txBody>
+          <a:bodyPr wrap="square" anchor="t">
+            <a:spAutoFit/>
+          </a:bodyPr>
+          <a:lstStyle/>
+          <a:p>
+            <a:r>
+              <a:rPr sz="1300" b="1" i="0">
+                <a:solidFill>
+                  <a:srgbClr val="8A9099"/>
+                </a:solidFill>
+                <a:latin typeface="Menlo"/>
+              </a:rPr>
               <a:t>LECTURE 1 · DISCUSSION (PAIR)</a:t>
             </a:r>
           </a:p>
@@ -7671,485 +8150,6 @@
                 <a:latin typeface="Avenir Next"/>
               </a:rPr>
               <a:t>Pair → Quiz 1, Q5, in one sentence: how does deep learning differ from the classic ML you use today? Then say which of YOUR lab signals a network could learn. 2 minutes.</a:t>
-            </a:r>
-          </a:p>
-        </p:txBody>
-      </p:sp>
-    </p:spTree>
-  </p:cSld>
-  <p:clrMapOvr>
-    <a:masterClrMapping/>
-  </p:clrMapOvr>
-</p:sld>
-</file>
-
-<file path=ppt/slides/slide23.xml><?xml version="1.0" encoding="utf-8"?>
-<p:sld xmlns:a="http://schemas.openxmlformats.org/drawingml/2006/main" xmlns:p="http://schemas.openxmlformats.org/presentationml/2006/main" xmlns:r="http://schemas.openxmlformats.org/officeDocument/2006/relationships">
-  <p:cSld>
-    <p:spTree>
-      <p:nvGrpSpPr>
-        <p:cNvPr id="1" name=""/>
-        <p:cNvGrpSpPr/>
-        <p:nvPr/>
-      </p:nvGrpSpPr>
-      <p:grpSpPr/>
-      <p:sp>
-        <p:nvSpPr>
-          <p:cNvPr id="2" name="Rectangle 1"/>
-          <p:cNvSpPr/>
-          <p:nvPr/>
-        </p:nvSpPr>
-        <p:spPr>
-          <a:xfrm>
-            <a:off x="0" y="0"/>
-            <a:ext cx="12191695" cy="6858000"/>
-          </a:xfrm>
-          <a:prstGeom prst="rect">
-            <a:avLst/>
-          </a:prstGeom>
-          <a:solidFill>
-            <a:srgbClr val="FBFBF8"/>
-          </a:solidFill>
-          <a:ln>
-            <a:noFill/>
-          </a:ln>
-          <a:effectLst/>
-        </p:spPr>
-        <p:style>
-          <a:lnRef idx="1">
-            <a:schemeClr val="accent1"/>
-          </a:lnRef>
-          <a:fillRef idx="3">
-            <a:schemeClr val="accent1"/>
-          </a:fillRef>
-          <a:effectRef idx="2">
-            <a:schemeClr val="accent1"/>
-          </a:effectRef>
-          <a:fontRef idx="minor">
-            <a:schemeClr val="lt1"/>
-          </a:fontRef>
-        </p:style>
-        <p:txBody>
-          <a:bodyPr rtlCol="0" anchor="ctr"/>
-          <a:lstStyle/>
-          <a:p>
-            <a:pPr algn="ctr"/>
-            <a:endParaRPr/>
-          </a:p>
-        </p:txBody>
-      </p:sp>
-      <p:sp>
-        <p:nvSpPr>
-          <p:cNvPr id="3" name="TextBox 2"/>
-          <p:cNvSpPr txBox="1"/>
-          <p:nvPr/>
-        </p:nvSpPr>
-        <p:spPr>
-          <a:xfrm>
-            <a:off x="548640" y="320040"/>
-            <a:ext cx="10972800" cy="365760"/>
-          </a:xfrm>
-          <a:prstGeom prst="rect">
-            <a:avLst/>
-          </a:prstGeom>
-          <a:noFill/>
-        </p:spPr>
-        <p:txBody>
-          <a:bodyPr wrap="square" anchor="t">
-            <a:spAutoFit/>
-          </a:bodyPr>
-          <a:lstStyle/>
-          <a:p>
-            <a:r>
-              <a:rPr sz="1300" b="1" i="0">
-                <a:solidFill>
-                  <a:srgbClr val="8A9099"/>
-                </a:solidFill>
-                <a:latin typeface="Menlo"/>
-              </a:rPr>
-              <a:t>ENGINEERED VS. LEARNED · YOUR TURN (YOU-DO = Q4)</a:t>
-            </a:r>
-          </a:p>
-        </p:txBody>
-      </p:sp>
-      <p:sp>
-        <p:nvSpPr>
-          <p:cNvPr id="4" name="TextBox 3"/>
-          <p:cNvSpPr txBox="1"/>
-          <p:nvPr/>
-        </p:nvSpPr>
-        <p:spPr>
-          <a:xfrm>
-            <a:off x="548640" y="731520"/>
-            <a:ext cx="11064240" cy="1005840"/>
-          </a:xfrm>
-          <a:prstGeom prst="rect">
-            <a:avLst/>
-          </a:prstGeom>
-          <a:noFill/>
-        </p:spPr>
-        <p:txBody>
-          <a:bodyPr wrap="square" anchor="t">
-            <a:spAutoFit/>
-          </a:bodyPr>
-          <a:lstStyle/>
-          <a:p>
-            <a:r>
-              <a:rPr sz="3400" b="1" i="0">
-                <a:solidFill>
-                  <a:srgbClr val="1B2025"/>
-                </a:solidFill>
-                <a:latin typeface="Avenir Next"/>
-              </a:rPr>
-              <a:t>Your turn — engineered or learned?</a:t>
-            </a:r>
-          </a:p>
-        </p:txBody>
-      </p:sp>
-      <p:sp>
-        <p:nvSpPr>
-          <p:cNvPr id="6" name="Rectangle 5"/>
-          <p:cNvSpPr/>
-          <p:nvPr/>
-        </p:nvSpPr>
-        <p:spPr>
-          <a:xfrm>
-            <a:off x="548640" y="5120640"/>
-            <a:ext cx="10515600" cy="923544"/>
-          </a:xfrm>
-          <a:prstGeom prst="rect">
-            <a:avLst/>
-          </a:prstGeom>
-          <a:solidFill>
-            <a:srgbClr val="F1F1EC"/>
-          </a:solidFill>
-          <a:ln w="12700">
-            <a:solidFill>
-              <a:srgbClr val="E09E2F"/>
-            </a:solidFill>
-          </a:ln>
-          <a:effectLst/>
-        </p:spPr>
-        <p:style>
-          <a:lnRef idx="1">
-            <a:schemeClr val="accent1"/>
-          </a:lnRef>
-          <a:fillRef idx="3">
-            <a:schemeClr val="accent1"/>
-          </a:fillRef>
-          <a:effectRef idx="2">
-            <a:schemeClr val="accent1"/>
-          </a:effectRef>
-          <a:fontRef idx="minor">
-            <a:schemeClr val="lt1"/>
-          </a:fontRef>
-        </p:style>
-        <p:txBody>
-          <a:bodyPr wrap="square" lIns="182880" rIns="182880" rtlCol="0" anchor="ctr"/>
-          <a:lstStyle/>
-          <a:p>
-            <a:pPr algn="ctr"/>
-            <a:r>
-              <a:rPr sz="1200" b="1" i="0" dirty="0">
-                <a:solidFill>
-                  <a:srgbClr val="E09E2F"/>
-                </a:solidFill>
-                <a:latin typeface="Menlo"/>
-              </a:rPr>
-              <a:t>CHECKPOINT · </a:t>
-            </a:r>
-            <a:r>
-              <a:rPr sz="1700" b="0" i="0" dirty="0">
-                <a:solidFill>
-                  <a:srgbClr val="3D444C"/>
-                </a:solidFill>
-                <a:latin typeface="Avenir Next"/>
-              </a:rPr>
-              <a:t>Your turn → Quiz 1, Q4. Two ways to call resistant vs. susceptible from the same MALDI-TOF spectrum. Which pipeline uses HAND-ENGINEERED features, and which uses LEARNED features? 1 minute — answer in the notes.</a:t>
-            </a:r>
-          </a:p>
-        </p:txBody>
-      </p:sp>
-      <p:sp>
-        <p:nvSpPr>
-          <p:cNvPr id="7" name="Rounded Rectangle 6"/>
-          <p:cNvSpPr/>
-          <p:nvPr/>
-        </p:nvSpPr>
-        <p:spPr>
-          <a:xfrm>
-            <a:off x="548640" y="1888800"/>
-            <a:ext cx="5143500" cy="1500000"/>
-          </a:xfrm>
-          <a:prstGeom prst="roundRect">
-            <a:avLst>
-              <a:gd name="adj" fmla="val 8000"/>
-            </a:avLst>
-          </a:prstGeom>
-          <a:solidFill>
-            <a:srgbClr val="FFFFFF"/>
-          </a:solidFill>
-          <a:ln w="12700">
-            <a:solidFill>
-              <a:srgbClr val="D9D9D2"/>
-            </a:solidFill>
-          </a:ln>
-          <a:effectLst/>
-        </p:spPr>
-        <p:style>
-          <a:lnRef idx="1">
-            <a:schemeClr val="accent1"/>
-          </a:lnRef>
-          <a:fillRef idx="3">
-            <a:schemeClr val="accent1"/>
-          </a:fillRef>
-          <a:effectRef idx="2">
-            <a:schemeClr val="accent1"/>
-          </a:effectRef>
-          <a:fontRef idx="minor">
-            <a:schemeClr val="lt1"/>
-          </a:fontRef>
-        </p:style>
-        <p:txBody>
-          <a:bodyPr rtlCol="0" anchor="ctr"/>
-          <a:lstStyle/>
-          <a:p/>
-        </p:txBody>
-      </p:sp>
-      <p:sp>
-        <p:nvSpPr>
-          <p:cNvPr id="8" name="TextBox 7"/>
-          <p:cNvSpPr txBox="1"/>
-          <p:nvPr/>
-        </p:nvSpPr>
-        <p:spPr>
-          <a:xfrm>
-            <a:off x="640080" y="1948800"/>
-            <a:ext cx="4960620" cy="1380000"/>
-          </a:xfrm>
-          <a:prstGeom prst="rect">
-            <a:avLst/>
-          </a:prstGeom>
-          <a:noFill/>
-        </p:spPr>
-        <p:txBody>
-          <a:bodyPr wrap="square" lIns="45720" rIns="45720" tIns="27432" bIns="27432" anchor="t">
-            <a:spAutoFit/>
-          </a:bodyPr>
-          <a:lstStyle/>
-          <a:p>
-            <a:pPr algn="l">
-              <a:spcAft>
-                <a:spcPts val="400"/>
-              </a:spcAft>
-            </a:pPr>
-            <a:r>
-              <a:rPr sz="1800" b="1">
-                <a:solidFill>
-                  <a:srgbClr val="0E7C7B"/>
-                </a:solidFill>
-                <a:latin typeface="Avenir Next"/>
-              </a:rPr>
-              <a:t>Pipeline A</a:t>
-            </a:r>
-          </a:p>
-          <a:p>
-            <a:pPr algn="l">
-              <a:spcAft>
-                <a:spcPts val="400"/>
-              </a:spcAft>
-            </a:pPr>
-            <a:r>
-              <a:rPr sz="1600" b="0">
-                <a:solidFill>
-                  <a:srgbClr val="1B2025"/>
-                </a:solidFill>
-                <a:latin typeface="Avenir Next"/>
-              </a:rPr>
-              <a:t>A technician computes the peak area at m/z 2415 and the 2415/4100 ratio, then feeds those two numbers to logistic regression.</a:t>
-            </a:r>
-          </a:p>
-        </p:txBody>
-      </p:sp>
-      <p:sp>
-        <p:nvSpPr>
-          <p:cNvPr id="9" name="Rounded Rectangle 8"/>
-          <p:cNvSpPr/>
-          <p:nvPr/>
-        </p:nvSpPr>
-        <p:spPr>
-          <a:xfrm>
-            <a:off x="5920740" y="1888800"/>
-            <a:ext cx="5143500" cy="1500000"/>
-          </a:xfrm>
-          <a:prstGeom prst="roundRect">
-            <a:avLst>
-              <a:gd name="adj" fmla="val 8000"/>
-            </a:avLst>
-          </a:prstGeom>
-          <a:solidFill>
-            <a:srgbClr val="FFFFFF"/>
-          </a:solidFill>
-          <a:ln w="12700">
-            <a:solidFill>
-              <a:srgbClr val="D9D9D2"/>
-            </a:solidFill>
-          </a:ln>
-          <a:effectLst/>
-        </p:spPr>
-        <p:style>
-          <a:lnRef idx="1">
-            <a:schemeClr val="accent1"/>
-          </a:lnRef>
-          <a:fillRef idx="3">
-            <a:schemeClr val="accent1"/>
-          </a:fillRef>
-          <a:effectRef idx="2">
-            <a:schemeClr val="accent1"/>
-          </a:effectRef>
-          <a:fontRef idx="minor">
-            <a:schemeClr val="lt1"/>
-          </a:fontRef>
-        </p:style>
-        <p:txBody>
-          <a:bodyPr rtlCol="0" anchor="ctr"/>
-          <a:lstStyle/>
-          <a:p/>
-        </p:txBody>
-      </p:sp>
-      <p:sp>
-        <p:nvSpPr>
-          <p:cNvPr id="10" name="TextBox 9"/>
-          <p:cNvSpPr txBox="1"/>
-          <p:nvPr/>
-        </p:nvSpPr>
-        <p:spPr>
-          <a:xfrm>
-            <a:off x="6012180" y="1948800"/>
-            <a:ext cx="4960620" cy="1380000"/>
-          </a:xfrm>
-          <a:prstGeom prst="rect">
-            <a:avLst/>
-          </a:prstGeom>
-          <a:noFill/>
-        </p:spPr>
-        <p:txBody>
-          <a:bodyPr wrap="square" lIns="45720" rIns="45720" tIns="27432" bIns="27432" anchor="t">
-            <a:spAutoFit/>
-          </a:bodyPr>
-          <a:lstStyle/>
-          <a:p>
-            <a:pPr algn="l">
-              <a:spcAft>
-                <a:spcPts val="400"/>
-              </a:spcAft>
-            </a:pPr>
-            <a:r>
-              <a:rPr sz="1800" b="1">
-                <a:solidFill>
-                  <a:srgbClr val="0E7C7B"/>
-                </a:solidFill>
-                <a:latin typeface="Avenir Next"/>
-              </a:rPr>
-              <a:t>Pipeline B</a:t>
-            </a:r>
-          </a:p>
-          <a:p>
-            <a:pPr algn="l">
-              <a:spcAft>
-                <a:spcPts val="400"/>
-              </a:spcAft>
-            </a:pPr>
-            <a:r>
-              <a:rPr sz="1600" b="0">
-                <a:solidFill>
-                  <a:srgbClr val="1B2025"/>
-                </a:solidFill>
-                <a:latin typeface="Avenir Next"/>
-              </a:rPr>
-              <a:t>The raw 6,000-bin spectrum goes straight into a neural network, which forms its own internal “peak-ish here” detector in an early layer.</a:t>
-            </a:r>
-          </a:p>
-        </p:txBody>
-      </p:sp>
-      <p:sp>
-        <p:nvSpPr>
-          <p:cNvPr id="11" name="TextBox 10"/>
-          <p:cNvSpPr txBox="1"/>
-          <p:nvPr/>
-        </p:nvSpPr>
-        <p:spPr>
-          <a:xfrm>
-            <a:off x="548640" y="3568800"/>
-            <a:ext cx="10515600" cy="900000"/>
-          </a:xfrm>
-          <a:prstGeom prst="rect">
-            <a:avLst/>
-          </a:prstGeom>
-          <a:noFill/>
-        </p:spPr>
-        <p:txBody>
-          <a:bodyPr wrap="square" lIns="45720" rIns="45720" tIns="27432" bIns="27432" anchor="t">
-            <a:spAutoFit/>
-          </a:bodyPr>
-          <a:lstStyle/>
-          <a:p>
-            <a:pPr algn="ctr">
-              <a:spcAft>
-                <a:spcPts val="400"/>
-              </a:spcAft>
-            </a:pPr>
-            <a:r>
-              <a:rPr sz="1700" b="0">
-                <a:solidFill>
-                  <a:srgbClr val="1B2025"/>
-                </a:solidFill>
-                <a:latin typeface="Avenir Next"/>
-              </a:rPr>
-              <a:t>Two ways to call resistant vs. susceptible from one MALDI-TOF spectrum.</a:t>
-            </a:r>
-          </a:p>
-          <a:p>
-            <a:pPr algn="ctr">
-              <a:spcAft>
-                <a:spcPts val="400"/>
-              </a:spcAft>
-            </a:pPr>
-            <a:r>
-              <a:rPr sz="1700" b="1">
-                <a:solidFill>
-                  <a:srgbClr val="1B2025"/>
-                </a:solidFill>
-                <a:latin typeface="Avenir Next"/>
-              </a:rPr>
-              <a:t>hand-engineered  →  Pipeline </a:t>
-            </a:r>
-            <a:r>
-              <a:rPr sz="1700" b="1">
-                <a:solidFill>
-                  <a:srgbClr val="0E7C7B"/>
-                </a:solidFill>
-                <a:latin typeface="Avenir Next"/>
-              </a:rPr>
-              <a:t>________</a:t>
-            </a:r>
-            <a:r>
-              <a:rPr sz="1700" b="1">
-                <a:solidFill>
-                  <a:srgbClr val="1B2025"/>
-                </a:solidFill>
-                <a:latin typeface="Avenir Next"/>
-              </a:rPr>
-              <a:t>          learned  →  Pipeline </a:t>
-            </a:r>
-            <a:r>
-              <a:rPr sz="1700" b="1">
-                <a:solidFill>
-                  <a:srgbClr val="0E7C7B"/>
-                </a:solidFill>
-                <a:latin typeface="Avenir Next"/>
-              </a:rPr>
-              <a:t>________</a:t>
             </a:r>
           </a:p>
         </p:txBody>

</xml_diff>